<commit_message>
Improve presentation design: icon motif, larger body text, title slide
Co-Authored-By: Claude Opus 5.5 <noreply@anthropic.com>
Claude-Session: https://claude.ai/code/session_01VZE4XfkebTWLatWpMU9HD1
</commit_message>
<xml_diff>
--- a/report/case-study-presentation.pptx
+++ b/report/case-study-presentation.pptx
@@ -130,7 +130,7 @@
   <p:extLst>
     <p:ext uri="{521415D9-36F7-43E2-AB2F-B90AF26B5E84}">
       <p14:sectionLst xmlns:p14="http://schemas.microsoft.com/office/powerpoint/2010/main">
-        <p14:section name="Introduction" id="{f378315c-7040-efa2-0cd5-bf9a1c0074d5}">
+        <p14:section name="Introduction" id="{b0c82e09-c38a-1e45-06e5-92b9883c9437}">
           <p14:sldIdLst>
             <p14:sldId id="256"/>
             <p14:sldId id="257"/>
@@ -138,13 +138,13 @@
             <p14:sldId id="259"/>
           </p14:sldIdLst>
         </p14:section>
-        <p14:section name="Part A: Literature" id="{728f1198-680d-6423-d339-c79fb580d874}">
+        <p14:section name="Part A: Literature" id="{6f1649f0-50d5-11be-b0df-5c8a4de9ceb1}">
           <p14:sldIdLst>
             <p14:sldId id="260"/>
             <p14:sldId id="261"/>
           </p14:sldIdLst>
         </p14:section>
-        <p14:section name="Part B: Design" id="{a81e3ac1-fe5a-17fa-2819-5bd0a3be1bad}">
+        <p14:section name="Part B: Design" id="{f9624de7-f8f0-a289-2e0c-68f876aa56a8}">
           <p14:sldIdLst>
             <p14:sldId id="262"/>
             <p14:sldId id="263"/>
@@ -153,7 +153,7 @@
             <p14:sldId id="266"/>
           </p14:sldIdLst>
         </p14:section>
-        <p14:section name="Part B: Results" id="{c38934c7-eb82-7822-3eac-510228bd89ed}">
+        <p14:section name="Part B: Results" id="{5d24a261-8143-da12-cfe5-e96b7c9f0eb2}">
           <p14:sldIdLst>
             <p14:sldId id="267"/>
             <p14:sldId id="268"/>
@@ -165,7 +165,7 @@
             <p14:sldId id="274"/>
           </p14:sldIdLst>
         </p14:section>
-        <p14:section name="Part C and conclusion" id="{23bb782b-ab72-bc18-3498-1baa6b805338}">
+        <p14:section name="Part C and conclusion" id="{4a1d32c1-f9a4-525b-e120-3942e9e43d86}">
           <p14:sldIdLst>
             <p14:sldId id="275"/>
             <p14:sldId id="276"/>
@@ -4057,9 +4057,33 @@
           </a:p>
         </p:txBody>
       </p:sp>
-      <p:sp>
-        <p:nvSpPr>
-          <p:cNvPr id="9" name="pill1"/>
+      <p:pic>
+        <p:nvPicPr>
+          <p:cNvPr id="9" name="icon1" descr="FaShieldAlt">    </p:cNvPr>
+          <p:cNvPicPr>
+            <a:picLocks noChangeAspect="1"/>
+          </p:cNvPicPr>
+          <p:nvPr/>
+        </p:nvPicPr>
+        <p:blipFill>
+          <a:blip r:embed="rId1"/>
+          <a:stretch>
+            <a:fillRect/>
+          </a:stretch>
+        </p:blipFill>
+        <p:spPr>
+          <a:xfrm>
+            <a:off x="10378440" y="411480"/>
+            <a:ext cx="1280160" cy="1280160"/>
+          </a:xfrm>
+          <a:prstGeom prst="rect">
+            <a:avLst/>
+          </a:prstGeom>
+        </p:spPr>
+      </p:pic>
+      <p:sp>
+        <p:nvSpPr>
+          <p:cNvPr id="10" name="pill2"/>
           <p:cNvSpPr/>
           <p:nvPr/>
         </p:nvSpPr>
@@ -4086,7 +4110,7 @@
       </p:sp>
       <p:sp>
         <p:nvSpPr>
-          <p:cNvPr id="10" name="Text 8"/>
+          <p:cNvPr id="11" name="Text 8"/>
           <p:cNvSpPr txBox="1"/>
           <p:nvPr/>
         </p:nvSpPr>
@@ -4122,7 +4146,7 @@
       </p:sp>
       <p:sp>
         <p:nvSpPr>
-          <p:cNvPr id="11" name="pill2"/>
+          <p:cNvPr id="12" name="pill3"/>
           <p:cNvSpPr/>
           <p:nvPr/>
         </p:nvSpPr>
@@ -4149,7 +4173,7 @@
       </p:sp>
       <p:sp>
         <p:nvSpPr>
-          <p:cNvPr id="12" name="Text 10"/>
+          <p:cNvPr id="13" name="Text 10"/>
           <p:cNvSpPr txBox="1"/>
           <p:nvPr/>
         </p:nvSpPr>
@@ -4185,7 +4209,7 @@
       </p:sp>
       <p:sp>
         <p:nvSpPr>
-          <p:cNvPr id="13" name="Text 11"/>
+          <p:cNvPr id="14" name="Text 11"/>
           <p:cNvSpPr txBox="1"/>
           <p:nvPr/>
         </p:nvSpPr>
@@ -4284,7 +4308,7 @@
       </p:sp>
       <p:sp>
         <p:nvSpPr>
-          <p:cNvPr id="3" name="card36"/>
+          <p:cNvPr id="3" name="card63"/>
           <p:cNvSpPr/>
           <p:nvPr/>
         </p:nvSpPr>
@@ -4722,7 +4746,7 @@
       </p:sp>
       <p:sp>
         <p:nvSpPr>
-          <p:cNvPr id="6" name="card37"/>
+          <p:cNvPr id="6" name="card64"/>
           <p:cNvSpPr/>
           <p:nvPr/>
         </p:nvSpPr>
@@ -4828,7 +4852,7 @@
       </p:sp>
       <p:sp>
         <p:nvSpPr>
-          <p:cNvPr id="9" name="card38"/>
+          <p:cNvPr id="9" name="card65"/>
           <p:cNvSpPr/>
           <p:nvPr/>
         </p:nvSpPr>
@@ -4934,7 +4958,7 @@
       </p:sp>
       <p:sp>
         <p:nvSpPr>
-          <p:cNvPr id="12" name="card39"/>
+          <p:cNvPr id="12" name="card66"/>
           <p:cNvSpPr/>
           <p:nvPr/>
         </p:nvSpPr>
@@ -5148,7 +5172,7 @@
       </p:sp>
       <p:sp>
         <p:nvSpPr>
-          <p:cNvPr id="3" name="card40"/>
+          <p:cNvPr id="3" name="card67"/>
           <p:cNvSpPr/>
           <p:nvPr/>
         </p:nvSpPr>
@@ -5291,45 +5315,33 @@
           </a:p>
         </p:txBody>
       </p:sp>
-      <p:sp>
-        <p:nvSpPr>
-          <p:cNvPr id="7" name="Text 5"/>
-          <p:cNvSpPr txBox="1"/>
-          <p:nvPr/>
-        </p:nvSpPr>
-        <p:spPr>
-          <a:xfrm>
-            <a:off x="2606040" y="2286000"/>
-            <a:ext cx="228600" cy="548640"/>
+      <p:pic>
+        <p:nvPicPr>
+          <p:cNvPr id="7" name="icon68" descr="FaChevronRight">    </p:cNvPr>
+          <p:cNvPicPr>
+            <a:picLocks noChangeAspect="1"/>
+          </p:cNvPicPr>
+          <p:nvPr/>
+        </p:nvPicPr>
+        <p:blipFill>
+          <a:blip r:embed="rId1"/>
+          <a:stretch>
+            <a:fillRect/>
+          </a:stretch>
+        </p:blipFill>
+        <p:spPr>
+          <a:xfrm>
+            <a:off x="2642616" y="2514600"/>
+            <a:ext cx="164592" cy="164592"/>
           </a:xfrm>
           <a:prstGeom prst="rect">
             <a:avLst/>
           </a:prstGeom>
-          <a:noFill/>
-          <a:ln/>
-        </p:spPr>
-        <p:txBody>
-          <a:bodyPr wrap="square" lIns="0" tIns="0" rIns="0" bIns="0" rtlCol="0" anchor="t"/>
-          <a:lstStyle/>
-          <a:p>
-            <a:pPr algn="ctr" indent="0" marL="0">
-              <a:buNone/>
-            </a:pPr>
-            <a:r>
-              <a:rPr lang="en-US" sz="2800" dirty="0">
-                <a:solidFill>
-                  <a:schemeClr val="accent6"/>
-                </a:solidFill>
-              </a:rPr>
-              <a:t>›</a:t>
-            </a:r>
-            <a:endParaRPr lang="en-US" sz="2800" dirty="0"/>
-          </a:p>
-        </p:txBody>
-      </p:sp>
-      <p:sp>
-        <p:nvSpPr>
-          <p:cNvPr id="8" name="card41"/>
+        </p:spPr>
+      </p:pic>
+      <p:sp>
+        <p:nvSpPr>
+          <p:cNvPr id="8" name="card69"/>
           <p:cNvSpPr/>
           <p:nvPr/>
         </p:nvSpPr>
@@ -5363,7 +5375,7 @@
       </p:sp>
       <p:sp>
         <p:nvSpPr>
-          <p:cNvPr id="9" name="Text 7"/>
+          <p:cNvPr id="9" name="Text 6"/>
           <p:cNvSpPr txBox="1"/>
           <p:nvPr/>
         </p:nvSpPr>
@@ -5402,7 +5414,7 @@
       </p:sp>
       <p:sp>
         <p:nvSpPr>
-          <p:cNvPr id="10" name="Text 8"/>
+          <p:cNvPr id="10" name="Text 7"/>
           <p:cNvSpPr txBox="1"/>
           <p:nvPr/>
         </p:nvSpPr>
@@ -5438,7 +5450,7 @@
       </p:sp>
       <p:sp>
         <p:nvSpPr>
-          <p:cNvPr id="11" name="Text 9"/>
+          <p:cNvPr id="11" name="Text 8"/>
           <p:cNvSpPr txBox="1"/>
           <p:nvPr/>
         </p:nvSpPr>
@@ -5472,45 +5484,33 @@
           </a:p>
         </p:txBody>
       </p:sp>
-      <p:sp>
-        <p:nvSpPr>
-          <p:cNvPr id="12" name="Text 10"/>
-          <p:cNvSpPr txBox="1"/>
-          <p:nvPr/>
-        </p:nvSpPr>
-        <p:spPr>
-          <a:xfrm>
-            <a:off x="4892040" y="2286000"/>
-            <a:ext cx="228600" cy="548640"/>
+      <p:pic>
+        <p:nvPicPr>
+          <p:cNvPr id="12" name="icon70" descr="FaChevronRight">    </p:cNvPr>
+          <p:cNvPicPr>
+            <a:picLocks noChangeAspect="1"/>
+          </p:cNvPicPr>
+          <p:nvPr/>
+        </p:nvPicPr>
+        <p:blipFill>
+          <a:blip r:embed="rId2"/>
+          <a:stretch>
+            <a:fillRect/>
+          </a:stretch>
+        </p:blipFill>
+        <p:spPr>
+          <a:xfrm>
+            <a:off x="4928616" y="2514600"/>
+            <a:ext cx="164592" cy="164592"/>
           </a:xfrm>
           <a:prstGeom prst="rect">
             <a:avLst/>
           </a:prstGeom>
-          <a:noFill/>
-          <a:ln/>
-        </p:spPr>
-        <p:txBody>
-          <a:bodyPr wrap="square" lIns="0" tIns="0" rIns="0" bIns="0" rtlCol="0" anchor="t"/>
-          <a:lstStyle/>
-          <a:p>
-            <a:pPr algn="ctr" indent="0" marL="0">
-              <a:buNone/>
-            </a:pPr>
-            <a:r>
-              <a:rPr lang="en-US" sz="2800" dirty="0">
-                <a:solidFill>
-                  <a:schemeClr val="accent6"/>
-                </a:solidFill>
-              </a:rPr>
-              <a:t>›</a:t>
-            </a:r>
-            <a:endParaRPr lang="en-US" sz="2800" dirty="0"/>
-          </a:p>
-        </p:txBody>
-      </p:sp>
-      <p:sp>
-        <p:nvSpPr>
-          <p:cNvPr id="13" name="card42"/>
+        </p:spPr>
+      </p:pic>
+      <p:sp>
+        <p:nvSpPr>
+          <p:cNvPr id="13" name="card71"/>
           <p:cNvSpPr/>
           <p:nvPr/>
         </p:nvSpPr>
@@ -5544,7 +5544,7 @@
       </p:sp>
       <p:sp>
         <p:nvSpPr>
-          <p:cNvPr id="14" name="Text 12"/>
+          <p:cNvPr id="14" name="Text 10"/>
           <p:cNvSpPr txBox="1"/>
           <p:nvPr/>
         </p:nvSpPr>
@@ -5583,7 +5583,7 @@
       </p:sp>
       <p:sp>
         <p:nvSpPr>
-          <p:cNvPr id="15" name="Text 13"/>
+          <p:cNvPr id="15" name="Text 11"/>
           <p:cNvSpPr txBox="1"/>
           <p:nvPr/>
         </p:nvSpPr>
@@ -5619,7 +5619,7 @@
       </p:sp>
       <p:sp>
         <p:nvSpPr>
-          <p:cNvPr id="16" name="Text 14"/>
+          <p:cNvPr id="16" name="Text 12"/>
           <p:cNvSpPr txBox="1"/>
           <p:nvPr/>
         </p:nvSpPr>
@@ -5653,45 +5653,33 @@
           </a:p>
         </p:txBody>
       </p:sp>
-      <p:sp>
-        <p:nvSpPr>
-          <p:cNvPr id="17" name="Text 15"/>
-          <p:cNvSpPr txBox="1"/>
-          <p:nvPr/>
-        </p:nvSpPr>
-        <p:spPr>
-          <a:xfrm>
-            <a:off x="7178040" y="2286000"/>
-            <a:ext cx="228600" cy="548640"/>
+      <p:pic>
+        <p:nvPicPr>
+          <p:cNvPr id="17" name="icon72" descr="FaChevronRight">    </p:cNvPr>
+          <p:cNvPicPr>
+            <a:picLocks noChangeAspect="1"/>
+          </p:cNvPicPr>
+          <p:nvPr/>
+        </p:nvPicPr>
+        <p:blipFill>
+          <a:blip r:embed="rId3"/>
+          <a:stretch>
+            <a:fillRect/>
+          </a:stretch>
+        </p:blipFill>
+        <p:spPr>
+          <a:xfrm>
+            <a:off x="7214616" y="2514600"/>
+            <a:ext cx="164592" cy="164592"/>
           </a:xfrm>
           <a:prstGeom prst="rect">
             <a:avLst/>
           </a:prstGeom>
-          <a:noFill/>
-          <a:ln/>
-        </p:spPr>
-        <p:txBody>
-          <a:bodyPr wrap="square" lIns="0" tIns="0" rIns="0" bIns="0" rtlCol="0" anchor="t"/>
-          <a:lstStyle/>
-          <a:p>
-            <a:pPr algn="ctr" indent="0" marL="0">
-              <a:buNone/>
-            </a:pPr>
-            <a:r>
-              <a:rPr lang="en-US" sz="2800" dirty="0">
-                <a:solidFill>
-                  <a:schemeClr val="accent6"/>
-                </a:solidFill>
-              </a:rPr>
-              <a:t>›</a:t>
-            </a:r>
-            <a:endParaRPr lang="en-US" sz="2800" dirty="0"/>
-          </a:p>
-        </p:txBody>
-      </p:sp>
-      <p:sp>
-        <p:nvSpPr>
-          <p:cNvPr id="18" name="card43"/>
+        </p:spPr>
+      </p:pic>
+      <p:sp>
+        <p:nvSpPr>
+          <p:cNvPr id="18" name="card73"/>
           <p:cNvSpPr/>
           <p:nvPr/>
         </p:nvSpPr>
@@ -5725,7 +5713,7 @@
       </p:sp>
       <p:sp>
         <p:nvSpPr>
-          <p:cNvPr id="19" name="Text 17"/>
+          <p:cNvPr id="19" name="Text 14"/>
           <p:cNvSpPr txBox="1"/>
           <p:nvPr/>
         </p:nvSpPr>
@@ -5764,7 +5752,7 @@
       </p:sp>
       <p:sp>
         <p:nvSpPr>
-          <p:cNvPr id="20" name="Text 18"/>
+          <p:cNvPr id="20" name="Text 15"/>
           <p:cNvSpPr txBox="1"/>
           <p:nvPr/>
         </p:nvSpPr>
@@ -5800,7 +5788,7 @@
       </p:sp>
       <p:sp>
         <p:nvSpPr>
-          <p:cNvPr id="21" name="Text 19"/>
+          <p:cNvPr id="21" name="Text 16"/>
           <p:cNvSpPr txBox="1"/>
           <p:nvPr/>
         </p:nvSpPr>
@@ -5834,45 +5822,33 @@
           </a:p>
         </p:txBody>
       </p:sp>
-      <p:sp>
-        <p:nvSpPr>
-          <p:cNvPr id="22" name="Text 20"/>
-          <p:cNvSpPr txBox="1"/>
-          <p:nvPr/>
-        </p:nvSpPr>
-        <p:spPr>
-          <a:xfrm>
-            <a:off x="9464040" y="2286000"/>
-            <a:ext cx="228600" cy="548640"/>
+      <p:pic>
+        <p:nvPicPr>
+          <p:cNvPr id="22" name="icon74" descr="FaChevronRight">    </p:cNvPr>
+          <p:cNvPicPr>
+            <a:picLocks noChangeAspect="1"/>
+          </p:cNvPicPr>
+          <p:nvPr/>
+        </p:nvPicPr>
+        <p:blipFill>
+          <a:blip r:embed="rId4"/>
+          <a:stretch>
+            <a:fillRect/>
+          </a:stretch>
+        </p:blipFill>
+        <p:spPr>
+          <a:xfrm>
+            <a:off x="9500616" y="2514600"/>
+            <a:ext cx="164592" cy="164592"/>
           </a:xfrm>
           <a:prstGeom prst="rect">
             <a:avLst/>
           </a:prstGeom>
-          <a:noFill/>
-          <a:ln/>
-        </p:spPr>
-        <p:txBody>
-          <a:bodyPr wrap="square" lIns="0" tIns="0" rIns="0" bIns="0" rtlCol="0" anchor="t"/>
-          <a:lstStyle/>
-          <a:p>
-            <a:pPr algn="ctr" indent="0" marL="0">
-              <a:buNone/>
-            </a:pPr>
-            <a:r>
-              <a:rPr lang="en-US" sz="2800" dirty="0">
-                <a:solidFill>
-                  <a:schemeClr val="accent6"/>
-                </a:solidFill>
-              </a:rPr>
-              <a:t>›</a:t>
-            </a:r>
-            <a:endParaRPr lang="en-US" sz="2800" dirty="0"/>
-          </a:p>
-        </p:txBody>
-      </p:sp>
-      <p:sp>
-        <p:nvSpPr>
-          <p:cNvPr id="23" name="card44"/>
+        </p:spPr>
+      </p:pic>
+      <p:sp>
+        <p:nvSpPr>
+          <p:cNvPr id="23" name="card75"/>
           <p:cNvSpPr/>
           <p:nvPr/>
         </p:nvSpPr>
@@ -5906,7 +5882,7 @@
       </p:sp>
       <p:sp>
         <p:nvSpPr>
-          <p:cNvPr id="24" name="Text 22"/>
+          <p:cNvPr id="24" name="Text 18"/>
           <p:cNvSpPr txBox="1"/>
           <p:nvPr/>
         </p:nvSpPr>
@@ -5945,7 +5921,7 @@
       </p:sp>
       <p:sp>
         <p:nvSpPr>
-          <p:cNvPr id="25" name="Text 23"/>
+          <p:cNvPr id="25" name="Text 19"/>
           <p:cNvSpPr txBox="1"/>
           <p:nvPr/>
         </p:nvSpPr>
@@ -5981,7 +5957,7 @@
       </p:sp>
       <p:sp>
         <p:nvSpPr>
-          <p:cNvPr id="26" name="Text 24"/>
+          <p:cNvPr id="26" name="Text 20"/>
           <p:cNvSpPr txBox="1"/>
           <p:nvPr/>
         </p:nvSpPr>
@@ -6017,7 +5993,7 @@
       </p:sp>
       <p:sp>
         <p:nvSpPr>
-          <p:cNvPr id="27" name="card45"/>
+          <p:cNvPr id="27" name="card76"/>
           <p:cNvSpPr/>
           <p:nvPr/>
         </p:nvSpPr>
@@ -6051,7 +6027,7 @@
       </p:sp>
       <p:sp>
         <p:nvSpPr>
-          <p:cNvPr id="28" name="Text 26"/>
+          <p:cNvPr id="28" name="Text 22"/>
           <p:cNvSpPr txBox="1"/>
           <p:nvPr/>
         </p:nvSpPr>
@@ -6252,7 +6228,7 @@
       </p:sp>
       <p:pic>
         <p:nvPicPr>
-          <p:cNvPr id="3" name="img46" descr="Stage 0: Sales PC reaches R-CORE by SSH and Telnet">    </p:cNvPr>
+          <p:cNvPr id="3" name="img77" descr="Stage 0: Sales PC reaches R-CORE by SSH and Telnet">    </p:cNvPr>
           <p:cNvPicPr>
             <a:picLocks noChangeAspect="1"/>
           </p:cNvPicPr>
@@ -6276,7 +6252,7 @@
       </p:pic>
       <p:sp>
         <p:nvSpPr>
-          <p:cNvPr id="4" name="card47"/>
+          <p:cNvPr id="4" name="card78"/>
           <p:cNvSpPr/>
           <p:nvPr/>
         </p:nvSpPr>
@@ -6360,7 +6336,7 @@
       </p:sp>
       <p:sp>
         <p:nvSpPr>
-          <p:cNvPr id="6" name="card48"/>
+          <p:cNvPr id="6" name="card79"/>
           <p:cNvSpPr/>
           <p:nvPr/>
         </p:nvSpPr>
@@ -6595,7 +6571,7 @@
       </p:sp>
       <p:pic>
         <p:nvPicPr>
-          <p:cNvPr id="3" name="img49" descr="Stage 1: HR pings WEB-SRV and FIN-PC1">    </p:cNvPr>
+          <p:cNvPr id="3" name="img80" descr="Stage 1: HR pings WEB-SRV and FIN-PC1">    </p:cNvPr>
           <p:cNvPicPr>
             <a:picLocks noChangeAspect="1"/>
           </p:cNvPicPr>
@@ -6619,7 +6595,7 @@
       </p:pic>
       <p:pic>
         <p:nvPicPr>
-          <p:cNvPr id="4" name="img50" descr="Stage 1: R-EDGE access-list counters">    </p:cNvPr>
+          <p:cNvPr id="4" name="img81" descr="Stage 1: R-EDGE access-list counters">    </p:cNvPr>
           <p:cNvPicPr>
             <a:picLocks noChangeAspect="1"/>
           </p:cNvPicPr>
@@ -6643,7 +6619,7 @@
       </p:pic>
       <p:sp>
         <p:nvSpPr>
-          <p:cNvPr id="5" name="pill51"/>
+          <p:cNvPr id="5" name="pill82"/>
           <p:cNvSpPr/>
           <p:nvPr/>
         </p:nvSpPr>
@@ -6742,7 +6718,7 @@
       </p:sp>
       <p:sp>
         <p:nvSpPr>
-          <p:cNvPr id="8" name="pill52"/>
+          <p:cNvPr id="8" name="pill83"/>
           <p:cNvSpPr/>
           <p:nvPr/>
         </p:nvSpPr>
@@ -6949,7 +6925,7 @@
       </p:sp>
       <p:pic>
         <p:nvPicPr>
-          <p:cNvPr id="3" name="img53" descr="Stage 2: HR to Finance ping blocked">    </p:cNvPr>
+          <p:cNvPr id="3" name="img84" descr="Stage 2: HR to Finance ping blocked">    </p:cNvPr>
           <p:cNvPicPr>
             <a:picLocks noChangeAspect="1"/>
           </p:cNvPicPr>
@@ -6973,7 +6949,7 @@
       </p:pic>
       <p:pic>
         <p:nvPicPr>
-          <p:cNvPr id="4" name="img54" descr="Stage 2: R-CORE ACLs with counters">    </p:cNvPr>
+          <p:cNvPr id="4" name="img85" descr="Stage 2: R-CORE ACLs with counters">    </p:cNvPr>
           <p:cNvPicPr>
             <a:picLocks noChangeAspect="1"/>
           </p:cNvPicPr>
@@ -6997,7 +6973,7 @@
       </p:pic>
       <p:sp>
         <p:nvSpPr>
-          <p:cNvPr id="5" name="pill55"/>
+          <p:cNvPr id="5" name="pill86"/>
           <p:cNvSpPr/>
           <p:nvPr/>
         </p:nvSpPr>
@@ -7096,7 +7072,7 @@
       </p:sp>
       <p:sp>
         <p:nvSpPr>
-          <p:cNvPr id="8" name="pill56"/>
+          <p:cNvPr id="8" name="pill87"/>
           <p:cNvSpPr/>
           <p:nvPr/>
         </p:nvSpPr>
@@ -16462,7 +16438,7 @@
       </p:graphicFrame>
       <p:sp>
         <p:nvSpPr>
-          <p:cNvPr id="4" name="card57"/>
+          <p:cNvPr id="4" name="card88"/>
           <p:cNvSpPr/>
           <p:nvPr/>
         </p:nvSpPr>
@@ -16607,7 +16583,7 @@
       </p:sp>
       <p:sp>
         <p:nvSpPr>
-          <p:cNvPr id="8" name="card58"/>
+          <p:cNvPr id="8" name="card89"/>
           <p:cNvSpPr/>
           <p:nvPr/>
         </p:nvSpPr>
@@ -16752,7 +16728,7 @@
       </p:sp>
       <p:sp>
         <p:nvSpPr>
-          <p:cNvPr id="12" name="card59"/>
+          <p:cNvPr id="12" name="card90"/>
           <p:cNvSpPr/>
           <p:nvPr/>
         </p:nvSpPr>
@@ -17041,7 +17017,7 @@
       </p:sp>
       <p:pic>
         <p:nvPicPr>
-          <p:cNvPr id="3" name="img60" descr="Stage 2: SAL-PC1 opens HR records page">    </p:cNvPr>
+          <p:cNvPr id="3" name="img91" descr="Stage 2: SAL-PC1 opens HR records page">    </p:cNvPr>
           <p:cNvPicPr>
             <a:picLocks noChangeAspect="1"/>
           </p:cNvPicPr>
@@ -17065,7 +17041,7 @@
       </p:pic>
       <p:pic>
         <p:nvPicPr>
-          <p:cNvPr id="4" name="img61" descr="Stage 3: SAL-PC1 gets Request Timeout">    </p:cNvPr>
+          <p:cNvPr id="4" name="img92" descr="Stage 3: SAL-PC1 gets Request Timeout">    </p:cNvPr>
           <p:cNvPicPr>
             <a:picLocks noChangeAspect="1"/>
           </p:cNvPicPr>
@@ -17089,7 +17065,7 @@
       </p:pic>
       <p:sp>
         <p:nvSpPr>
-          <p:cNvPr id="5" name="pill62"/>
+          <p:cNvPr id="5" name="pill93"/>
           <p:cNvSpPr/>
           <p:nvPr/>
         </p:nvSpPr>
@@ -17188,7 +17164,7 @@
       </p:sp>
       <p:sp>
         <p:nvSpPr>
-          <p:cNvPr id="8" name="pill63"/>
+          <p:cNvPr id="8" name="pill94"/>
           <p:cNvSpPr/>
           <p:nvPr/>
         </p:nvSpPr>
@@ -17395,7 +17371,7 @@
       </p:sp>
       <p:pic>
         <p:nvPicPr>
-          <p:cNvPr id="3" name="img64" descr="Stage 3 FTP: login works, dir fails">    </p:cNvPr>
+          <p:cNvPr id="3" name="img95" descr="Stage 3 FTP: login works, dir fails">    </p:cNvPr>
           <p:cNvPicPr>
             <a:picLocks noChangeAspect="1"/>
           </p:cNvPicPr>
@@ -17419,7 +17395,7 @@
       </p:pic>
       <p:sp>
         <p:nvSpPr>
-          <p:cNvPr id="4" name="card65"/>
+          <p:cNvPr id="4" name="card96"/>
           <p:cNvSpPr/>
           <p:nvPr/>
         </p:nvSpPr>
@@ -17695,7 +17671,7 @@
       </p:sp>
       <p:sp>
         <p:nvSpPr>
-          <p:cNvPr id="3" name="card66"/>
+          <p:cNvPr id="3" name="card97"/>
           <p:cNvSpPr/>
           <p:nvPr/>
         </p:nvSpPr>
@@ -17729,14 +17705,63 @@
       </p:sp>
       <p:sp>
         <p:nvSpPr>
-          <p:cNvPr id="4" name="Text 2"/>
+          <p:cNvPr id="4" name="iconbg98"/>
+          <p:cNvSpPr/>
+          <p:nvPr/>
+        </p:nvSpPr>
+        <p:spPr>
+          <a:xfrm>
+            <a:off x="822960" y="1600200"/>
+            <a:ext cx="548640" cy="548640"/>
+          </a:xfrm>
+          <a:prstGeom prst="ellipse">
+            <a:avLst/>
+          </a:prstGeom>
+          <a:solidFill>
+            <a:srgbClr val="2E3A46"/>
+          </a:solidFill>
+          <a:ln w="12700">
+            <a:solidFill>
+              <a:srgbClr val="2E3A46"/>
+            </a:solidFill>
+            <a:prstDash val="solid"/>
+          </a:ln>
+        </p:spPr>
+      </p:sp>
+      <p:pic>
+        <p:nvPicPr>
+          <p:cNvPr id="5" name="icon99" descr="FaCodeBranch">    </p:cNvPr>
+          <p:cNvPicPr>
+            <a:picLocks noChangeAspect="1"/>
+          </p:cNvPicPr>
+          <p:nvPr/>
+        </p:nvPicPr>
+        <p:blipFill>
+          <a:blip r:embed="rId1"/>
+          <a:stretch>
+            <a:fillRect/>
+          </a:stretch>
+        </p:blipFill>
+        <p:spPr>
+          <a:xfrm>
+            <a:off x="954634" y="1731874"/>
+            <a:ext cx="285293" cy="285293"/>
+          </a:xfrm>
+          <a:prstGeom prst="rect">
+            <a:avLst/>
+          </a:prstGeom>
+        </p:spPr>
+      </p:pic>
+      <p:sp>
+        <p:nvSpPr>
+          <p:cNvPr id="6" name="Text 3"/>
           <p:cNvSpPr txBox="1"/>
           <p:nvPr/>
         </p:nvSpPr>
         <p:spPr>
           <a:xfrm>
-            <a:off x="822960" y="1600200"/>
-            <a:ext cx="4846320" cy="457200"/>
+            <a:off x="1554480" y="1600200"/>
+            <a:ext cx="4206240" cy="548640"/>
           </a:xfrm>
           <a:prstGeom prst="rect">
             <a:avLst/>
@@ -17745,7 +17770,7 @@
           <a:ln/>
         </p:spPr>
         <p:txBody>
-          <a:bodyPr wrap="square" lIns="0" tIns="0" rIns="0" bIns="0" rtlCol="0" anchor="t"/>
+          <a:bodyPr wrap="square" lIns="0" tIns="0" rIns="0" bIns="0" rtlCol="0" anchor="ctr"/>
           <a:lstStyle/>
           <a:p>
             <a:pPr indent="0" marL="0">
@@ -17765,14 +17790,14 @@
       </p:sp>
       <p:sp>
         <p:nvSpPr>
-          <p:cNvPr id="5" name="Text 3"/>
+          <p:cNvPr id="7" name="Text 4"/>
           <p:cNvSpPr txBox="1"/>
           <p:nvPr/>
         </p:nvSpPr>
         <p:spPr>
           <a:xfrm>
-            <a:off x="822960" y="2148840"/>
-            <a:ext cx="4892040" cy="1280160"/>
+            <a:off x="822960" y="2286000"/>
+            <a:ext cx="4892040" cy="1188720"/>
           </a:xfrm>
           <a:prstGeom prst="rect">
             <a:avLst/>
@@ -17788,20 +17813,20 @@
               <a:buNone/>
             </a:pPr>
             <a:r>
-              <a:rPr lang="en-US" sz="1500" dirty="0">
+              <a:rPr lang="en-US" sz="1600" dirty="0">
                 <a:solidFill>
                   <a:schemeClr val="tx1"/>
                 </a:solidFill>
               </a:rPr>
               <a:t>In Stage 2, Sales SSH to 192.168.40.1 timed out (interface ACL) while SSH to 192.168.50.1 was refused (router login rule): one goal, enforced in two places.</a:t>
             </a:r>
-            <a:endParaRPr lang="en-US" sz="1500" dirty="0"/>
+            <a:endParaRPr lang="en-US" sz="1600" dirty="0"/>
           </a:p>
         </p:txBody>
       </p:sp>
       <p:sp>
         <p:nvSpPr>
-          <p:cNvPr id="6" name="card67"/>
+          <p:cNvPr id="8" name="card100"/>
           <p:cNvSpPr/>
           <p:nvPr/>
         </p:nvSpPr>
@@ -17835,14 +17860,63 @@
       </p:sp>
       <p:sp>
         <p:nvSpPr>
-          <p:cNvPr id="7" name="Text 5"/>
+          <p:cNvPr id="9" name="iconbg101"/>
+          <p:cNvSpPr/>
+          <p:nvPr/>
+        </p:nvSpPr>
+        <p:spPr>
+          <a:xfrm>
+            <a:off x="6446520" y="1600200"/>
+            <a:ext cx="548640" cy="548640"/>
+          </a:xfrm>
+          <a:prstGeom prst="ellipse">
+            <a:avLst/>
+          </a:prstGeom>
+          <a:solidFill>
+            <a:srgbClr val="2E3A46"/>
+          </a:solidFill>
+          <a:ln w="12700">
+            <a:solidFill>
+              <a:srgbClr val="2E3A46"/>
+            </a:solidFill>
+            <a:prstDash val="solid"/>
+          </a:ln>
+        </p:spPr>
+      </p:sp>
+      <p:pic>
+        <p:nvPicPr>
+          <p:cNvPr id="10" name="icon102" descr="FaSortAmountDown">    </p:cNvPr>
+          <p:cNvPicPr>
+            <a:picLocks noChangeAspect="1"/>
+          </p:cNvPicPr>
+          <p:nvPr/>
+        </p:nvPicPr>
+        <p:blipFill>
+          <a:blip r:embed="rId2"/>
+          <a:stretch>
+            <a:fillRect/>
+          </a:stretch>
+        </p:blipFill>
+        <p:spPr>
+          <a:xfrm>
+            <a:off x="6578194" y="1731874"/>
+            <a:ext cx="285293" cy="285293"/>
+          </a:xfrm>
+          <a:prstGeom prst="rect">
+            <a:avLst/>
+          </a:prstGeom>
+        </p:spPr>
+      </p:pic>
+      <p:sp>
+        <p:nvSpPr>
+          <p:cNvPr id="11" name="Text 7"/>
           <p:cNvSpPr txBox="1"/>
           <p:nvPr/>
         </p:nvSpPr>
         <p:spPr>
           <a:xfrm>
-            <a:off x="6446520" y="1600200"/>
-            <a:ext cx="4846320" cy="457200"/>
+            <a:off x="7178040" y="1600200"/>
+            <a:ext cx="4206240" cy="548640"/>
           </a:xfrm>
           <a:prstGeom prst="rect">
             <a:avLst/>
@@ -17851,7 +17925,7 @@
           <a:ln/>
         </p:spPr>
         <p:txBody>
-          <a:bodyPr wrap="square" lIns="0" tIns="0" rIns="0" bIns="0" rtlCol="0" anchor="t"/>
+          <a:bodyPr wrap="square" lIns="0" tIns="0" rIns="0" bIns="0" rtlCol="0" anchor="ctr"/>
           <a:lstStyle/>
           <a:p>
             <a:pPr indent="0" marL="0">
@@ -17871,14 +17945,14 @@
       </p:sp>
       <p:sp>
         <p:nvSpPr>
-          <p:cNvPr id="8" name="Text 6"/>
+          <p:cNvPr id="12" name="Text 8"/>
           <p:cNvSpPr txBox="1"/>
           <p:nvPr/>
         </p:nvSpPr>
         <p:spPr>
           <a:xfrm>
-            <a:off x="6446520" y="2148840"/>
-            <a:ext cx="4892040" cy="1280160"/>
+            <a:off x="6446520" y="2286000"/>
+            <a:ext cx="4892040" cy="1188720"/>
           </a:xfrm>
           <a:prstGeom prst="rect">
             <a:avLst/>
@@ -17894,20 +17968,20 @@
               <a:buNone/>
             </a:pPr>
             <a:r>
-              <a:rPr lang="en-US" sz="1500" dirty="0">
+              <a:rPr lang="en-US" sz="1600" dirty="0">
                 <a:solidFill>
                   <a:schemeClr val="tx1"/>
                 </a:solidFill>
               </a:rPr>
               <a:t>The Stage 3 edge ACL is the strictest but has the fewest entries (6 → 6 → 5).</a:t>
             </a:r>
-            <a:endParaRPr lang="en-US" sz="1500" dirty="0"/>
+            <a:endParaRPr lang="en-US" sz="1600" dirty="0"/>
           </a:p>
         </p:txBody>
       </p:sp>
       <p:sp>
         <p:nvSpPr>
-          <p:cNvPr id="9" name="card68"/>
+          <p:cNvPr id="13" name="card103"/>
           <p:cNvSpPr/>
           <p:nvPr/>
         </p:nvSpPr>
@@ -17941,14 +18015,63 @@
       </p:sp>
       <p:sp>
         <p:nvSpPr>
-          <p:cNvPr id="10" name="Text 8"/>
+          <p:cNvPr id="14" name="iconbg104"/>
+          <p:cNvSpPr/>
+          <p:nvPr/>
+        </p:nvSpPr>
+        <p:spPr>
+          <a:xfrm>
+            <a:off x="822960" y="3977640"/>
+            <a:ext cx="548640" cy="548640"/>
+          </a:xfrm>
+          <a:prstGeom prst="ellipse">
+            <a:avLst/>
+          </a:prstGeom>
+          <a:solidFill>
+            <a:srgbClr val="2E3A46"/>
+          </a:solidFill>
+          <a:ln w="12700">
+            <a:solidFill>
+              <a:srgbClr val="2E3A46"/>
+            </a:solidFill>
+            <a:prstDash val="solid"/>
+          </a:ln>
+        </p:spPr>
+      </p:sp>
+      <p:pic>
+        <p:nvPicPr>
+          <p:cNvPr id="15" name="icon105" descr="FaProjectDiagram">    </p:cNvPr>
+          <p:cNvPicPr>
+            <a:picLocks noChangeAspect="1"/>
+          </p:cNvPicPr>
+          <p:nvPr/>
+        </p:nvPicPr>
+        <p:blipFill>
+          <a:blip r:embed="rId3"/>
+          <a:stretch>
+            <a:fillRect/>
+          </a:stretch>
+        </p:blipFill>
+        <p:spPr>
+          <a:xfrm>
+            <a:off x="954634" y="4109314"/>
+            <a:ext cx="285293" cy="285293"/>
+          </a:xfrm>
+          <a:prstGeom prst="rect">
+            <a:avLst/>
+          </a:prstGeom>
+        </p:spPr>
+      </p:pic>
+      <p:sp>
+        <p:nvSpPr>
+          <p:cNvPr id="16" name="Text 11"/>
           <p:cNvSpPr txBox="1"/>
           <p:nvPr/>
         </p:nvSpPr>
         <p:spPr>
           <a:xfrm>
-            <a:off x="822960" y="3977640"/>
-            <a:ext cx="4846320" cy="457200"/>
+            <a:off x="1554480" y="3977640"/>
+            <a:ext cx="4206240" cy="548640"/>
           </a:xfrm>
           <a:prstGeom prst="rect">
             <a:avLst/>
@@ -17957,7 +18080,7 @@
           <a:ln/>
         </p:spPr>
         <p:txBody>
-          <a:bodyPr wrap="square" lIns="0" tIns="0" rIns="0" bIns="0" rtlCol="0" anchor="t"/>
+          <a:bodyPr wrap="square" lIns="0" tIns="0" rIns="0" bIns="0" rtlCol="0" anchor="ctr"/>
           <a:lstStyle/>
           <a:p>
             <a:pPr indent="0" marL="0">
@@ -17977,14 +18100,14 @@
       </p:sp>
       <p:sp>
         <p:nvSpPr>
-          <p:cNvPr id="11" name="Text 9"/>
+          <p:cNvPr id="17" name="Text 12"/>
           <p:cNvSpPr txBox="1"/>
           <p:nvPr/>
         </p:nvSpPr>
         <p:spPr>
           <a:xfrm>
-            <a:off x="822960" y="4526280"/>
-            <a:ext cx="4892040" cy="1280160"/>
+            <a:off x="822960" y="4663440"/>
+            <a:ext cx="4892040" cy="1188720"/>
           </a:xfrm>
           <a:prstGeom prst="rect">
             <a:avLst/>
@@ -18000,20 +18123,20 @@
               <a:buNone/>
             </a:pPr>
             <a:r>
-              <a:rPr lang="en-US" sz="1500" dirty="0">
+              <a:rPr lang="en-US" sz="1600" dirty="0">
                 <a:solidFill>
                   <a:schemeClr val="tx1"/>
                 </a:solidFill>
               </a:rPr>
               <a:t>HR-PC1 always reached HR-PC2: traffic inside a VLAN never passes the router, so no router ACL can filter it.</a:t>
             </a:r>
-            <a:endParaRPr lang="en-US" sz="1500" dirty="0"/>
+            <a:endParaRPr lang="en-US" sz="1600" dirty="0"/>
           </a:p>
         </p:txBody>
       </p:sp>
       <p:sp>
         <p:nvSpPr>
-          <p:cNvPr id="12" name="card69"/>
+          <p:cNvPr id="18" name="card106"/>
           <p:cNvSpPr/>
           <p:nvPr/>
         </p:nvSpPr>
@@ -18047,14 +18170,63 @@
       </p:sp>
       <p:sp>
         <p:nvSpPr>
-          <p:cNvPr id="13" name="Text 11"/>
+          <p:cNvPr id="19" name="iconbg107"/>
+          <p:cNvSpPr/>
+          <p:nvPr/>
+        </p:nvSpPr>
+        <p:spPr>
+          <a:xfrm>
+            <a:off x="6446520" y="3977640"/>
+            <a:ext cx="548640" cy="548640"/>
+          </a:xfrm>
+          <a:prstGeom prst="ellipse">
+            <a:avLst/>
+          </a:prstGeom>
+          <a:solidFill>
+            <a:srgbClr val="2E3A46"/>
+          </a:solidFill>
+          <a:ln w="12700">
+            <a:solidFill>
+              <a:srgbClr val="2E3A46"/>
+            </a:solidFill>
+            <a:prstDash val="solid"/>
+          </a:ln>
+        </p:spPr>
+      </p:sp>
+      <p:pic>
+        <p:nvPicPr>
+          <p:cNvPr id="20" name="icon108" descr="FaWrench">    </p:cNvPr>
+          <p:cNvPicPr>
+            <a:picLocks noChangeAspect="1"/>
+          </p:cNvPicPr>
+          <p:nvPr/>
+        </p:nvPicPr>
+        <p:blipFill>
+          <a:blip r:embed="rId4"/>
+          <a:stretch>
+            <a:fillRect/>
+          </a:stretch>
+        </p:blipFill>
+        <p:spPr>
+          <a:xfrm>
+            <a:off x="6578194" y="4109314"/>
+            <a:ext cx="285293" cy="285293"/>
+          </a:xfrm>
+          <a:prstGeom prst="rect">
+            <a:avLst/>
+          </a:prstGeom>
+        </p:spPr>
+      </p:pic>
+      <p:sp>
+        <p:nvSpPr>
+          <p:cNvPr id="21" name="Text 15"/>
           <p:cNvSpPr txBox="1"/>
           <p:nvPr/>
         </p:nvSpPr>
         <p:spPr>
           <a:xfrm>
-            <a:off x="6446520" y="3977640"/>
-            <a:ext cx="4846320" cy="457200"/>
+            <a:off x="7178040" y="3977640"/>
+            <a:ext cx="4206240" cy="548640"/>
           </a:xfrm>
           <a:prstGeom prst="rect">
             <a:avLst/>
@@ -18063,7 +18235,7 @@
           <a:ln/>
         </p:spPr>
         <p:txBody>
-          <a:bodyPr wrap="square" lIns="0" tIns="0" rIns="0" bIns="0" rtlCol="0" anchor="t"/>
+          <a:bodyPr wrap="square" lIns="0" tIns="0" rIns="0" bIns="0" rtlCol="0" anchor="ctr"/>
           <a:lstStyle/>
           <a:p>
             <a:pPr indent="0" marL="0">
@@ -18083,14 +18255,14 @@
       </p:sp>
       <p:sp>
         <p:nvSpPr>
-          <p:cNvPr id="14" name="Text 12"/>
+          <p:cNvPr id="22" name="Text 16"/>
           <p:cNvSpPr txBox="1"/>
           <p:nvPr/>
         </p:nvSpPr>
         <p:spPr>
           <a:xfrm>
-            <a:off x="6446520" y="4526280"/>
-            <a:ext cx="4892040" cy="1280160"/>
+            <a:off x="6446520" y="4663440"/>
+            <a:ext cx="4892040" cy="1188720"/>
           </a:xfrm>
           <a:prstGeom prst="rect">
             <a:avLst/>
@@ -18106,14 +18278,14 @@
               <a:buNone/>
             </a:pPr>
             <a:r>
-              <a:rPr lang="en-US" sz="1500" dirty="0">
+              <a:rPr lang="en-US" sz="1600" dirty="0">
                 <a:solidFill>
                   <a:schemeClr val="tx1"/>
                 </a:solidFill>
               </a:rPr>
               <a:t>A duplicate IP on R-CORE and wrong server addresses were found in Stage 0 and corrected before testing.</a:t>
             </a:r>
-            <a:endParaRPr lang="en-US" sz="1500" dirty="0"/>
+            <a:endParaRPr lang="en-US" sz="1600" dirty="0"/>
           </a:p>
         </p:txBody>
       </p:sp>
@@ -18291,7 +18463,7 @@
       </p:sp>
       <p:sp>
         <p:nvSpPr>
-          <p:cNvPr id="5" name="card3"/>
+          <p:cNvPr id="5" name="card4"/>
           <p:cNvSpPr/>
           <p:nvPr/>
         </p:nvSpPr>
@@ -18497,7 +18669,7 @@
       </p:sp>
       <p:sp>
         <p:nvSpPr>
-          <p:cNvPr id="11" name="card4"/>
+          <p:cNvPr id="11" name="card5"/>
           <p:cNvSpPr/>
           <p:nvPr/>
         </p:nvSpPr>
@@ -18703,7 +18875,7 @@
       </p:sp>
       <p:sp>
         <p:nvSpPr>
-          <p:cNvPr id="17" name="card5"/>
+          <p:cNvPr id="17" name="card6"/>
           <p:cNvSpPr/>
           <p:nvPr/>
         </p:nvSpPr>
@@ -18909,7 +19081,7 @@
       </p:sp>
       <p:sp>
         <p:nvSpPr>
-          <p:cNvPr id="23" name="card6"/>
+          <p:cNvPr id="23" name="card7"/>
           <p:cNvSpPr/>
           <p:nvPr/>
         </p:nvSpPr>
@@ -20722,7 +20894,7 @@
       </p:sp>
       <p:sp>
         <p:nvSpPr>
-          <p:cNvPr id="3" name="card70"/>
+          <p:cNvPr id="3" name="card109"/>
           <p:cNvSpPr/>
           <p:nvPr/>
         </p:nvSpPr>
@@ -20756,14 +20928,63 @@
       </p:sp>
       <p:sp>
         <p:nvSpPr>
-          <p:cNvPr id="4" name="Text 2"/>
+          <p:cNvPr id="4" name="iconbg110"/>
+          <p:cNvSpPr/>
+          <p:nvPr/>
+        </p:nvSpPr>
+        <p:spPr>
+          <a:xfrm>
+            <a:off x="822960" y="1627632"/>
+            <a:ext cx="530352" cy="530352"/>
+          </a:xfrm>
+          <a:prstGeom prst="ellipse">
+            <a:avLst/>
+          </a:prstGeom>
+          <a:solidFill>
+            <a:srgbClr val="C0392B"/>
+          </a:solidFill>
+          <a:ln w="12700">
+            <a:solidFill>
+              <a:srgbClr val="C0392B"/>
+            </a:solidFill>
+            <a:prstDash val="solid"/>
+          </a:ln>
+        </p:spPr>
+      </p:sp>
+      <p:pic>
+        <p:nvPicPr>
+          <p:cNvPr id="5" name="icon111" descr="FaCompress">    </p:cNvPr>
+          <p:cNvPicPr>
+            <a:picLocks noChangeAspect="1"/>
+          </p:cNvPicPr>
+          <p:nvPr/>
+        </p:nvPicPr>
+        <p:blipFill>
+          <a:blip r:embed="rId1"/>
+          <a:stretch>
+            <a:fillRect/>
+          </a:stretch>
+        </p:blipFill>
+        <p:spPr>
+          <a:xfrm>
+            <a:off x="950244" y="1754916"/>
+            <a:ext cx="275783" cy="275783"/>
+          </a:xfrm>
+          <a:prstGeom prst="rect">
+            <a:avLst/>
+          </a:prstGeom>
+        </p:spPr>
+      </p:pic>
+      <p:sp>
+        <p:nvSpPr>
+          <p:cNvPr id="6" name="Text 3"/>
           <p:cNvSpPr txBox="1"/>
           <p:nvPr/>
         </p:nvSpPr>
         <p:spPr>
           <a:xfrm>
-            <a:off x="822960" y="1645920"/>
-            <a:ext cx="3017520" cy="457200"/>
+            <a:off x="1508760" y="1627632"/>
+            <a:ext cx="2377440" cy="530352"/>
           </a:xfrm>
           <a:prstGeom prst="rect">
             <a:avLst/>
@@ -20772,7 +20993,7 @@
           <a:ln/>
         </p:spPr>
         <p:txBody>
-          <a:bodyPr wrap="square" lIns="0" tIns="0" rIns="0" bIns="0" rtlCol="0" anchor="t"/>
+          <a:bodyPr wrap="square" lIns="0" tIns="0" rIns="0" bIns="0" rtlCol="0" anchor="ctr"/>
           <a:lstStyle/>
           <a:p>
             <a:pPr indent="0" marL="0">
@@ -20792,14 +21013,14 @@
       </p:sp>
       <p:sp>
         <p:nvSpPr>
-          <p:cNvPr id="5" name="Text 3"/>
+          <p:cNvPr id="7" name="Text 4"/>
           <p:cNvSpPr txBox="1"/>
           <p:nvPr/>
         </p:nvSpPr>
         <p:spPr>
           <a:xfrm>
-            <a:off x="822960" y="2194560"/>
-            <a:ext cx="3017520" cy="1143000"/>
+            <a:off x="822960" y="2286000"/>
+            <a:ext cx="3017520" cy="1097280"/>
           </a:xfrm>
           <a:prstGeom prst="rect">
             <a:avLst/>
@@ -20815,20 +21036,20 @@
               <a:buNone/>
             </a:pPr>
             <a:r>
-              <a:rPr lang="en-US" sz="1500" dirty="0">
+              <a:rPr lang="en-US" sz="1600" dirty="0">
                 <a:solidFill>
                   <a:schemeClr val="tx1"/>
                 </a:solidFill>
               </a:rPr>
               <a:t>19 devices and 40 rules, versus large real rule sets</a:t>
             </a:r>
-            <a:endParaRPr lang="en-US" sz="1500" dirty="0"/>
+            <a:endParaRPr lang="en-US" sz="1600" dirty="0"/>
           </a:p>
         </p:txBody>
       </p:sp>
       <p:sp>
         <p:nvSpPr>
-          <p:cNvPr id="6" name="card71"/>
+          <p:cNvPr id="8" name="card112"/>
           <p:cNvSpPr/>
           <p:nvPr/>
         </p:nvSpPr>
@@ -20862,14 +21083,63 @@
       </p:sp>
       <p:sp>
         <p:nvSpPr>
-          <p:cNvPr id="7" name="Text 5"/>
+          <p:cNvPr id="9" name="iconbg113"/>
+          <p:cNvSpPr/>
+          <p:nvPr/>
+        </p:nvSpPr>
+        <p:spPr>
+          <a:xfrm>
+            <a:off x="4590288" y="1627632"/>
+            <a:ext cx="530352" cy="530352"/>
+          </a:xfrm>
+          <a:prstGeom prst="ellipse">
+            <a:avLst/>
+          </a:prstGeom>
+          <a:solidFill>
+            <a:srgbClr val="C0392B"/>
+          </a:solidFill>
+          <a:ln w="12700">
+            <a:solidFill>
+              <a:srgbClr val="C0392B"/>
+            </a:solidFill>
+            <a:prstDash val="solid"/>
+          </a:ln>
+        </p:spPr>
+      </p:sp>
+      <p:pic>
+        <p:nvPicPr>
+          <p:cNvPr id="10" name="icon114" descr="FaEyeSlash">    </p:cNvPr>
+          <p:cNvPicPr>
+            <a:picLocks noChangeAspect="1"/>
+          </p:cNvPicPr>
+          <p:nvPr/>
+        </p:nvPicPr>
+        <p:blipFill>
+          <a:blip r:embed="rId2"/>
+          <a:stretch>
+            <a:fillRect/>
+          </a:stretch>
+        </p:blipFill>
+        <p:spPr>
+          <a:xfrm>
+            <a:off x="4717572" y="1754916"/>
+            <a:ext cx="275783" cy="275783"/>
+          </a:xfrm>
+          <a:prstGeom prst="rect">
+            <a:avLst/>
+          </a:prstGeom>
+        </p:spPr>
+      </p:pic>
+      <p:sp>
+        <p:nvSpPr>
+          <p:cNvPr id="11" name="Text 7"/>
           <p:cNvSpPr txBox="1"/>
           <p:nvPr/>
         </p:nvSpPr>
         <p:spPr>
           <a:xfrm>
-            <a:off x="4590288" y="1645920"/>
-            <a:ext cx="3017520" cy="457200"/>
+            <a:off x="5276088" y="1627632"/>
+            <a:ext cx="2377440" cy="530352"/>
           </a:xfrm>
           <a:prstGeom prst="rect">
             <a:avLst/>
@@ -20878,7 +21148,7 @@
           <a:ln/>
         </p:spPr>
         <p:txBody>
-          <a:bodyPr wrap="square" lIns="0" tIns="0" rIns="0" bIns="0" rtlCol="0" anchor="t"/>
+          <a:bodyPr wrap="square" lIns="0" tIns="0" rIns="0" bIns="0" rtlCol="0" anchor="ctr"/>
           <a:lstStyle/>
           <a:p>
             <a:pPr indent="0" marL="0">
@@ -20898,14 +21168,14 @@
       </p:sp>
       <p:sp>
         <p:nvSpPr>
-          <p:cNvPr id="8" name="Text 6"/>
+          <p:cNvPr id="12" name="Text 8"/>
           <p:cNvSpPr txBox="1"/>
           <p:nvPr/>
         </p:nvSpPr>
         <p:spPr>
           <a:xfrm>
-            <a:off x="4590288" y="2194560"/>
-            <a:ext cx="3017520" cy="1143000"/>
+            <a:off x="4590288" y="2286000"/>
+            <a:ext cx="3017520" cy="1097280"/>
           </a:xfrm>
           <a:prstGeom prst="rect">
             <a:avLst/>
@@ -20921,20 +21191,20 @@
               <a:buNone/>
             </a:pPr>
             <a:r>
-              <a:rPr lang="en-US" sz="1500" dirty="0">
+              <a:rPr lang="en-US" sz="1600" dirty="0">
                 <a:solidFill>
                   <a:schemeClr val="tx1"/>
                 </a:solidFill>
               </a:rPr>
               <a:t>Screenshots for 17 tests in Stage 0, 4 in Stage 1, 14 in Stage 2, 7 in Stage 3</a:t>
             </a:r>
-            <a:endParaRPr lang="en-US" sz="1500" dirty="0"/>
+            <a:endParaRPr lang="en-US" sz="1600" dirty="0"/>
           </a:p>
         </p:txBody>
       </p:sp>
       <p:sp>
         <p:nvSpPr>
-          <p:cNvPr id="9" name="card72"/>
+          <p:cNvPr id="13" name="card115"/>
           <p:cNvSpPr/>
           <p:nvPr/>
         </p:nvSpPr>
@@ -20968,14 +21238,63 @@
       </p:sp>
       <p:sp>
         <p:nvSpPr>
-          <p:cNvPr id="10" name="Text 8"/>
+          <p:cNvPr id="14" name="iconbg116"/>
+          <p:cNvSpPr/>
+          <p:nvPr/>
+        </p:nvSpPr>
+        <p:spPr>
+          <a:xfrm>
+            <a:off x="8357616" y="1627632"/>
+            <a:ext cx="530352" cy="530352"/>
+          </a:xfrm>
+          <a:prstGeom prst="ellipse">
+            <a:avLst/>
+          </a:prstGeom>
+          <a:solidFill>
+            <a:srgbClr val="C0392B"/>
+          </a:solidFill>
+          <a:ln w="12700">
+            <a:solidFill>
+              <a:srgbClr val="C0392B"/>
+            </a:solidFill>
+            <a:prstDash val="solid"/>
+          </a:ln>
+        </p:spPr>
+      </p:sp>
+      <p:pic>
+        <p:nvPicPr>
+          <p:cNvPr id="15" name="icon117" descr="FaIdCard">    </p:cNvPr>
+          <p:cNvPicPr>
+            <a:picLocks noChangeAspect="1"/>
+          </p:cNvPicPr>
+          <p:nvPr/>
+        </p:nvPicPr>
+        <p:blipFill>
+          <a:blip r:embed="rId3"/>
+          <a:stretch>
+            <a:fillRect/>
+          </a:stretch>
+        </p:blipFill>
+        <p:spPr>
+          <a:xfrm>
+            <a:off x="8484900" y="1754916"/>
+            <a:ext cx="275783" cy="275783"/>
+          </a:xfrm>
+          <a:prstGeom prst="rect">
+            <a:avLst/>
+          </a:prstGeom>
+        </p:spPr>
+      </p:pic>
+      <p:sp>
+        <p:nvSpPr>
+          <p:cNvPr id="16" name="Text 11"/>
           <p:cNvSpPr txBox="1"/>
           <p:nvPr/>
         </p:nvSpPr>
         <p:spPr>
           <a:xfrm>
-            <a:off x="8357616" y="1645920"/>
-            <a:ext cx="3017520" cy="457200"/>
+            <a:off x="9043416" y="1627632"/>
+            <a:ext cx="2377440" cy="530352"/>
           </a:xfrm>
           <a:prstGeom prst="rect">
             <a:avLst/>
@@ -20984,7 +21303,7 @@
           <a:ln/>
         </p:spPr>
         <p:txBody>
-          <a:bodyPr wrap="square" lIns="0" tIns="0" rIns="0" bIns="0" rtlCol="0" anchor="t"/>
+          <a:bodyPr wrap="square" lIns="0" tIns="0" rIns="0" bIns="0" rtlCol="0" anchor="ctr"/>
           <a:lstStyle/>
           <a:p>
             <a:pPr indent="0" marL="0">
@@ -21004,14 +21323,14 @@
       </p:sp>
       <p:sp>
         <p:nvSpPr>
-          <p:cNvPr id="11" name="Text 9"/>
+          <p:cNvPr id="17" name="Text 12"/>
           <p:cNvSpPr txBox="1"/>
           <p:nvPr/>
         </p:nvSpPr>
         <p:spPr>
           <a:xfrm>
-            <a:off x="8357616" y="2194560"/>
-            <a:ext cx="3017520" cy="1143000"/>
+            <a:off x="8357616" y="2286000"/>
+            <a:ext cx="3017520" cy="1097280"/>
           </a:xfrm>
           <a:prstGeom prst="rect">
             <a:avLst/>
@@ -21027,20 +21346,20 @@
               <a:buNone/>
             </a:pPr>
             <a:r>
-              <a:rPr lang="en-US" sz="1500" dirty="0">
+              <a:rPr lang="en-US" sz="1600" dirty="0">
                 <a:solidFill>
                   <a:schemeClr val="tx1"/>
                 </a:solidFill>
               </a:rPr>
               <a:t>ACLs see addresses and ports, never user or device identity</a:t>
             </a:r>
-            <a:endParaRPr lang="en-US" sz="1500" dirty="0"/>
+            <a:endParaRPr lang="en-US" sz="1600" dirty="0"/>
           </a:p>
         </p:txBody>
       </p:sp>
       <p:sp>
         <p:nvSpPr>
-          <p:cNvPr id="12" name="card73"/>
+          <p:cNvPr id="18" name="card118"/>
           <p:cNvSpPr/>
           <p:nvPr/>
         </p:nvSpPr>
@@ -21074,14 +21393,63 @@
       </p:sp>
       <p:sp>
         <p:nvSpPr>
-          <p:cNvPr id="13" name="Text 11"/>
+          <p:cNvPr id="19" name="iconbg119"/>
+          <p:cNvSpPr/>
+          <p:nvPr/>
+        </p:nvSpPr>
+        <p:spPr>
+          <a:xfrm>
+            <a:off x="822960" y="4005072"/>
+            <a:ext cx="530352" cy="530352"/>
+          </a:xfrm>
+          <a:prstGeom prst="ellipse">
+            <a:avLst/>
+          </a:prstGeom>
+          <a:solidFill>
+            <a:srgbClr val="C0392B"/>
+          </a:solidFill>
+          <a:ln w="12700">
+            <a:solidFill>
+              <a:srgbClr val="C0392B"/>
+            </a:solidFill>
+            <a:prstDash val="solid"/>
+          </a:ln>
+        </p:spPr>
+      </p:sp>
+      <p:pic>
+        <p:nvPicPr>
+          <p:cNvPr id="20" name="icon120" descr="FaDesktop">    </p:cNvPr>
+          <p:cNvPicPr>
+            <a:picLocks noChangeAspect="1"/>
+          </p:cNvPicPr>
+          <p:nvPr/>
+        </p:nvPicPr>
+        <p:blipFill>
+          <a:blip r:embed="rId4"/>
+          <a:stretch>
+            <a:fillRect/>
+          </a:stretch>
+        </p:blipFill>
+        <p:spPr>
+          <a:xfrm>
+            <a:off x="950244" y="4132356"/>
+            <a:ext cx="275783" cy="275783"/>
+          </a:xfrm>
+          <a:prstGeom prst="rect">
+            <a:avLst/>
+          </a:prstGeom>
+        </p:spPr>
+      </p:pic>
+      <p:sp>
+        <p:nvSpPr>
+          <p:cNvPr id="21" name="Text 15"/>
           <p:cNvSpPr txBox="1"/>
           <p:nvPr/>
         </p:nvSpPr>
         <p:spPr>
           <a:xfrm>
-            <a:off x="822960" y="4023360"/>
-            <a:ext cx="3017520" cy="457200"/>
+            <a:off x="1508760" y="4005072"/>
+            <a:ext cx="2377440" cy="530352"/>
           </a:xfrm>
           <a:prstGeom prst="rect">
             <a:avLst/>
@@ -21090,7 +21458,7 @@
           <a:ln/>
         </p:spPr>
         <p:txBody>
-          <a:bodyPr wrap="square" lIns="0" tIns="0" rIns="0" bIns="0" rtlCol="0" anchor="t"/>
+          <a:bodyPr wrap="square" lIns="0" tIns="0" rIns="0" bIns="0" rtlCol="0" anchor="ctr"/>
           <a:lstStyle/>
           <a:p>
             <a:pPr indent="0" marL="0">
@@ -21110,14 +21478,14 @@
       </p:sp>
       <p:sp>
         <p:nvSpPr>
-          <p:cNvPr id="14" name="Text 12"/>
+          <p:cNvPr id="22" name="Text 16"/>
           <p:cNvSpPr txBox="1"/>
           <p:nvPr/>
         </p:nvSpPr>
         <p:spPr>
           <a:xfrm>
-            <a:off x="822960" y="4572000"/>
-            <a:ext cx="3017520" cy="1143000"/>
+            <a:off x="822960" y="4663440"/>
+            <a:ext cx="3017520" cy="1097280"/>
           </a:xfrm>
           <a:prstGeom prst="rect">
             <a:avLst/>
@@ -21133,20 +21501,20 @@
               <a:buNone/>
             </a:pPr>
             <a:r>
-              <a:rPr lang="en-US" sz="1500" dirty="0">
+              <a:rPr lang="en-US" sz="1600" dirty="0">
                 <a:solidFill>
                   <a:schemeClr val="tx1"/>
                 </a:solidFill>
               </a:rPr>
               <a:t>FTP stands in for a database; no NAT, logging or attack traffic</a:t>
             </a:r>
-            <a:endParaRPr lang="en-US" sz="1500" dirty="0"/>
+            <a:endParaRPr lang="en-US" sz="1600" dirty="0"/>
           </a:p>
         </p:txBody>
       </p:sp>
       <p:sp>
         <p:nvSpPr>
-          <p:cNvPr id="15" name="card74"/>
+          <p:cNvPr id="23" name="card121"/>
           <p:cNvSpPr/>
           <p:nvPr/>
         </p:nvSpPr>
@@ -21180,14 +21548,63 @@
       </p:sp>
       <p:sp>
         <p:nvSpPr>
-          <p:cNvPr id="16" name="Text 14"/>
+          <p:cNvPr id="24" name="iconbg122"/>
+          <p:cNvSpPr/>
+          <p:nvPr/>
+        </p:nvSpPr>
+        <p:spPr>
+          <a:xfrm>
+            <a:off x="4590288" y="4005072"/>
+            <a:ext cx="530352" cy="530352"/>
+          </a:xfrm>
+          <a:prstGeom prst="ellipse">
+            <a:avLst/>
+          </a:prstGeom>
+          <a:solidFill>
+            <a:srgbClr val="C0392B"/>
+          </a:solidFill>
+          <a:ln w="12700">
+            <a:solidFill>
+              <a:srgbClr val="C0392B"/>
+            </a:solidFill>
+            <a:prstDash val="solid"/>
+          </a:ln>
+        </p:spPr>
+      </p:sp>
+      <p:pic>
+        <p:nvPicPr>
+          <p:cNvPr id="25" name="icon123" descr="FaBan">    </p:cNvPr>
+          <p:cNvPicPr>
+            <a:picLocks noChangeAspect="1"/>
+          </p:cNvPicPr>
+          <p:nvPr/>
+        </p:nvPicPr>
+        <p:blipFill>
+          <a:blip r:embed="rId5"/>
+          <a:stretch>
+            <a:fillRect/>
+          </a:stretch>
+        </p:blipFill>
+        <p:spPr>
+          <a:xfrm>
+            <a:off x="4717572" y="4132356"/>
+            <a:ext cx="275783" cy="275783"/>
+          </a:xfrm>
+          <a:prstGeom prst="rect">
+            <a:avLst/>
+          </a:prstGeom>
+        </p:spPr>
+      </p:pic>
+      <p:sp>
+        <p:nvSpPr>
+          <p:cNvPr id="26" name="Text 19"/>
           <p:cNvSpPr txBox="1"/>
           <p:nvPr/>
         </p:nvSpPr>
         <p:spPr>
           <a:xfrm>
-            <a:off x="4590288" y="4023360"/>
-            <a:ext cx="3017520" cy="457200"/>
+            <a:off x="5276088" y="4005072"/>
+            <a:ext cx="2377440" cy="530352"/>
           </a:xfrm>
           <a:prstGeom prst="rect">
             <a:avLst/>
@@ -21196,7 +21613,7 @@
           <a:ln/>
         </p:spPr>
         <p:txBody>
-          <a:bodyPr wrap="square" lIns="0" tIns="0" rIns="0" bIns="0" rtlCol="0" anchor="t"/>
+          <a:bodyPr wrap="square" lIns="0" tIns="0" rIns="0" bIns="0" rtlCol="0" anchor="ctr"/>
           <a:lstStyle/>
           <a:p>
             <a:pPr indent="0" marL="0">
@@ -21216,14 +21633,14 @@
       </p:sp>
       <p:sp>
         <p:nvSpPr>
-          <p:cNvPr id="17" name="Text 15"/>
+          <p:cNvPr id="27" name="Text 20"/>
           <p:cNvSpPr txBox="1"/>
           <p:nvPr/>
         </p:nvSpPr>
         <p:spPr>
           <a:xfrm>
-            <a:off x="4590288" y="4572000"/>
-            <a:ext cx="3017520" cy="1143000"/>
+            <a:off x="4590288" y="4663440"/>
+            <a:ext cx="3017520" cy="1097280"/>
           </a:xfrm>
           <a:prstGeom prst="rect">
             <a:avLst/>
@@ -21239,20 +21656,20 @@
               <a:buNone/>
             </a:pPr>
             <a:r>
-              <a:rPr lang="en-US" sz="1500" dirty="0">
+              <a:rPr lang="en-US" sz="1600" dirty="0">
                 <a:solidFill>
                   <a:schemeClr val="tx1"/>
                 </a:solidFill>
               </a:rPr>
               <a:t>Misconfiguration experiments M1 and M2; zero-hit and line-change metrics</a:t>
             </a:r>
-            <a:endParaRPr lang="en-US" sz="1500" dirty="0"/>
+            <a:endParaRPr lang="en-US" sz="1600" dirty="0"/>
           </a:p>
         </p:txBody>
       </p:sp>
       <p:sp>
         <p:nvSpPr>
-          <p:cNvPr id="18" name="card75"/>
+          <p:cNvPr id="28" name="card124"/>
           <p:cNvSpPr/>
           <p:nvPr/>
         </p:nvSpPr>
@@ -21286,14 +21703,63 @@
       </p:sp>
       <p:sp>
         <p:nvSpPr>
-          <p:cNvPr id="19" name="Text 17"/>
+          <p:cNvPr id="29" name="iconbg125"/>
+          <p:cNvSpPr/>
+          <p:nvPr/>
+        </p:nvSpPr>
+        <p:spPr>
+          <a:xfrm>
+            <a:off x="8357616" y="4005072"/>
+            <a:ext cx="530352" cy="530352"/>
+          </a:xfrm>
+          <a:prstGeom prst="ellipse">
+            <a:avLst/>
+          </a:prstGeom>
+          <a:solidFill>
+            <a:srgbClr val="C0392B"/>
+          </a:solidFill>
+          <a:ln w="12700">
+            <a:solidFill>
+              <a:srgbClr val="C0392B"/>
+            </a:solidFill>
+            <a:prstDash val="solid"/>
+          </a:ln>
+        </p:spPr>
+      </p:sp>
+      <p:pic>
+        <p:nvPicPr>
+          <p:cNvPr id="30" name="icon126" descr="FaExchangeAlt">    </p:cNvPr>
+          <p:cNvPicPr>
+            <a:picLocks noChangeAspect="1"/>
+          </p:cNvPicPr>
+          <p:nvPr/>
+        </p:nvPicPr>
+        <p:blipFill>
+          <a:blip r:embed="rId6"/>
+          <a:stretch>
+            <a:fillRect/>
+          </a:stretch>
+        </p:blipFill>
+        <p:spPr>
+          <a:xfrm>
+            <a:off x="8484900" y="4132356"/>
+            <a:ext cx="275783" cy="275783"/>
+          </a:xfrm>
+          <a:prstGeom prst="rect">
+            <a:avLst/>
+          </a:prstGeom>
+        </p:spPr>
+      </p:pic>
+      <p:sp>
+        <p:nvSpPr>
+          <p:cNvPr id="31" name="Text 23"/>
           <p:cNvSpPr txBox="1"/>
           <p:nvPr/>
         </p:nvSpPr>
         <p:spPr>
           <a:xfrm>
-            <a:off x="8357616" y="4023360"/>
-            <a:ext cx="3017520" cy="457200"/>
+            <a:off x="9043416" y="4005072"/>
+            <a:ext cx="2377440" cy="530352"/>
           </a:xfrm>
           <a:prstGeom prst="rect">
             <a:avLst/>
@@ -21302,7 +21768,7 @@
           <a:ln/>
         </p:spPr>
         <p:txBody>
-          <a:bodyPr wrap="square" lIns="0" tIns="0" rIns="0" bIns="0" rtlCol="0" anchor="t"/>
+          <a:bodyPr wrap="square" lIns="0" tIns="0" rIns="0" bIns="0" rtlCol="0" anchor="ctr"/>
           <a:lstStyle/>
           <a:p>
             <a:pPr indent="0" marL="0">
@@ -21322,14 +21788,14 @@
       </p:sp>
       <p:sp>
         <p:nvSpPr>
-          <p:cNvPr id="20" name="Text 18"/>
+          <p:cNvPr id="32" name="Text 24"/>
           <p:cNvSpPr txBox="1"/>
           <p:nvPr/>
         </p:nvSpPr>
         <p:spPr>
           <a:xfrm>
-            <a:off x="8357616" y="4572000"/>
-            <a:ext cx="3017520" cy="1143000"/>
+            <a:off x="8357616" y="4663440"/>
+            <a:ext cx="3017520" cy="1097280"/>
           </a:xfrm>
           <a:prstGeom prst="rect">
             <a:avLst/>
@@ -21345,14 +21811,14 @@
               <a:buNone/>
             </a:pPr>
             <a:r>
-              <a:rPr lang="en-US" sz="1500" dirty="0">
+              <a:rPr lang="en-US" sz="1600" dirty="0">
                 <a:solidFill>
                   <a:schemeClr val="tx1"/>
                 </a:solidFill>
               </a:rPr>
               <a:t>established accepts any TCP segment with ACK or RST set</a:t>
             </a:r>
-            <a:endParaRPr lang="en-US" sz="1500" dirty="0"/>
+            <a:endParaRPr lang="en-US" sz="1600" dirty="0"/>
           </a:p>
         </p:txBody>
       </p:sp>
@@ -21466,7 +21932,7 @@
       </p:sp>
       <p:sp>
         <p:nvSpPr>
-          <p:cNvPr id="3" name="card76"/>
+          <p:cNvPr id="3" name="card127"/>
           <p:cNvSpPr/>
           <p:nvPr/>
         </p:nvSpPr>
@@ -21500,39 +21966,63 @@
       </p:sp>
       <p:sp>
         <p:nvSpPr>
-          <p:cNvPr id="4" name="fut0"/>
+          <p:cNvPr id="4" name="iconbg128"/>
           <p:cNvSpPr/>
           <p:nvPr/>
         </p:nvSpPr>
         <p:spPr>
           <a:xfrm>
-            <a:off x="822960" y="1645920"/>
-            <a:ext cx="457200" cy="457200"/>
+            <a:off x="822960" y="1618488"/>
+            <a:ext cx="548640" cy="548640"/>
           </a:xfrm>
           <a:prstGeom prst="ellipse">
             <a:avLst/>
           </a:prstGeom>
           <a:solidFill>
-            <a:schemeClr val="accent3"/>
+            <a:srgbClr val="E09F3E"/>
           </a:solidFill>
           <a:ln w="12700">
             <a:solidFill>
-              <a:schemeClr val="accent3"/>
+              <a:srgbClr val="E09F3E"/>
             </a:solidFill>
             <a:prstDash val="solid"/>
           </a:ln>
         </p:spPr>
       </p:sp>
-      <p:sp>
-        <p:nvSpPr>
-          <p:cNvPr id="5" name="Text 3"/>
+      <p:pic>
+        <p:nvPicPr>
+          <p:cNvPr id="5" name="icon129" descr="FaWrench">    </p:cNvPr>
+          <p:cNvPicPr>
+            <a:picLocks noChangeAspect="1"/>
+          </p:cNvPicPr>
+          <p:nvPr/>
+        </p:nvPicPr>
+        <p:blipFill>
+          <a:blip r:embed="rId1"/>
+          <a:stretch>
+            <a:fillRect/>
+          </a:stretch>
+        </p:blipFill>
+        <p:spPr>
+          <a:xfrm>
+            <a:off x="954634" y="1750162"/>
+            <a:ext cx="285293" cy="285293"/>
+          </a:xfrm>
+          <a:prstGeom prst="rect">
+            <a:avLst/>
+          </a:prstGeom>
+        </p:spPr>
+      </p:pic>
+      <p:sp>
+        <p:nvSpPr>
+          <p:cNvPr id="6" name="Text 3"/>
           <p:cNvSpPr txBox="1"/>
           <p:nvPr/>
         </p:nvSpPr>
         <p:spPr>
           <a:xfrm>
-            <a:off x="1463040" y="1645920"/>
-            <a:ext cx="4297680" cy="457200"/>
+            <a:off x="1554480" y="1664208"/>
+            <a:ext cx="4206240" cy="457200"/>
           </a:xfrm>
           <a:prstGeom prst="rect">
             <a:avLst/>
@@ -21561,13 +22051,13 @@
       </p:sp>
       <p:sp>
         <p:nvSpPr>
-          <p:cNvPr id="6" name="Text 4"/>
+          <p:cNvPr id="7" name="Text 4"/>
           <p:cNvSpPr txBox="1"/>
           <p:nvPr/>
         </p:nvSpPr>
         <p:spPr>
           <a:xfrm>
-            <a:off x="822960" y="2286000"/>
+            <a:off x="822960" y="2331720"/>
             <a:ext cx="4937760" cy="1051560"/>
           </a:xfrm>
           <a:prstGeom prst="rect">
@@ -21584,20 +22074,20 @@
               <a:buNone/>
             </a:pPr>
             <a:r>
-              <a:rPr lang="en-US" sz="1500" dirty="0">
+              <a:rPr lang="en-US" sz="1600" dirty="0">
                 <a:solidFill>
                   <a:schemeClr val="tx2"/>
                 </a:solidFill>
               </a:rPr>
               <a:t>Add one minimal, correctly ordered data-channel rule, or move the finance service to HTTPS/SFTP, and re-test</a:t>
             </a:r>
-            <a:endParaRPr lang="en-US" sz="1500" dirty="0"/>
+            <a:endParaRPr lang="en-US" sz="1600" dirty="0"/>
           </a:p>
         </p:txBody>
       </p:sp>
       <p:sp>
         <p:nvSpPr>
-          <p:cNvPr id="7" name="card77"/>
+          <p:cNvPr id="8" name="card130"/>
           <p:cNvSpPr/>
           <p:nvPr/>
         </p:nvSpPr>
@@ -21631,39 +22121,63 @@
       </p:sp>
       <p:sp>
         <p:nvSpPr>
-          <p:cNvPr id="8" name="fut1"/>
+          <p:cNvPr id="9" name="iconbg131"/>
           <p:cNvSpPr/>
           <p:nvPr/>
         </p:nvSpPr>
         <p:spPr>
           <a:xfrm>
-            <a:off x="6446520" y="1645920"/>
-            <a:ext cx="457200" cy="457200"/>
+            <a:off x="6446520" y="1618488"/>
+            <a:ext cx="548640" cy="548640"/>
           </a:xfrm>
           <a:prstGeom prst="ellipse">
             <a:avLst/>
           </a:prstGeom>
           <a:solidFill>
-            <a:schemeClr val="accent3"/>
+            <a:srgbClr val="E09F3E"/>
           </a:solidFill>
           <a:ln w="12700">
             <a:solidFill>
-              <a:schemeClr val="accent3"/>
+              <a:srgbClr val="E09F3E"/>
             </a:solidFill>
             <a:prstDash val="solid"/>
           </a:ln>
         </p:spPr>
       </p:sp>
-      <p:sp>
-        <p:nvSpPr>
-          <p:cNvPr id="9" name="Text 7"/>
+      <p:pic>
+        <p:nvPicPr>
+          <p:cNvPr id="10" name="icon132" descr="FaBug">    </p:cNvPr>
+          <p:cNvPicPr>
+            <a:picLocks noChangeAspect="1"/>
+          </p:cNvPicPr>
+          <p:nvPr/>
+        </p:nvPicPr>
+        <p:blipFill>
+          <a:blip r:embed="rId2"/>
+          <a:stretch>
+            <a:fillRect/>
+          </a:stretch>
+        </p:blipFill>
+        <p:spPr>
+          <a:xfrm>
+            <a:off x="6578194" y="1750162"/>
+            <a:ext cx="285293" cy="285293"/>
+          </a:xfrm>
+          <a:prstGeom prst="rect">
+            <a:avLst/>
+          </a:prstGeom>
+        </p:spPr>
+      </p:pic>
+      <p:sp>
+        <p:nvSpPr>
+          <p:cNvPr id="11" name="Text 7"/>
           <p:cNvSpPr txBox="1"/>
           <p:nvPr/>
         </p:nvSpPr>
         <p:spPr>
           <a:xfrm>
-            <a:off x="7086600" y="1645920"/>
-            <a:ext cx="4297680" cy="457200"/>
+            <a:off x="7178040" y="1664208"/>
+            <a:ext cx="4206240" cy="457200"/>
           </a:xfrm>
           <a:prstGeom prst="rect">
             <a:avLst/>
@@ -21692,13 +22206,13 @@
       </p:sp>
       <p:sp>
         <p:nvSpPr>
-          <p:cNvPr id="10" name="Text 8"/>
+          <p:cNvPr id="12" name="Text 8"/>
           <p:cNvSpPr txBox="1"/>
           <p:nvPr/>
         </p:nvSpPr>
         <p:spPr>
           <a:xfrm>
-            <a:off x="6446520" y="2286000"/>
+            <a:off x="6446520" y="2331720"/>
             <a:ext cx="4937760" cy="1051560"/>
           </a:xfrm>
           <a:prstGeom prst="rect">
@@ -21715,20 +22229,20 @@
               <a:buNone/>
             </a:pPr>
             <a:r>
-              <a:rPr lang="en-US" sz="1500" dirty="0">
+              <a:rPr lang="en-US" sz="1600" dirty="0">
                 <a:solidFill>
                   <a:schemeClr val="tx2"/>
                 </a:solidFill>
               </a:rPr>
               <a:t>M1 (shadowed rule) and M2 (missing DNS rule) on copies of Stages 2 and 3</a:t>
             </a:r>
-            <a:endParaRPr lang="en-US" sz="1500" dirty="0"/>
+            <a:endParaRPr lang="en-US" sz="1600" dirty="0"/>
           </a:p>
         </p:txBody>
       </p:sp>
       <p:sp>
         <p:nvSpPr>
-          <p:cNvPr id="11" name="card78"/>
+          <p:cNvPr id="13" name="card133"/>
           <p:cNvSpPr/>
           <p:nvPr/>
         </p:nvSpPr>
@@ -21762,39 +22276,63 @@
       </p:sp>
       <p:sp>
         <p:nvSpPr>
-          <p:cNvPr id="12" name="fut2"/>
+          <p:cNvPr id="14" name="iconbg134"/>
           <p:cNvSpPr/>
           <p:nvPr/>
         </p:nvSpPr>
         <p:spPr>
           <a:xfrm>
-            <a:off x="822960" y="3977640"/>
-            <a:ext cx="457200" cy="457200"/>
+            <a:off x="822960" y="3950208"/>
+            <a:ext cx="548640" cy="548640"/>
           </a:xfrm>
           <a:prstGeom prst="ellipse">
             <a:avLst/>
           </a:prstGeom>
           <a:solidFill>
-            <a:schemeClr val="accent3"/>
+            <a:srgbClr val="E09F3E"/>
           </a:solidFill>
           <a:ln w="12700">
             <a:solidFill>
-              <a:schemeClr val="accent3"/>
+              <a:srgbClr val="E09F3E"/>
             </a:solidFill>
             <a:prstDash val="solid"/>
           </a:ln>
         </p:spPr>
       </p:sp>
-      <p:sp>
-        <p:nvSpPr>
-          <p:cNvPr id="13" name="Text 11"/>
+      <p:pic>
+        <p:nvPicPr>
+          <p:cNvPr id="15" name="icon135" descr="FaCamera">    </p:cNvPr>
+          <p:cNvPicPr>
+            <a:picLocks noChangeAspect="1"/>
+          </p:cNvPicPr>
+          <p:nvPr/>
+        </p:nvPicPr>
+        <p:blipFill>
+          <a:blip r:embed="rId3"/>
+          <a:stretch>
+            <a:fillRect/>
+          </a:stretch>
+        </p:blipFill>
+        <p:spPr>
+          <a:xfrm>
+            <a:off x="954634" y="4081882"/>
+            <a:ext cx="285293" cy="285293"/>
+          </a:xfrm>
+          <a:prstGeom prst="rect">
+            <a:avLst/>
+          </a:prstGeom>
+        </p:spPr>
+      </p:pic>
+      <p:sp>
+        <p:nvSpPr>
+          <p:cNvPr id="16" name="Text 11"/>
           <p:cNvSpPr txBox="1"/>
           <p:nvPr/>
         </p:nvSpPr>
         <p:spPr>
           <a:xfrm>
-            <a:off x="1463040" y="3977640"/>
-            <a:ext cx="4297680" cy="457200"/>
+            <a:off x="1554480" y="3995928"/>
+            <a:ext cx="4206240" cy="457200"/>
           </a:xfrm>
           <a:prstGeom prst="rect">
             <a:avLst/>
@@ -21823,13 +22361,13 @@
       </p:sp>
       <p:sp>
         <p:nvSpPr>
-          <p:cNvPr id="14" name="Text 12"/>
+          <p:cNvPr id="17" name="Text 12"/>
           <p:cNvSpPr txBox="1"/>
           <p:nvPr/>
         </p:nvSpPr>
         <p:spPr>
           <a:xfrm>
-            <a:off x="822960" y="4617720"/>
+            <a:off x="822960" y="4663440"/>
             <a:ext cx="4937760" cy="1051560"/>
           </a:xfrm>
           <a:prstGeom prst="rect">
@@ -21846,20 +22384,20 @@
               <a:buNone/>
             </a:pPr>
             <a:r>
-              <a:rPr lang="en-US" sz="1500" dirty="0">
+              <a:rPr lang="en-US" sz="1600" dirty="0">
                 <a:solidFill>
                   <a:schemeClr val="tx2"/>
                 </a:solidFill>
               </a:rPr>
               <a:t>Capture every test and ACL counter in every stage; save running configs to measure lines changed</a:t>
             </a:r>
-            <a:endParaRPr lang="en-US" sz="1500" dirty="0"/>
+            <a:endParaRPr lang="en-US" sz="1600" dirty="0"/>
           </a:p>
         </p:txBody>
       </p:sp>
       <p:sp>
         <p:nvSpPr>
-          <p:cNvPr id="15" name="card79"/>
+          <p:cNvPr id="18" name="card136"/>
           <p:cNvSpPr/>
           <p:nvPr/>
         </p:nvSpPr>
@@ -21893,39 +22431,63 @@
       </p:sp>
       <p:sp>
         <p:nvSpPr>
-          <p:cNvPr id="16" name="fut3"/>
+          <p:cNvPr id="19" name="iconbg137"/>
           <p:cNvSpPr/>
           <p:nvPr/>
         </p:nvSpPr>
         <p:spPr>
           <a:xfrm>
-            <a:off x="6446520" y="3977640"/>
-            <a:ext cx="457200" cy="457200"/>
+            <a:off x="6446520" y="3950208"/>
+            <a:ext cx="548640" cy="548640"/>
           </a:xfrm>
           <a:prstGeom prst="ellipse">
             <a:avLst/>
           </a:prstGeom>
           <a:solidFill>
-            <a:schemeClr val="accent3"/>
+            <a:srgbClr val="E09F3E"/>
           </a:solidFill>
           <a:ln w="12700">
             <a:solidFill>
-              <a:schemeClr val="accent3"/>
+              <a:srgbClr val="E09F3E"/>
             </a:solidFill>
             <a:prstDash val="solid"/>
           </a:ln>
         </p:spPr>
       </p:sp>
-      <p:sp>
-        <p:nvSpPr>
-          <p:cNvPr id="17" name="Text 15"/>
+      <p:pic>
+        <p:nvPicPr>
+          <p:cNvPr id="20" name="icon138" descr="FaFingerprint">    </p:cNvPr>
+          <p:cNvPicPr>
+            <a:picLocks noChangeAspect="1"/>
+          </p:cNvPicPr>
+          <p:nvPr/>
+        </p:nvPicPr>
+        <p:blipFill>
+          <a:blip r:embed="rId4"/>
+          <a:stretch>
+            <a:fillRect/>
+          </a:stretch>
+        </p:blipFill>
+        <p:spPr>
+          <a:xfrm>
+            <a:off x="6578194" y="4081882"/>
+            <a:ext cx="285293" cy="285293"/>
+          </a:xfrm>
+          <a:prstGeom prst="rect">
+            <a:avLst/>
+          </a:prstGeom>
+        </p:spPr>
+      </p:pic>
+      <p:sp>
+        <p:nvSpPr>
+          <p:cNvPr id="21" name="Text 15"/>
           <p:cNvSpPr txBox="1"/>
           <p:nvPr/>
         </p:nvSpPr>
         <p:spPr>
           <a:xfrm>
-            <a:off x="7086600" y="3977640"/>
-            <a:ext cx="4297680" cy="457200"/>
+            <a:off x="7178040" y="3995928"/>
+            <a:ext cx="4206240" cy="457200"/>
           </a:xfrm>
           <a:prstGeom prst="rect">
             <a:avLst/>
@@ -21954,13 +22516,13 @@
       </p:sp>
       <p:sp>
         <p:nvSpPr>
-          <p:cNvPr id="18" name="Text 16"/>
+          <p:cNvPr id="22" name="Text 16"/>
           <p:cNvSpPr txBox="1"/>
           <p:nvPr/>
         </p:nvSpPr>
         <p:spPr>
           <a:xfrm>
-            <a:off x="6446520" y="4617720"/>
+            <a:off x="6446520" y="4663440"/>
             <a:ext cx="4937760" cy="1051560"/>
           </a:xfrm>
           <a:prstGeom prst="rect">
@@ -21977,14 +22539,14 @@
               <a:buNone/>
             </a:pPr>
             <a:r>
-              <a:rPr lang="en-US" sz="1500" dirty="0">
+              <a:rPr lang="en-US" sz="1600" dirty="0">
                 <a:solidFill>
                   <a:schemeClr val="tx2"/>
                 </a:solidFill>
               </a:rPr>
               <a:t>Compare with a stateful firewall and with identity-based microsegmentation (Zero Trust)</a:t>
             </a:r>
-            <a:endParaRPr lang="en-US" sz="1500" dirty="0"/>
+            <a:endParaRPr lang="en-US" sz="1600" dirty="0"/>
           </a:p>
         </p:txBody>
       </p:sp>
@@ -22098,14 +22660,14 @@
       </p:sp>
       <p:sp>
         <p:nvSpPr>
-          <p:cNvPr id="3" name="cdot0"/>
+          <p:cNvPr id="3" name="iconbg139"/>
           <p:cNvSpPr/>
           <p:nvPr/>
         </p:nvSpPr>
         <p:spPr>
           <a:xfrm>
-            <a:off x="640080" y="1737360"/>
-            <a:ext cx="548640" cy="548640"/>
+            <a:off x="640080" y="1600200"/>
+            <a:ext cx="777240" cy="777240"/>
           </a:xfrm>
           <a:prstGeom prst="ellipse">
             <a:avLst/>
@@ -22121,9 +22683,33 @@
           </a:ln>
         </p:spPr>
       </p:sp>
-      <p:sp>
-        <p:nvSpPr>
-          <p:cNvPr id="4" name="Text 2"/>
+      <p:pic>
+        <p:nvPicPr>
+          <p:cNvPr id="4" name="icon140" descr="FaShieldAlt">    </p:cNvPr>
+          <p:cNvPicPr>
+            <a:picLocks noChangeAspect="1"/>
+          </p:cNvPicPr>
+          <p:nvPr/>
+        </p:nvPicPr>
+        <p:blipFill>
+          <a:blip r:embed="rId1"/>
+          <a:stretch>
+            <a:fillRect/>
+          </a:stretch>
+        </p:blipFill>
+        <p:spPr>
+          <a:xfrm>
+            <a:off x="826618" y="1786738"/>
+            <a:ext cx="404165" cy="404165"/>
+          </a:xfrm>
+          <a:prstGeom prst="rect">
+            <a:avLst/>
+          </a:prstGeom>
+        </p:spPr>
+      </p:pic>
+      <p:sp>
+        <p:nvSpPr>
+          <p:cNvPr id="5" name="Text 2"/>
           <p:cNvSpPr txBox="1"/>
           <p:nvPr/>
         </p:nvSpPr>
@@ -22162,7 +22748,7 @@
       </p:sp>
       <p:sp>
         <p:nvSpPr>
-          <p:cNvPr id="5" name="Text 3"/>
+          <p:cNvPr id="6" name="Text 3"/>
           <p:cNvSpPr txBox="1"/>
           <p:nvPr/>
         </p:nvSpPr>
@@ -22198,14 +22784,14 @@
       </p:sp>
       <p:sp>
         <p:nvSpPr>
-          <p:cNvPr id="6" name="cdot1"/>
+          <p:cNvPr id="7" name="iconbg141"/>
           <p:cNvSpPr/>
           <p:nvPr/>
         </p:nvSpPr>
         <p:spPr>
           <a:xfrm>
-            <a:off x="4389120" y="1737360"/>
-            <a:ext cx="548640" cy="548640"/>
+            <a:off x="4389120" y="1600200"/>
+            <a:ext cx="777240" cy="777240"/>
           </a:xfrm>
           <a:prstGeom prst="ellipse">
             <a:avLst/>
@@ -22221,9 +22807,33 @@
           </a:ln>
         </p:spPr>
       </p:sp>
-      <p:sp>
-        <p:nvSpPr>
-          <p:cNvPr id="7" name="Text 5"/>
+      <p:pic>
+        <p:nvPicPr>
+          <p:cNvPr id="8" name="icon142" descr="FaChartLine">    </p:cNvPr>
+          <p:cNvPicPr>
+            <a:picLocks noChangeAspect="1"/>
+          </p:cNvPicPr>
+          <p:nvPr/>
+        </p:nvPicPr>
+        <p:blipFill>
+          <a:blip r:embed="rId2"/>
+          <a:stretch>
+            <a:fillRect/>
+          </a:stretch>
+        </p:blipFill>
+        <p:spPr>
+          <a:xfrm>
+            <a:off x="4575658" y="1786738"/>
+            <a:ext cx="404165" cy="404165"/>
+          </a:xfrm>
+          <a:prstGeom prst="rect">
+            <a:avLst/>
+          </a:prstGeom>
+        </p:spPr>
+      </p:pic>
+      <p:sp>
+        <p:nvSpPr>
+          <p:cNvPr id="9" name="Text 5"/>
           <p:cNvSpPr txBox="1"/>
           <p:nvPr/>
         </p:nvSpPr>
@@ -22262,7 +22872,7 @@
       </p:sp>
       <p:sp>
         <p:nvSpPr>
-          <p:cNvPr id="8" name="Text 6"/>
+          <p:cNvPr id="10" name="Text 6"/>
           <p:cNvSpPr txBox="1"/>
           <p:nvPr/>
         </p:nvSpPr>
@@ -22298,14 +22908,14 @@
       </p:sp>
       <p:sp>
         <p:nvSpPr>
-          <p:cNvPr id="9" name="cdot2"/>
+          <p:cNvPr id="11" name="iconbg143"/>
           <p:cNvSpPr/>
           <p:nvPr/>
         </p:nvSpPr>
         <p:spPr>
           <a:xfrm>
-            <a:off x="8138160" y="1737360"/>
-            <a:ext cx="548640" cy="548640"/>
+            <a:off x="8138160" y="1600200"/>
+            <a:ext cx="777240" cy="777240"/>
           </a:xfrm>
           <a:prstGeom prst="ellipse">
             <a:avLst/>
@@ -22321,9 +22931,33 @@
           </a:ln>
         </p:spPr>
       </p:sp>
-      <p:sp>
-        <p:nvSpPr>
-          <p:cNvPr id="10" name="Text 8"/>
+      <p:pic>
+        <p:nvPicPr>
+          <p:cNvPr id="12" name="icon144" descr="FaUserCog">    </p:cNvPr>
+          <p:cNvPicPr>
+            <a:picLocks noChangeAspect="1"/>
+          </p:cNvPicPr>
+          <p:nvPr/>
+        </p:nvPicPr>
+        <p:blipFill>
+          <a:blip r:embed="rId3"/>
+          <a:stretch>
+            <a:fillRect/>
+          </a:stretch>
+        </p:blipFill>
+        <p:spPr>
+          <a:xfrm>
+            <a:off x="8324698" y="1786738"/>
+            <a:ext cx="404165" cy="404165"/>
+          </a:xfrm>
+          <a:prstGeom prst="rect">
+            <a:avLst/>
+          </a:prstGeom>
+        </p:spPr>
+      </p:pic>
+      <p:sp>
+        <p:nvSpPr>
+          <p:cNvPr id="13" name="Text 8"/>
           <p:cNvSpPr txBox="1"/>
           <p:nvPr/>
         </p:nvSpPr>
@@ -22362,7 +22996,7 @@
       </p:sp>
       <p:sp>
         <p:nvSpPr>
-          <p:cNvPr id="11" name="Text 9"/>
+          <p:cNvPr id="14" name="Text 9"/>
           <p:cNvSpPr txBox="1"/>
           <p:nvPr/>
         </p:nvSpPr>
@@ -22398,7 +23032,7 @@
       </p:sp>
       <p:sp>
         <p:nvSpPr>
-          <p:cNvPr id="12" name="Text 10"/>
+          <p:cNvPr id="15" name="Text 10"/>
           <p:cNvSpPr txBox="1"/>
           <p:nvPr/>
         </p:nvSpPr>
@@ -22437,7 +23071,7 @@
       </p:sp>
       <p:sp>
         <p:nvSpPr>
-          <p:cNvPr id="13" name="Text 11"/>
+          <p:cNvPr id="16" name="Text 11"/>
           <p:cNvSpPr txBox="1"/>
           <p:nvPr/>
         </p:nvSpPr>
@@ -22917,7 +23551,7 @@
       </p:sp>
       <p:sp>
         <p:nvSpPr>
-          <p:cNvPr id="3" name="card7"/>
+          <p:cNvPr id="3" name="card8"/>
           <p:cNvSpPr/>
           <p:nvPr/>
         </p:nvSpPr>
@@ -22951,14 +23585,63 @@
       </p:sp>
       <p:sp>
         <p:nvSpPr>
-          <p:cNvPr id="4" name="Text 2"/>
+          <p:cNvPr id="4" name="iconbg9"/>
+          <p:cNvSpPr/>
+          <p:nvPr/>
+        </p:nvSpPr>
+        <p:spPr>
+          <a:xfrm>
+            <a:off x="868680" y="1691640"/>
+            <a:ext cx="685800" cy="685800"/>
+          </a:xfrm>
+          <a:prstGeom prst="ellipse">
+            <a:avLst/>
+          </a:prstGeom>
+          <a:solidFill>
+            <a:srgbClr val="C0392B"/>
+          </a:solidFill>
+          <a:ln w="12700">
+            <a:solidFill>
+              <a:srgbClr val="C0392B"/>
+            </a:solidFill>
+            <a:prstDash val="solid"/>
+          </a:ln>
+        </p:spPr>
+      </p:sp>
+      <p:pic>
+        <p:nvPicPr>
+          <p:cNvPr id="5" name="icon10" descr="FaLockOpen">    </p:cNvPr>
+          <p:cNvPicPr>
+            <a:picLocks noChangeAspect="1"/>
+          </p:cNvPicPr>
+          <p:nvPr/>
+        </p:nvPicPr>
+        <p:blipFill>
+          <a:blip r:embed="rId1"/>
+          <a:stretch>
+            <a:fillRect/>
+          </a:stretch>
+        </p:blipFill>
+        <p:spPr>
+          <a:xfrm>
+            <a:off x="1033272" y="1856232"/>
+            <a:ext cx="356616" cy="356616"/>
+          </a:xfrm>
+          <a:prstGeom prst="rect">
+            <a:avLst/>
+          </a:prstGeom>
+        </p:spPr>
+      </p:pic>
+      <p:sp>
+        <p:nvSpPr>
+          <p:cNvPr id="6" name="Text 3"/>
           <p:cNvSpPr txBox="1"/>
           <p:nvPr/>
         </p:nvSpPr>
         <p:spPr>
           <a:xfrm>
-            <a:off x="868680" y="1645920"/>
-            <a:ext cx="4846320" cy="3931920"/>
+            <a:off x="1737360" y="1691640"/>
+            <a:ext cx="4114800" cy="685800"/>
           </a:xfrm>
           <a:prstGeom prst="rect">
             <a:avLst/>
@@ -22967,7 +23650,7 @@
           <a:ln/>
         </p:spPr>
         <p:txBody>
-          <a:bodyPr wrap="square" lIns="0" tIns="0" rIns="0" bIns="0" rtlCol="0" anchor="t"/>
+          <a:bodyPr wrap="square" lIns="0" tIns="0" rIns="0" bIns="0" rtlCol="0" anchor="ctr"/>
           <a:lstStyle/>
           <a:p>
             <a:pPr indent="0" marL="0">
@@ -22981,36 +23664,115 @@
               </a:rPr>
               <a:t>Broad rules are easy, but open</a:t>
             </a:r>
-            <a:endParaRPr lang="en-US" sz="1600" dirty="0"/>
-          </a:p>
+            <a:endParaRPr lang="en-US" sz="2000" dirty="0"/>
+          </a:p>
+        </p:txBody>
+      </p:sp>
+      <p:sp>
+        <p:nvSpPr>
+          <p:cNvPr id="7" name="Text 4"/>
+          <p:cNvSpPr txBox="1"/>
+          <p:nvPr/>
+        </p:nvSpPr>
+        <p:spPr>
+          <a:xfrm>
+            <a:off x="868680" y="2514600"/>
+            <a:ext cx="4937760" cy="1097280"/>
+          </a:xfrm>
+          <a:prstGeom prst="rect">
+            <a:avLst/>
+          </a:prstGeom>
+          <a:noFill/>
+          <a:ln/>
+        </p:spPr>
+        <p:txBody>
+          <a:bodyPr wrap="square" lIns="0" tIns="0" rIns="0" bIns="0" rtlCol="0" anchor="t"/>
+          <a:lstStyle/>
           <a:p>
             <a:pPr indent="0" marL="0">
               <a:buNone/>
             </a:pPr>
             <a:r>
-              <a:rPr lang="en-US" sz="1600" dirty="0">
+              <a:rPr lang="en-US" sz="1700" dirty="0">
                 <a:solidFill>
-                  <a:schemeClr val="tx1"/>
+                  <a:schemeClr val="tx2"/>
                 </a:solidFill>
               </a:rPr>
               <a:t>Most small networks let every department reach every server. One router ACL can close those paths.</a:t>
             </a:r>
-            <a:endParaRPr lang="en-US" sz="1600" dirty="0"/>
-          </a:p>
-          <a:p>
-            <a:pPr indent="0" marL="0">
-              <a:buNone/>
-            </a:pPr>
-            <a:r>
-              <a:rPr lang="en-US" sz="1600" dirty="0">
-                <a:solidFill>
-                  <a:schemeClr val="tx1"/>
-                </a:solidFill>
-              </a:rPr>
-              <a:t> </a:t>
-            </a:r>
-            <a:endParaRPr lang="en-US" sz="1600" dirty="0"/>
-          </a:p>
+            <a:endParaRPr lang="en-US" sz="1700" dirty="0"/>
+          </a:p>
+        </p:txBody>
+      </p:sp>
+      <p:sp>
+        <p:nvSpPr>
+          <p:cNvPr id="8" name="iconbg11"/>
+          <p:cNvSpPr/>
+          <p:nvPr/>
+        </p:nvSpPr>
+        <p:spPr>
+          <a:xfrm>
+            <a:off x="868680" y="3749040"/>
+            <a:ext cx="685800" cy="685800"/>
+          </a:xfrm>
+          <a:prstGeom prst="ellipse">
+            <a:avLst/>
+          </a:prstGeom>
+          <a:solidFill>
+            <a:srgbClr val="1E8E5A"/>
+          </a:solidFill>
+          <a:ln w="12700">
+            <a:solidFill>
+              <a:srgbClr val="1E8E5A"/>
+            </a:solidFill>
+            <a:prstDash val="solid"/>
+          </a:ln>
+        </p:spPr>
+      </p:sp>
+      <p:pic>
+        <p:nvPicPr>
+          <p:cNvPr id="9" name="icon12" descr="FaLock">    </p:cNvPr>
+          <p:cNvPicPr>
+            <a:picLocks noChangeAspect="1"/>
+          </p:cNvPicPr>
+          <p:nvPr/>
+        </p:nvPicPr>
+        <p:blipFill>
+          <a:blip r:embed="rId2"/>
+          <a:stretch>
+            <a:fillRect/>
+          </a:stretch>
+        </p:blipFill>
+        <p:spPr>
+          <a:xfrm>
+            <a:off x="1033272" y="3913632"/>
+            <a:ext cx="356616" cy="356616"/>
+          </a:xfrm>
+          <a:prstGeom prst="rect">
+            <a:avLst/>
+          </a:prstGeom>
+        </p:spPr>
+      </p:pic>
+      <p:sp>
+        <p:nvSpPr>
+          <p:cNvPr id="10" name="Text 6"/>
+          <p:cNvSpPr txBox="1"/>
+          <p:nvPr/>
+        </p:nvSpPr>
+        <p:spPr>
+          <a:xfrm>
+            <a:off x="1737360" y="3749040"/>
+            <a:ext cx="4114800" cy="685800"/>
+          </a:xfrm>
+          <a:prstGeom prst="rect">
+            <a:avLst/>
+          </a:prstGeom>
+          <a:noFill/>
+          <a:ln/>
+        </p:spPr>
+        <p:txBody>
+          <a:bodyPr wrap="square" lIns="0" tIns="0" rIns="0" bIns="0" rtlCol="0" anchor="ctr"/>
+          <a:lstStyle/>
           <a:p>
             <a:pPr indent="0" marL="0">
               <a:buNone/>
@@ -23023,27 +23785,49 @@
               </a:rPr>
               <a:t>Strict rules are safe, but costly</a:t>
             </a:r>
-            <a:endParaRPr lang="en-US" sz="1600" dirty="0"/>
-          </a:p>
+            <a:endParaRPr lang="en-US" sz="2000" dirty="0"/>
+          </a:p>
+        </p:txBody>
+      </p:sp>
+      <p:sp>
+        <p:nvSpPr>
+          <p:cNvPr id="11" name="Text 7"/>
+          <p:cNvSpPr txBox="1"/>
+          <p:nvPr/>
+        </p:nvSpPr>
+        <p:spPr>
+          <a:xfrm>
+            <a:off x="868680" y="4572000"/>
+            <a:ext cx="4937760" cy="1143000"/>
+          </a:xfrm>
+          <a:prstGeom prst="rect">
+            <a:avLst/>
+          </a:prstGeom>
+          <a:noFill/>
+          <a:ln/>
+        </p:spPr>
+        <p:txBody>
+          <a:bodyPr wrap="square" lIns="0" tIns="0" rIns="0" bIns="0" rtlCol="0" anchor="t"/>
+          <a:lstStyle/>
           <a:p>
             <a:pPr indent="0" marL="0">
               <a:buNone/>
             </a:pPr>
             <a:r>
-              <a:rPr lang="en-US" sz="1600" dirty="0">
+              <a:rPr lang="en-US" sz="1700" dirty="0">
                 <a:solidFill>
-                  <a:schemeClr val="tx1"/>
+                  <a:schemeClr val="tx2"/>
                 </a:solidFill>
               </a:rPr>
-              <a:t>Each step towards least privilege adds rules, conditions and dependence on rule order, which the literature links to configuration errors.</a:t>
+              <a:t>Each step towards least privilege adds rules, conditions and rule-order dependence, which the literature links to errors.</a:t>
             </a:r>
-            <a:endParaRPr lang="en-US" sz="1600" dirty="0"/>
+            <a:endParaRPr lang="en-US" sz="1700" dirty="0"/>
           </a:p>
         </p:txBody>
       </p:sp>
       <p:sp>
         <p:nvSpPr>
-          <p:cNvPr id="5" name="Text 3"/>
+          <p:cNvPr id="12" name="Text 8"/>
           <p:cNvSpPr txBox="1"/>
           <p:nvPr/>
         </p:nvSpPr>
@@ -23079,7 +23863,7 @@
       </p:sp>
       <p:sp>
         <p:nvSpPr>
-          <p:cNvPr id="6" name="Text 4"/>
+          <p:cNvPr id="13" name="Text 9"/>
           <p:cNvSpPr txBox="1"/>
           <p:nvPr/>
         </p:nvSpPr>
@@ -23118,7 +23902,7 @@
       </p:sp>
       <p:sp>
         <p:nvSpPr>
-          <p:cNvPr id="7" name="pill8"/>
+          <p:cNvPr id="14" name="pill13"/>
           <p:cNvSpPr/>
           <p:nvPr/>
         </p:nvSpPr>
@@ -23145,7 +23929,7 @@
       </p:sp>
       <p:sp>
         <p:nvSpPr>
-          <p:cNvPr id="8" name="Text 6"/>
+          <p:cNvPr id="15" name="Text 11"/>
           <p:cNvSpPr txBox="1"/>
           <p:nvPr/>
         </p:nvSpPr>
@@ -23181,7 +23965,7 @@
       </p:sp>
       <p:sp>
         <p:nvSpPr>
-          <p:cNvPr id="9" name="pill9"/>
+          <p:cNvPr id="16" name="pill14"/>
           <p:cNvSpPr/>
           <p:nvPr/>
         </p:nvSpPr>
@@ -23208,7 +23992,7 @@
       </p:sp>
       <p:sp>
         <p:nvSpPr>
-          <p:cNvPr id="10" name="Text 8"/>
+          <p:cNvPr id="17" name="Text 13"/>
           <p:cNvSpPr txBox="1"/>
           <p:nvPr/>
         </p:nvSpPr>
@@ -23244,7 +24028,7 @@
       </p:sp>
       <p:sp>
         <p:nvSpPr>
-          <p:cNvPr id="11" name="Text 9"/>
+          <p:cNvPr id="18" name="Text 14"/>
           <p:cNvSpPr txBox="1"/>
           <p:nvPr/>
         </p:nvSpPr>
@@ -23388,7 +24172,7 @@
       </p:sp>
       <p:sp>
         <p:nvSpPr>
-          <p:cNvPr id="3" name="card10"/>
+          <p:cNvPr id="3" name="card15"/>
           <p:cNvSpPr/>
           <p:nvPr/>
         </p:nvSpPr>
@@ -23422,53 +24206,63 @@
       </p:sp>
       <p:sp>
         <p:nvSpPr>
-          <p:cNvPr id="4" name="Text 2"/>
+          <p:cNvPr id="4" name="iconbg16"/>
+          <p:cNvSpPr/>
+          <p:nvPr/>
+        </p:nvSpPr>
+        <p:spPr>
+          <a:xfrm>
+            <a:off x="777240" y="1719072"/>
+            <a:ext cx="658368" cy="658368"/>
+          </a:xfrm>
+          <a:prstGeom prst="ellipse">
+            <a:avLst/>
+          </a:prstGeom>
+          <a:solidFill>
+            <a:srgbClr val="E09F3E"/>
+          </a:solidFill>
+          <a:ln w="12700">
+            <a:solidFill>
+              <a:srgbClr val="E09F3E"/>
+            </a:solidFill>
+            <a:prstDash val="solid"/>
+          </a:ln>
+        </p:spPr>
+      </p:sp>
+      <p:pic>
+        <p:nvPicPr>
+          <p:cNvPr id="5" name="icon17" descr="FaNetworkWired">    </p:cNvPr>
+          <p:cNvPicPr>
+            <a:picLocks noChangeAspect="1"/>
+          </p:cNvPicPr>
+          <p:nvPr/>
+        </p:nvPicPr>
+        <p:blipFill>
+          <a:blip r:embed="rId1"/>
+          <a:stretch>
+            <a:fillRect/>
+          </a:stretch>
+        </p:blipFill>
+        <p:spPr>
+          <a:xfrm>
+            <a:off x="935248" y="1877080"/>
+            <a:ext cx="342351" cy="342351"/>
+          </a:xfrm>
+          <a:prstGeom prst="rect">
+            <a:avLst/>
+          </a:prstGeom>
+        </p:spPr>
+      </p:pic>
+      <p:sp>
+        <p:nvSpPr>
+          <p:cNvPr id="6" name="Text 3"/>
           <p:cNvSpPr txBox="1"/>
           <p:nvPr/>
         </p:nvSpPr>
         <p:spPr>
           <a:xfrm>
-            <a:off x="822960" y="1371600"/>
-            <a:ext cx="548640" cy="1371600"/>
-          </a:xfrm>
-          <a:prstGeom prst="rect">
-            <a:avLst/>
-          </a:prstGeom>
-          <a:noFill/>
-          <a:ln/>
-        </p:spPr>
-        <p:txBody>
-          <a:bodyPr wrap="square" lIns="0" tIns="0" rIns="0" bIns="0" rtlCol="0" anchor="ctr"/>
-          <a:lstStyle/>
-          <a:p>
-            <a:pPr indent="0" marL="0">
-              <a:buNone/>
-            </a:pPr>
-            <a:r>
-              <a:rPr lang="en-US" sz="3000" b="1" dirty="0">
-                <a:solidFill>
-                  <a:schemeClr val="accent3"/>
-                </a:solidFill>
-                <a:latin typeface="Cambria" pitchFamily="34" charset="0"/>
-                <a:ea typeface="Cambria" pitchFamily="34" charset="-122"/>
-                <a:cs typeface="Cambria" pitchFamily="34" charset="-120"/>
-              </a:rPr>
-              <a:t>1</a:t>
-            </a:r>
-            <a:endParaRPr lang="en-US" sz="3000" dirty="0"/>
-          </a:p>
-        </p:txBody>
-      </p:sp>
-      <p:sp>
-        <p:nvSpPr>
-          <p:cNvPr id="5" name="Text 3"/>
-          <p:cNvSpPr txBox="1"/>
-          <p:nvPr/>
-        </p:nvSpPr>
-        <p:spPr>
-          <a:xfrm>
-            <a:off x="1463040" y="1554480"/>
-            <a:ext cx="4297680" cy="411480"/>
+            <a:off x="1600200" y="1554480"/>
+            <a:ext cx="4206240" cy="411480"/>
           </a:xfrm>
           <a:prstGeom prst="rect">
             <a:avLst/>
@@ -23497,14 +24291,14 @@
       </p:sp>
       <p:sp>
         <p:nvSpPr>
-          <p:cNvPr id="6" name="Text 4"/>
+          <p:cNvPr id="7" name="Text 4"/>
           <p:cNvSpPr txBox="1"/>
           <p:nvPr/>
         </p:nvSpPr>
         <p:spPr>
           <a:xfrm>
-            <a:off x="1463040" y="1965960"/>
-            <a:ext cx="4297680" cy="731520"/>
+            <a:off x="1600200" y="1965960"/>
+            <a:ext cx="4206240" cy="731520"/>
           </a:xfrm>
           <a:prstGeom prst="rect">
             <a:avLst/>
@@ -23520,20 +24314,20 @@
               <a:buNone/>
             </a:pPr>
             <a:r>
-              <a:rPr lang="en-US" sz="1400" dirty="0">
+              <a:rPr lang="en-US" sz="1500" dirty="0">
                 <a:solidFill>
                   <a:schemeClr val="tx2"/>
                 </a:solidFill>
               </a:rPr>
               <a:t>A multi-department network in Packet Tracer; confirm every test flow works with no ACLs</a:t>
             </a:r>
-            <a:endParaRPr lang="en-US" sz="1400" dirty="0"/>
+            <a:endParaRPr lang="en-US" sz="1500" dirty="0"/>
           </a:p>
         </p:txBody>
       </p:sp>
       <p:sp>
         <p:nvSpPr>
-          <p:cNvPr id="7" name="card11"/>
+          <p:cNvPr id="8" name="card18"/>
           <p:cNvSpPr/>
           <p:nvPr/>
         </p:nvSpPr>
@@ -23567,53 +24361,63 @@
       </p:sp>
       <p:sp>
         <p:nvSpPr>
-          <p:cNvPr id="8" name="Text 6"/>
+          <p:cNvPr id="9" name="iconbg19"/>
+          <p:cNvSpPr/>
+          <p:nvPr/>
+        </p:nvSpPr>
+        <p:spPr>
+          <a:xfrm>
+            <a:off x="6400800" y="1719072"/>
+            <a:ext cx="658368" cy="658368"/>
+          </a:xfrm>
+          <a:prstGeom prst="ellipse">
+            <a:avLst/>
+          </a:prstGeom>
+          <a:solidFill>
+            <a:srgbClr val="E09F3E"/>
+          </a:solidFill>
+          <a:ln w="12700">
+            <a:solidFill>
+              <a:srgbClr val="E09F3E"/>
+            </a:solidFill>
+            <a:prstDash val="solid"/>
+          </a:ln>
+        </p:spPr>
+      </p:sp>
+      <p:pic>
+        <p:nvPicPr>
+          <p:cNvPr id="10" name="icon20" descr="FaClipboardList">    </p:cNvPr>
+          <p:cNvPicPr>
+            <a:picLocks noChangeAspect="1"/>
+          </p:cNvPicPr>
+          <p:nvPr/>
+        </p:nvPicPr>
+        <p:blipFill>
+          <a:blip r:embed="rId2"/>
+          <a:stretch>
+            <a:fillRect/>
+          </a:stretch>
+        </p:blipFill>
+        <p:spPr>
+          <a:xfrm>
+            <a:off x="6558808" y="1877080"/>
+            <a:ext cx="342351" cy="342351"/>
+          </a:xfrm>
+          <a:prstGeom prst="rect">
+            <a:avLst/>
+          </a:prstGeom>
+        </p:spPr>
+      </p:pic>
+      <p:sp>
+        <p:nvSpPr>
+          <p:cNvPr id="11" name="Text 7"/>
           <p:cNvSpPr txBox="1"/>
           <p:nvPr/>
         </p:nvSpPr>
         <p:spPr>
           <a:xfrm>
-            <a:off x="6446520" y="1371600"/>
-            <a:ext cx="548640" cy="1371600"/>
-          </a:xfrm>
-          <a:prstGeom prst="rect">
-            <a:avLst/>
-          </a:prstGeom>
-          <a:noFill/>
-          <a:ln/>
-        </p:spPr>
-        <p:txBody>
-          <a:bodyPr wrap="square" lIns="0" tIns="0" rIns="0" bIns="0" rtlCol="0" anchor="ctr"/>
-          <a:lstStyle/>
-          <a:p>
-            <a:pPr indent="0" marL="0">
-              <a:buNone/>
-            </a:pPr>
-            <a:r>
-              <a:rPr lang="en-US" sz="3000" b="1" dirty="0">
-                <a:solidFill>
-                  <a:schemeClr val="accent3"/>
-                </a:solidFill>
-                <a:latin typeface="Cambria" pitchFamily="34" charset="0"/>
-                <a:ea typeface="Cambria" pitchFamily="34" charset="-122"/>
-                <a:cs typeface="Cambria" pitchFamily="34" charset="-120"/>
-              </a:rPr>
-              <a:t>2</a:t>
-            </a:r>
-            <a:endParaRPr lang="en-US" sz="3000" dirty="0"/>
-          </a:p>
-        </p:txBody>
-      </p:sp>
-      <p:sp>
-        <p:nvSpPr>
-          <p:cNvPr id="9" name="Text 7"/>
-          <p:cNvSpPr txBox="1"/>
-          <p:nvPr/>
-        </p:nvSpPr>
-        <p:spPr>
-          <a:xfrm>
-            <a:off x="7086600" y="1554480"/>
-            <a:ext cx="4297680" cy="411480"/>
+            <a:off x="7223760" y="1554480"/>
+            <a:ext cx="4206240" cy="411480"/>
           </a:xfrm>
           <a:prstGeom prst="rect">
             <a:avLst/>
@@ -23642,14 +24446,14 @@
       </p:sp>
       <p:sp>
         <p:nvSpPr>
-          <p:cNvPr id="10" name="Text 8"/>
+          <p:cNvPr id="12" name="Text 8"/>
           <p:cNvSpPr txBox="1"/>
           <p:nvPr/>
         </p:nvSpPr>
         <p:spPr>
           <a:xfrm>
-            <a:off x="7086600" y="1965960"/>
-            <a:ext cx="4297680" cy="731520"/>
+            <a:off x="7223760" y="1965960"/>
+            <a:ext cx="4206240" cy="731520"/>
           </a:xfrm>
           <a:prstGeom prst="rect">
             <a:avLst/>
@@ -23665,20 +24469,20 @@
               <a:buNone/>
             </a:pPr>
             <a:r>
-              <a:rPr lang="en-US" sz="1400" dirty="0">
+              <a:rPr lang="en-US" sz="1500" dirty="0">
                 <a:solidFill>
                   <a:schemeClr val="tx2"/>
                 </a:solidFill>
               </a:rPr>
               <a:t>Write the required and forbidden flows before writing any rule</a:t>
             </a:r>
-            <a:endParaRPr lang="en-US" sz="1400" dirty="0"/>
+            <a:endParaRPr lang="en-US" sz="1500" dirty="0"/>
           </a:p>
         </p:txBody>
       </p:sp>
       <p:sp>
         <p:nvSpPr>
-          <p:cNvPr id="11" name="card12"/>
+          <p:cNvPr id="13" name="card21"/>
           <p:cNvSpPr/>
           <p:nvPr/>
         </p:nvSpPr>
@@ -23712,53 +24516,63 @@
       </p:sp>
       <p:sp>
         <p:nvSpPr>
-          <p:cNvPr id="12" name="Text 10"/>
+          <p:cNvPr id="14" name="iconbg22"/>
+          <p:cNvSpPr/>
+          <p:nvPr/>
+        </p:nvSpPr>
+        <p:spPr>
+          <a:xfrm>
+            <a:off x="777240" y="3273552"/>
+            <a:ext cx="658368" cy="658368"/>
+          </a:xfrm>
+          <a:prstGeom prst="ellipse">
+            <a:avLst/>
+          </a:prstGeom>
+          <a:solidFill>
+            <a:srgbClr val="E09F3E"/>
+          </a:solidFill>
+          <a:ln w="12700">
+            <a:solidFill>
+              <a:srgbClr val="E09F3E"/>
+            </a:solidFill>
+            <a:prstDash val="solid"/>
+          </a:ln>
+        </p:spPr>
+      </p:sp>
+      <p:pic>
+        <p:nvPicPr>
+          <p:cNvPr id="15" name="icon23" descr="FaLayerGroup">    </p:cNvPr>
+          <p:cNvPicPr>
+            <a:picLocks noChangeAspect="1"/>
+          </p:cNvPicPr>
+          <p:nvPr/>
+        </p:nvPicPr>
+        <p:blipFill>
+          <a:blip r:embed="rId3"/>
+          <a:stretch>
+            <a:fillRect/>
+          </a:stretch>
+        </p:blipFill>
+        <p:spPr>
+          <a:xfrm>
+            <a:off x="935248" y="3431560"/>
+            <a:ext cx="342351" cy="342351"/>
+          </a:xfrm>
+          <a:prstGeom prst="rect">
+            <a:avLst/>
+          </a:prstGeom>
+        </p:spPr>
+      </p:pic>
+      <p:sp>
+        <p:nvSpPr>
+          <p:cNvPr id="16" name="Text 11"/>
           <p:cNvSpPr txBox="1"/>
           <p:nvPr/>
         </p:nvSpPr>
         <p:spPr>
           <a:xfrm>
-            <a:off x="822960" y="2926080"/>
-            <a:ext cx="548640" cy="1371600"/>
-          </a:xfrm>
-          <a:prstGeom prst="rect">
-            <a:avLst/>
-          </a:prstGeom>
-          <a:noFill/>
-          <a:ln/>
-        </p:spPr>
-        <p:txBody>
-          <a:bodyPr wrap="square" lIns="0" tIns="0" rIns="0" bIns="0" rtlCol="0" anchor="ctr"/>
-          <a:lstStyle/>
-          <a:p>
-            <a:pPr indent="0" marL="0">
-              <a:buNone/>
-            </a:pPr>
-            <a:r>
-              <a:rPr lang="en-US" sz="3000" b="1" dirty="0">
-                <a:solidFill>
-                  <a:schemeClr val="accent3"/>
-                </a:solidFill>
-                <a:latin typeface="Cambria" pitchFamily="34" charset="0"/>
-                <a:ea typeface="Cambria" pitchFamily="34" charset="-122"/>
-                <a:cs typeface="Cambria" pitchFamily="34" charset="-120"/>
-              </a:rPr>
-              <a:t>3</a:t>
-            </a:r>
-            <a:endParaRPr lang="en-US" sz="3000" dirty="0"/>
-          </a:p>
-        </p:txBody>
-      </p:sp>
-      <p:sp>
-        <p:nvSpPr>
-          <p:cNvPr id="13" name="Text 11"/>
-          <p:cNvSpPr txBox="1"/>
-          <p:nvPr/>
-        </p:nvSpPr>
-        <p:spPr>
-          <a:xfrm>
-            <a:off x="1463040" y="3108960"/>
-            <a:ext cx="4297680" cy="411480"/>
+            <a:off x="1600200" y="3108960"/>
+            <a:ext cx="4206240" cy="411480"/>
           </a:xfrm>
           <a:prstGeom prst="rect">
             <a:avLst/>
@@ -23787,14 +24601,14 @@
       </p:sp>
       <p:sp>
         <p:nvSpPr>
-          <p:cNvPr id="14" name="Text 12"/>
+          <p:cNvPr id="17" name="Text 12"/>
           <p:cNvSpPr txBox="1"/>
           <p:nvPr/>
         </p:nvSpPr>
         <p:spPr>
           <a:xfrm>
-            <a:off x="1463040" y="3520440"/>
-            <a:ext cx="4297680" cy="731520"/>
+            <a:off x="1600200" y="3520440"/>
+            <a:ext cx="4206240" cy="731520"/>
           </a:xfrm>
           <a:prstGeom prst="rect">
             <a:avLst/>
@@ -23810,20 +24624,20 @@
               <a:buNone/>
             </a:pPr>
             <a:r>
-              <a:rPr lang="en-US" sz="1400" dirty="0">
+              <a:rPr lang="en-US" sz="1500" dirty="0">
                 <a:solidFill>
                   <a:schemeClr val="tx2"/>
                 </a:solidFill>
               </a:rPr>
               <a:t>Three policy stages at the same seven enforcement points</a:t>
             </a:r>
-            <a:endParaRPr lang="en-US" sz="1400" dirty="0"/>
+            <a:endParaRPr lang="en-US" sz="1500" dirty="0"/>
           </a:p>
         </p:txBody>
       </p:sp>
       <p:sp>
         <p:nvSpPr>
-          <p:cNvPr id="15" name="card13"/>
+          <p:cNvPr id="18" name="card24"/>
           <p:cNvSpPr/>
           <p:nvPr/>
         </p:nvSpPr>
@@ -23857,53 +24671,63 @@
       </p:sp>
       <p:sp>
         <p:nvSpPr>
-          <p:cNvPr id="16" name="Text 14"/>
+          <p:cNvPr id="19" name="iconbg25"/>
+          <p:cNvSpPr/>
+          <p:nvPr/>
+        </p:nvSpPr>
+        <p:spPr>
+          <a:xfrm>
+            <a:off x="6400800" y="3273552"/>
+            <a:ext cx="658368" cy="658368"/>
+          </a:xfrm>
+          <a:prstGeom prst="ellipse">
+            <a:avLst/>
+          </a:prstGeom>
+          <a:solidFill>
+            <a:srgbClr val="E09F3E"/>
+          </a:solidFill>
+          <a:ln w="12700">
+            <a:solidFill>
+              <a:srgbClr val="E09F3E"/>
+            </a:solidFill>
+            <a:prstDash val="solid"/>
+          </a:ln>
+        </p:spPr>
+      </p:sp>
+      <p:pic>
+        <p:nvPicPr>
+          <p:cNvPr id="20" name="icon26" descr="FaChartBar">    </p:cNvPr>
+          <p:cNvPicPr>
+            <a:picLocks noChangeAspect="1"/>
+          </p:cNvPicPr>
+          <p:nvPr/>
+        </p:nvPicPr>
+        <p:blipFill>
+          <a:blip r:embed="rId4"/>
+          <a:stretch>
+            <a:fillRect/>
+          </a:stretch>
+        </p:blipFill>
+        <p:spPr>
+          <a:xfrm>
+            <a:off x="6558808" y="3431560"/>
+            <a:ext cx="342351" cy="342351"/>
+          </a:xfrm>
+          <a:prstGeom prst="rect">
+            <a:avLst/>
+          </a:prstGeom>
+        </p:spPr>
+      </p:pic>
+      <p:sp>
+        <p:nvSpPr>
+          <p:cNvPr id="21" name="Text 15"/>
           <p:cNvSpPr txBox="1"/>
           <p:nvPr/>
         </p:nvSpPr>
         <p:spPr>
           <a:xfrm>
-            <a:off x="6446520" y="2926080"/>
-            <a:ext cx="548640" cy="1371600"/>
-          </a:xfrm>
-          <a:prstGeom prst="rect">
-            <a:avLst/>
-          </a:prstGeom>
-          <a:noFill/>
-          <a:ln/>
-        </p:spPr>
-        <p:txBody>
-          <a:bodyPr wrap="square" lIns="0" tIns="0" rIns="0" bIns="0" rtlCol="0" anchor="ctr"/>
-          <a:lstStyle/>
-          <a:p>
-            <a:pPr indent="0" marL="0">
-              <a:buNone/>
-            </a:pPr>
-            <a:r>
-              <a:rPr lang="en-US" sz="3000" b="1" dirty="0">
-                <a:solidFill>
-                  <a:schemeClr val="accent3"/>
-                </a:solidFill>
-                <a:latin typeface="Cambria" pitchFamily="34" charset="0"/>
-                <a:ea typeface="Cambria" pitchFamily="34" charset="-122"/>
-                <a:cs typeface="Cambria" pitchFamily="34" charset="-120"/>
-              </a:rPr>
-              <a:t>4</a:t>
-            </a:r>
-            <a:endParaRPr lang="en-US" sz="3000" dirty="0"/>
-          </a:p>
-        </p:txBody>
-      </p:sp>
-      <p:sp>
-        <p:nvSpPr>
-          <p:cNvPr id="17" name="Text 15"/>
-          <p:cNvSpPr txBox="1"/>
-          <p:nvPr/>
-        </p:nvSpPr>
-        <p:spPr>
-          <a:xfrm>
-            <a:off x="7086600" y="3108960"/>
-            <a:ext cx="4297680" cy="411480"/>
+            <a:off x="7223760" y="3108960"/>
+            <a:ext cx="4206240" cy="411480"/>
           </a:xfrm>
           <a:prstGeom prst="rect">
             <a:avLst/>
@@ -23932,14 +24756,14 @@
       </p:sp>
       <p:sp>
         <p:nvSpPr>
-          <p:cNvPr id="18" name="Text 16"/>
+          <p:cNvPr id="22" name="Text 16"/>
           <p:cNvSpPr txBox="1"/>
           <p:nvPr/>
         </p:nvSpPr>
         <p:spPr>
           <a:xfrm>
-            <a:off x="7086600" y="3520440"/>
-            <a:ext cx="4297680" cy="731520"/>
+            <a:off x="7223760" y="3520440"/>
+            <a:ext cx="4206240" cy="731520"/>
           </a:xfrm>
           <a:prstGeom prst="rect">
             <a:avLst/>
@@ -23955,20 +24779,20 @@
               <a:buNone/>
             </a:pPr>
             <a:r>
-              <a:rPr lang="en-US" sz="1400" dirty="0">
+              <a:rPr lang="en-US" sz="1500" dirty="0">
                 <a:solidFill>
                   <a:schemeClr val="tx2"/>
                 </a:solidFill>
               </a:rPr>
               <a:t>Unnecessary access left, and policy size, specificity and rule-order dependence</a:t>
             </a:r>
-            <a:endParaRPr lang="en-US" sz="1400" dirty="0"/>
+            <a:endParaRPr lang="en-US" sz="1500" dirty="0"/>
           </a:p>
         </p:txBody>
       </p:sp>
       <p:sp>
         <p:nvSpPr>
-          <p:cNvPr id="19" name="card14"/>
+          <p:cNvPr id="23" name="card27"/>
           <p:cNvSpPr/>
           <p:nvPr/>
         </p:nvSpPr>
@@ -24002,53 +24826,63 @@
       </p:sp>
       <p:sp>
         <p:nvSpPr>
-          <p:cNvPr id="20" name="Text 18"/>
+          <p:cNvPr id="24" name="iconbg28"/>
+          <p:cNvSpPr/>
+          <p:nvPr/>
+        </p:nvSpPr>
+        <p:spPr>
+          <a:xfrm>
+            <a:off x="777240" y="4828032"/>
+            <a:ext cx="658368" cy="658368"/>
+          </a:xfrm>
+          <a:prstGeom prst="ellipse">
+            <a:avLst/>
+          </a:prstGeom>
+          <a:solidFill>
+            <a:srgbClr val="E09F3E"/>
+          </a:solidFill>
+          <a:ln w="12700">
+            <a:solidFill>
+              <a:srgbClr val="E09F3E"/>
+            </a:solidFill>
+            <a:prstDash val="solid"/>
+          </a:ln>
+        </p:spPr>
+      </p:sp>
+      <p:pic>
+        <p:nvPicPr>
+          <p:cNvPr id="25" name="icon29" descr="FaBug">    </p:cNvPr>
+          <p:cNvPicPr>
+            <a:picLocks noChangeAspect="1"/>
+          </p:cNvPicPr>
+          <p:nvPr/>
+        </p:nvPicPr>
+        <p:blipFill>
+          <a:blip r:embed="rId5"/>
+          <a:stretch>
+            <a:fillRect/>
+          </a:stretch>
+        </p:blipFill>
+        <p:spPr>
+          <a:xfrm>
+            <a:off x="935248" y="4986040"/>
+            <a:ext cx="342351" cy="342351"/>
+          </a:xfrm>
+          <a:prstGeom prst="rect">
+            <a:avLst/>
+          </a:prstGeom>
+        </p:spPr>
+      </p:pic>
+      <p:sp>
+        <p:nvSpPr>
+          <p:cNvPr id="26" name="Text 19"/>
           <p:cNvSpPr txBox="1"/>
           <p:nvPr/>
         </p:nvSpPr>
         <p:spPr>
           <a:xfrm>
-            <a:off x="822960" y="4480560"/>
-            <a:ext cx="548640" cy="1371600"/>
-          </a:xfrm>
-          <a:prstGeom prst="rect">
-            <a:avLst/>
-          </a:prstGeom>
-          <a:noFill/>
-          <a:ln/>
-        </p:spPr>
-        <p:txBody>
-          <a:bodyPr wrap="square" lIns="0" tIns="0" rIns="0" bIns="0" rtlCol="0" anchor="ctr"/>
-          <a:lstStyle/>
-          <a:p>
-            <a:pPr indent="0" marL="0">
-              <a:buNone/>
-            </a:pPr>
-            <a:r>
-              <a:rPr lang="en-US" sz="3000" b="1" dirty="0">
-                <a:solidFill>
-                  <a:schemeClr val="accent3"/>
-                </a:solidFill>
-                <a:latin typeface="Cambria" pitchFamily="34" charset="0"/>
-                <a:ea typeface="Cambria" pitchFamily="34" charset="-122"/>
-                <a:cs typeface="Cambria" pitchFamily="34" charset="-120"/>
-              </a:rPr>
-              <a:t>5</a:t>
-            </a:r>
-            <a:endParaRPr lang="en-US" sz="3000" dirty="0"/>
-          </a:p>
-        </p:txBody>
-      </p:sp>
-      <p:sp>
-        <p:nvSpPr>
-          <p:cNvPr id="21" name="Text 19"/>
-          <p:cNvSpPr txBox="1"/>
-          <p:nvPr/>
-        </p:nvSpPr>
-        <p:spPr>
-          <a:xfrm>
-            <a:off x="1463040" y="4663440"/>
-            <a:ext cx="4297680" cy="411480"/>
+            <a:off x="1600200" y="4663440"/>
+            <a:ext cx="4206240" cy="411480"/>
           </a:xfrm>
           <a:prstGeom prst="rect">
             <a:avLst/>
@@ -24077,14 +24911,14 @@
       </p:sp>
       <p:sp>
         <p:nvSpPr>
-          <p:cNvPr id="22" name="Text 20"/>
+          <p:cNvPr id="27" name="Text 20"/>
           <p:cNvSpPr txBox="1"/>
           <p:nvPr/>
         </p:nvSpPr>
         <p:spPr>
           <a:xfrm>
-            <a:off x="1463040" y="5074920"/>
-            <a:ext cx="4297680" cy="731520"/>
+            <a:off x="1600200" y="5074920"/>
+            <a:ext cx="4206240" cy="731520"/>
           </a:xfrm>
           <a:prstGeom prst="rect">
             <a:avLst/>
@@ -24100,20 +24934,20 @@
               <a:buNone/>
             </a:pPr>
             <a:r>
-              <a:rPr lang="en-US" sz="1400" dirty="0">
+              <a:rPr lang="en-US" sz="1500" dirty="0">
                 <a:solidFill>
                   <a:schemeClr val="tx2"/>
                 </a:solidFill>
               </a:rPr>
               <a:t>Design two typical policy mistakes (shadowed rule, missing DNS rule)</a:t>
             </a:r>
-            <a:endParaRPr lang="en-US" sz="1400" dirty="0"/>
+            <a:endParaRPr lang="en-US" sz="1500" dirty="0"/>
           </a:p>
         </p:txBody>
       </p:sp>
       <p:sp>
         <p:nvSpPr>
-          <p:cNvPr id="23" name="card15"/>
+          <p:cNvPr id="28" name="card30"/>
           <p:cNvSpPr/>
           <p:nvPr/>
         </p:nvSpPr>
@@ -24147,53 +24981,63 @@
       </p:sp>
       <p:sp>
         <p:nvSpPr>
-          <p:cNvPr id="24" name="Text 22"/>
+          <p:cNvPr id="29" name="iconbg31"/>
+          <p:cNvSpPr/>
+          <p:nvPr/>
+        </p:nvSpPr>
+        <p:spPr>
+          <a:xfrm>
+            <a:off x="6400800" y="4828032"/>
+            <a:ext cx="658368" cy="658368"/>
+          </a:xfrm>
+          <a:prstGeom prst="ellipse">
+            <a:avLst/>
+          </a:prstGeom>
+          <a:solidFill>
+            <a:srgbClr val="E09F3E"/>
+          </a:solidFill>
+          <a:ln w="12700">
+            <a:solidFill>
+              <a:srgbClr val="E09F3E"/>
+            </a:solidFill>
+            <a:prstDash val="solid"/>
+          </a:ln>
+        </p:spPr>
+      </p:sp>
+      <p:pic>
+        <p:nvPicPr>
+          <p:cNvPr id="30" name="icon32" descr="FaBalanceScale">    </p:cNvPr>
+          <p:cNvPicPr>
+            <a:picLocks noChangeAspect="1"/>
+          </p:cNvPicPr>
+          <p:nvPr/>
+        </p:nvPicPr>
+        <p:blipFill>
+          <a:blip r:embed="rId6"/>
+          <a:stretch>
+            <a:fillRect/>
+          </a:stretch>
+        </p:blipFill>
+        <p:spPr>
+          <a:xfrm>
+            <a:off x="6558808" y="4986040"/>
+            <a:ext cx="342351" cy="342351"/>
+          </a:xfrm>
+          <a:prstGeom prst="rect">
+            <a:avLst/>
+          </a:prstGeom>
+        </p:spPr>
+      </p:pic>
+      <p:sp>
+        <p:nvSpPr>
+          <p:cNvPr id="31" name="Text 23"/>
           <p:cNvSpPr txBox="1"/>
           <p:nvPr/>
         </p:nvSpPr>
         <p:spPr>
           <a:xfrm>
-            <a:off x="6446520" y="4480560"/>
-            <a:ext cx="548640" cy="1371600"/>
-          </a:xfrm>
-          <a:prstGeom prst="rect">
-            <a:avLst/>
-          </a:prstGeom>
-          <a:noFill/>
-          <a:ln/>
-        </p:spPr>
-        <p:txBody>
-          <a:bodyPr wrap="square" lIns="0" tIns="0" rIns="0" bIns="0" rtlCol="0" anchor="ctr"/>
-          <a:lstStyle/>
-          <a:p>
-            <a:pPr indent="0" marL="0">
-              <a:buNone/>
-            </a:pPr>
-            <a:r>
-              <a:rPr lang="en-US" sz="3000" b="1" dirty="0">
-                <a:solidFill>
-                  <a:schemeClr val="accent3"/>
-                </a:solidFill>
-                <a:latin typeface="Cambria" pitchFamily="34" charset="0"/>
-                <a:ea typeface="Cambria" pitchFamily="34" charset="-122"/>
-                <a:cs typeface="Cambria" pitchFamily="34" charset="-120"/>
-              </a:rPr>
-              <a:t>6</a:t>
-            </a:r>
-            <a:endParaRPr lang="en-US" sz="3000" dirty="0"/>
-          </a:p>
-        </p:txBody>
-      </p:sp>
-      <p:sp>
-        <p:nvSpPr>
-          <p:cNvPr id="25" name="Text 23"/>
-          <p:cNvSpPr txBox="1"/>
-          <p:nvPr/>
-        </p:nvSpPr>
-        <p:spPr>
-          <a:xfrm>
-            <a:off x="7086600" y="4663440"/>
-            <a:ext cx="4297680" cy="411480"/>
+            <a:off x="7223760" y="4663440"/>
+            <a:ext cx="4206240" cy="411480"/>
           </a:xfrm>
           <a:prstGeom prst="rect">
             <a:avLst/>
@@ -24222,14 +25066,14 @@
       </p:sp>
       <p:sp>
         <p:nvSpPr>
-          <p:cNvPr id="26" name="Text 24"/>
+          <p:cNvPr id="32" name="Text 24"/>
           <p:cNvSpPr txBox="1"/>
           <p:nvPr/>
         </p:nvSpPr>
         <p:spPr>
           <a:xfrm>
-            <a:off x="7086600" y="5074920"/>
-            <a:ext cx="4297680" cy="731520"/>
+            <a:off x="7223760" y="5074920"/>
+            <a:ext cx="4206240" cy="731520"/>
           </a:xfrm>
           <a:prstGeom prst="rect">
             <a:avLst/>
@@ -24245,14 +25089,14 @@
               <a:buNone/>
             </a:pPr>
             <a:r>
-              <a:rPr lang="en-US" sz="1400" dirty="0">
+              <a:rPr lang="en-US" sz="1500" dirty="0">
                 <a:solidFill>
                   <a:schemeClr val="tx2"/>
                 </a:solidFill>
               </a:rPr>
               <a:t>Relate the results to the literature reviewed in Part A</a:t>
             </a:r>
-            <a:endParaRPr lang="en-US" sz="1400" dirty="0"/>
+            <a:endParaRPr lang="en-US" sz="1500" dirty="0"/>
           </a:p>
         </p:txBody>
       </p:sp>
@@ -24366,7 +25210,7 @@
       </p:sp>
       <p:sp>
         <p:nvSpPr>
-          <p:cNvPr id="3" name="card16"/>
+          <p:cNvPr id="3" name="card33"/>
           <p:cNvSpPr/>
           <p:nvPr/>
         </p:nvSpPr>
@@ -24400,68 +25244,56 @@
       </p:sp>
       <p:sp>
         <p:nvSpPr>
-          <p:cNvPr id="4" name="num0"/>
+          <p:cNvPr id="4" name="iconbg34"/>
           <p:cNvSpPr/>
           <p:nvPr/>
         </p:nvSpPr>
         <p:spPr>
           <a:xfrm>
-            <a:off x="777240" y="1645920"/>
-            <a:ext cx="502920" cy="502920"/>
+            <a:off x="777240" y="1618488"/>
+            <a:ext cx="566928" cy="566928"/>
           </a:xfrm>
           <a:prstGeom prst="ellipse">
             <a:avLst/>
           </a:prstGeom>
           <a:solidFill>
-            <a:schemeClr val="tx2"/>
+            <a:srgbClr val="2E3A46"/>
           </a:solidFill>
           <a:ln w="12700">
             <a:solidFill>
-              <a:schemeClr val="tx2"/>
+              <a:srgbClr val="2E3A46"/>
             </a:solidFill>
             <a:prstDash val="solid"/>
           </a:ln>
         </p:spPr>
       </p:sp>
-      <p:sp>
-        <p:nvSpPr>
-          <p:cNvPr id="5" name="Text 3"/>
-          <p:cNvSpPr txBox="1"/>
-          <p:nvPr/>
-        </p:nvSpPr>
-        <p:spPr>
-          <a:xfrm>
-            <a:off x="777240" y="1645920"/>
-            <a:ext cx="502920" cy="502920"/>
+      <p:pic>
+        <p:nvPicPr>
+          <p:cNvPr id="5" name="icon35" descr="FaShieldAlt">    </p:cNvPr>
+          <p:cNvPicPr>
+            <a:picLocks noChangeAspect="1"/>
+          </p:cNvPicPr>
+          <p:nvPr/>
+        </p:nvPicPr>
+        <p:blipFill>
+          <a:blip r:embed="rId1"/>
+          <a:stretch>
+            <a:fillRect/>
+          </a:stretch>
+        </p:blipFill>
+        <p:spPr>
+          <a:xfrm>
+            <a:off x="913303" y="1754551"/>
+            <a:ext cx="294803" cy="294803"/>
           </a:xfrm>
           <a:prstGeom prst="rect">
             <a:avLst/>
           </a:prstGeom>
-          <a:noFill/>
-          <a:ln/>
-        </p:spPr>
-        <p:txBody>
-          <a:bodyPr wrap="square" lIns="0" tIns="0" rIns="0" bIns="0" rtlCol="0" anchor="ctr"/>
-          <a:lstStyle/>
-          <a:p>
-            <a:pPr algn="ctr" indent="0" marL="0">
-              <a:buNone/>
-            </a:pPr>
-            <a:r>
-              <a:rPr lang="en-US" sz="1600" b="1" dirty="0">
-                <a:solidFill>
-                  <a:schemeClr val="bg1"/>
-                </a:solidFill>
-              </a:rPr>
-              <a:t>1</a:t>
-            </a:r>
-            <a:endParaRPr lang="en-US" sz="1600" dirty="0"/>
-          </a:p>
-        </p:txBody>
-      </p:sp>
-      <p:sp>
-        <p:nvSpPr>
-          <p:cNvPr id="6" name="Text 4"/>
+        </p:spPr>
+      </p:pic>
+      <p:sp>
+        <p:nvSpPr>
+          <p:cNvPr id="6" name="Text 3"/>
           <p:cNvSpPr txBox="1"/>
           <p:nvPr/>
         </p:nvSpPr>
@@ -24497,7 +25329,7 @@
       </p:sp>
       <p:sp>
         <p:nvSpPr>
-          <p:cNvPr id="7" name="Text 5"/>
+          <p:cNvPr id="7" name="Text 4"/>
           <p:cNvSpPr txBox="1"/>
           <p:nvPr/>
         </p:nvSpPr>
@@ -24520,20 +25352,20 @@
               <a:buNone/>
             </a:pPr>
             <a:r>
-              <a:rPr lang="en-US" sz="1400" dirty="0">
+              <a:rPr lang="en-US" sz="1500" dirty="0">
                 <a:solidFill>
                   <a:schemeClr val="tx2"/>
                 </a:solidFill>
               </a:rPr>
               <a:t>Default deny at the boundary; inside often trusted</a:t>
             </a:r>
-            <a:endParaRPr lang="en-US" sz="1400" dirty="0"/>
+            <a:endParaRPr lang="en-US" sz="1500" dirty="0"/>
           </a:p>
         </p:txBody>
       </p:sp>
       <p:sp>
         <p:nvSpPr>
-          <p:cNvPr id="8" name="Text 6"/>
+          <p:cNvPr id="8" name="Text 5"/>
           <p:cNvSpPr txBox="1"/>
           <p:nvPr/>
         </p:nvSpPr>
@@ -24569,7 +25401,7 @@
       </p:sp>
       <p:sp>
         <p:nvSpPr>
-          <p:cNvPr id="9" name="card17"/>
+          <p:cNvPr id="9" name="card36"/>
           <p:cNvSpPr/>
           <p:nvPr/>
         </p:nvSpPr>
@@ -24603,68 +25435,56 @@
       </p:sp>
       <p:sp>
         <p:nvSpPr>
-          <p:cNvPr id="10" name="num1"/>
+          <p:cNvPr id="10" name="iconbg37"/>
           <p:cNvSpPr/>
           <p:nvPr/>
         </p:nvSpPr>
         <p:spPr>
           <a:xfrm>
-            <a:off x="4544568" y="1645920"/>
-            <a:ext cx="502920" cy="502920"/>
+            <a:off x="4544568" y="1618488"/>
+            <a:ext cx="566928" cy="566928"/>
           </a:xfrm>
           <a:prstGeom prst="ellipse">
             <a:avLst/>
           </a:prstGeom>
           <a:solidFill>
-            <a:schemeClr val="tx2"/>
+            <a:srgbClr val="2E3A46"/>
           </a:solidFill>
           <a:ln w="12700">
             <a:solidFill>
-              <a:schemeClr val="tx2"/>
+              <a:srgbClr val="2E3A46"/>
             </a:solidFill>
             <a:prstDash val="solid"/>
           </a:ln>
         </p:spPr>
       </p:sp>
-      <p:sp>
-        <p:nvSpPr>
-          <p:cNvPr id="11" name="Text 9"/>
-          <p:cNvSpPr txBox="1"/>
-          <p:nvPr/>
-        </p:nvSpPr>
-        <p:spPr>
-          <a:xfrm>
-            <a:off x="4544568" y="1645920"/>
-            <a:ext cx="502920" cy="502920"/>
+      <p:pic>
+        <p:nvPicPr>
+          <p:cNvPr id="11" name="icon38" descr="FaSortAmountDown">    </p:cNvPr>
+          <p:cNvPicPr>
+            <a:picLocks noChangeAspect="1"/>
+          </p:cNvPicPr>
+          <p:nvPr/>
+        </p:nvPicPr>
+        <p:blipFill>
+          <a:blip r:embed="rId2"/>
+          <a:stretch>
+            <a:fillRect/>
+          </a:stretch>
+        </p:blipFill>
+        <p:spPr>
+          <a:xfrm>
+            <a:off x="4680631" y="1754551"/>
+            <a:ext cx="294803" cy="294803"/>
           </a:xfrm>
           <a:prstGeom prst="rect">
             <a:avLst/>
           </a:prstGeom>
-          <a:noFill/>
-          <a:ln/>
-        </p:spPr>
-        <p:txBody>
-          <a:bodyPr wrap="square" lIns="0" tIns="0" rIns="0" bIns="0" rtlCol="0" anchor="ctr"/>
-          <a:lstStyle/>
-          <a:p>
-            <a:pPr algn="ctr" indent="0" marL="0">
-              <a:buNone/>
-            </a:pPr>
-            <a:r>
-              <a:rPr lang="en-US" sz="1600" b="1" dirty="0">
-                <a:solidFill>
-                  <a:schemeClr val="bg1"/>
-                </a:solidFill>
-              </a:rPr>
-              <a:t>2</a:t>
-            </a:r>
-            <a:endParaRPr lang="en-US" sz="1600" dirty="0"/>
-          </a:p>
-        </p:txBody>
-      </p:sp>
-      <p:sp>
-        <p:nvSpPr>
-          <p:cNvPr id="12" name="Text 10"/>
+        </p:spPr>
+      </p:pic>
+      <p:sp>
+        <p:nvSpPr>
+          <p:cNvPr id="12" name="Text 8"/>
           <p:cNvSpPr txBox="1"/>
           <p:nvPr/>
         </p:nvSpPr>
@@ -24700,7 +25520,7 @@
       </p:sp>
       <p:sp>
         <p:nvSpPr>
-          <p:cNvPr id="13" name="Text 11"/>
+          <p:cNvPr id="13" name="Text 9"/>
           <p:cNvSpPr txBox="1"/>
           <p:nvPr/>
         </p:nvSpPr>
@@ -24723,20 +25543,20 @@
               <a:buNone/>
             </a:pPr>
             <a:r>
-              <a:rPr lang="en-US" sz="1400" dirty="0">
+              <a:rPr lang="en-US" sz="1500" dirty="0">
                 <a:solidFill>
                   <a:schemeClr val="tx2"/>
                 </a:solidFill>
               </a:rPr>
               <a:t>First-match order causes shadowing and redundancy</a:t>
             </a:r>
-            <a:endParaRPr lang="en-US" sz="1400" dirty="0"/>
+            <a:endParaRPr lang="en-US" sz="1500" dirty="0"/>
           </a:p>
         </p:txBody>
       </p:sp>
       <p:sp>
         <p:nvSpPr>
-          <p:cNvPr id="14" name="Text 12"/>
+          <p:cNvPr id="14" name="Text 10"/>
           <p:cNvSpPr txBox="1"/>
           <p:nvPr/>
         </p:nvSpPr>
@@ -24772,7 +25592,7 @@
       </p:sp>
       <p:sp>
         <p:nvSpPr>
-          <p:cNvPr id="15" name="card18"/>
+          <p:cNvPr id="15" name="card39"/>
           <p:cNvSpPr/>
           <p:nvPr/>
         </p:nvSpPr>
@@ -24806,68 +25626,56 @@
       </p:sp>
       <p:sp>
         <p:nvSpPr>
-          <p:cNvPr id="16" name="num2"/>
+          <p:cNvPr id="16" name="iconbg40"/>
           <p:cNvSpPr/>
           <p:nvPr/>
         </p:nvSpPr>
         <p:spPr>
           <a:xfrm>
-            <a:off x="8311896" y="1645920"/>
-            <a:ext cx="502920" cy="502920"/>
+            <a:off x="8311896" y="1618488"/>
+            <a:ext cx="566928" cy="566928"/>
           </a:xfrm>
           <a:prstGeom prst="ellipse">
             <a:avLst/>
           </a:prstGeom>
           <a:solidFill>
-            <a:schemeClr val="tx2"/>
+            <a:srgbClr val="2E3A46"/>
           </a:solidFill>
           <a:ln w="12700">
             <a:solidFill>
-              <a:schemeClr val="tx2"/>
+              <a:srgbClr val="2E3A46"/>
             </a:solidFill>
             <a:prstDash val="solid"/>
           </a:ln>
         </p:spPr>
       </p:sp>
-      <p:sp>
-        <p:nvSpPr>
-          <p:cNvPr id="17" name="Text 15"/>
-          <p:cNvSpPr txBox="1"/>
-          <p:nvPr/>
-        </p:nvSpPr>
-        <p:spPr>
-          <a:xfrm>
-            <a:off x="8311896" y="1645920"/>
-            <a:ext cx="502920" cy="502920"/>
+      <p:pic>
+        <p:nvPicPr>
+          <p:cNvPr id="17" name="icon41" descr="FaExclamationTriangle">    </p:cNvPr>
+          <p:cNvPicPr>
+            <a:picLocks noChangeAspect="1"/>
+          </p:cNvPicPr>
+          <p:nvPr/>
+        </p:nvPicPr>
+        <p:blipFill>
+          <a:blip r:embed="rId3"/>
+          <a:stretch>
+            <a:fillRect/>
+          </a:stretch>
+        </p:blipFill>
+        <p:spPr>
+          <a:xfrm>
+            <a:off x="8447959" y="1754551"/>
+            <a:ext cx="294803" cy="294803"/>
           </a:xfrm>
           <a:prstGeom prst="rect">
             <a:avLst/>
           </a:prstGeom>
-          <a:noFill/>
-          <a:ln/>
-        </p:spPr>
-        <p:txBody>
-          <a:bodyPr wrap="square" lIns="0" tIns="0" rIns="0" bIns="0" rtlCol="0" anchor="ctr"/>
-          <a:lstStyle/>
-          <a:p>
-            <a:pPr algn="ctr" indent="0" marL="0">
-              <a:buNone/>
-            </a:pPr>
-            <a:r>
-              <a:rPr lang="en-US" sz="1600" b="1" dirty="0">
-                <a:solidFill>
-                  <a:schemeClr val="bg1"/>
-                </a:solidFill>
-              </a:rPr>
-              <a:t>3</a:t>
-            </a:r>
-            <a:endParaRPr lang="en-US" sz="1600" dirty="0"/>
-          </a:p>
-        </p:txBody>
-      </p:sp>
-      <p:sp>
-        <p:nvSpPr>
-          <p:cNvPr id="18" name="Text 16"/>
+        </p:spPr>
+      </p:pic>
+      <p:sp>
+        <p:nvSpPr>
+          <p:cNvPr id="18" name="Text 13"/>
           <p:cNvSpPr txBox="1"/>
           <p:nvPr/>
         </p:nvSpPr>
@@ -24903,7 +25711,7 @@
       </p:sp>
       <p:sp>
         <p:nvSpPr>
-          <p:cNvPr id="19" name="Text 17"/>
+          <p:cNvPr id="19" name="Text 14"/>
           <p:cNvSpPr txBox="1"/>
           <p:nvPr/>
         </p:nvSpPr>
@@ -24926,20 +25734,20 @@
               <a:buNone/>
             </a:pPr>
             <a:r>
-              <a:rPr lang="en-US" sz="1400" dirty="0">
+              <a:rPr lang="en-US" sz="1500" dirty="0">
                 <a:solidFill>
                   <a:schemeClr val="tx2"/>
                 </a:solidFill>
               </a:rPr>
               <a:t>Real rule sets are often wrong; complexity tracks risk</a:t>
             </a:r>
-            <a:endParaRPr lang="en-US" sz="1400" dirty="0"/>
+            <a:endParaRPr lang="en-US" sz="1500" dirty="0"/>
           </a:p>
         </p:txBody>
       </p:sp>
       <p:sp>
         <p:nvSpPr>
-          <p:cNvPr id="20" name="Text 18"/>
+          <p:cNvPr id="20" name="Text 15"/>
           <p:cNvSpPr txBox="1"/>
           <p:nvPr/>
         </p:nvSpPr>
@@ -24975,7 +25783,7 @@
       </p:sp>
       <p:sp>
         <p:nvSpPr>
-          <p:cNvPr id="21" name="card19"/>
+          <p:cNvPr id="21" name="card42"/>
           <p:cNvSpPr/>
           <p:nvPr/>
         </p:nvSpPr>
@@ -25009,68 +25817,56 @@
       </p:sp>
       <p:sp>
         <p:nvSpPr>
-          <p:cNvPr id="22" name="num3"/>
+          <p:cNvPr id="22" name="iconbg43"/>
           <p:cNvSpPr/>
           <p:nvPr/>
         </p:nvSpPr>
         <p:spPr>
           <a:xfrm>
-            <a:off x="2660904" y="4023360"/>
-            <a:ext cx="502920" cy="502920"/>
+            <a:off x="2660904" y="3995928"/>
+            <a:ext cx="566928" cy="566928"/>
           </a:xfrm>
           <a:prstGeom prst="ellipse">
             <a:avLst/>
           </a:prstGeom>
           <a:solidFill>
-            <a:schemeClr val="tx2"/>
+            <a:srgbClr val="2E3A46"/>
           </a:solidFill>
           <a:ln w="12700">
             <a:solidFill>
-              <a:schemeClr val="tx2"/>
+              <a:srgbClr val="2E3A46"/>
             </a:solidFill>
             <a:prstDash val="solid"/>
           </a:ln>
         </p:spPr>
       </p:sp>
-      <p:sp>
-        <p:nvSpPr>
-          <p:cNvPr id="23" name="Text 21"/>
-          <p:cNvSpPr txBox="1"/>
-          <p:nvPr/>
-        </p:nvSpPr>
-        <p:spPr>
-          <a:xfrm>
-            <a:off x="2660904" y="4023360"/>
-            <a:ext cx="502920" cy="502920"/>
+      <p:pic>
+        <p:nvPicPr>
+          <p:cNvPr id="23" name="icon44" descr="FaUserLock">    </p:cNvPr>
+          <p:cNvPicPr>
+            <a:picLocks noChangeAspect="1"/>
+          </p:cNvPicPr>
+          <p:nvPr/>
+        </p:nvPicPr>
+        <p:blipFill>
+          <a:blip r:embed="rId4"/>
+          <a:stretch>
+            <a:fillRect/>
+          </a:stretch>
+        </p:blipFill>
+        <p:spPr>
+          <a:xfrm>
+            <a:off x="2796967" y="4131991"/>
+            <a:ext cx="294803" cy="294803"/>
           </a:xfrm>
           <a:prstGeom prst="rect">
             <a:avLst/>
           </a:prstGeom>
-          <a:noFill/>
-          <a:ln/>
-        </p:spPr>
-        <p:txBody>
-          <a:bodyPr wrap="square" lIns="0" tIns="0" rIns="0" bIns="0" rtlCol="0" anchor="ctr"/>
-          <a:lstStyle/>
-          <a:p>
-            <a:pPr algn="ctr" indent="0" marL="0">
-              <a:buNone/>
-            </a:pPr>
-            <a:r>
-              <a:rPr lang="en-US" sz="1600" b="1" dirty="0">
-                <a:solidFill>
-                  <a:schemeClr val="bg1"/>
-                </a:solidFill>
-              </a:rPr>
-              <a:t>4</a:t>
-            </a:r>
-            <a:endParaRPr lang="en-US" sz="1600" dirty="0"/>
-          </a:p>
-        </p:txBody>
-      </p:sp>
-      <p:sp>
-        <p:nvSpPr>
-          <p:cNvPr id="24" name="Text 22"/>
+        </p:spPr>
+      </p:pic>
+      <p:sp>
+        <p:nvSpPr>
+          <p:cNvPr id="24" name="Text 18"/>
           <p:cNvSpPr txBox="1"/>
           <p:nvPr/>
         </p:nvSpPr>
@@ -25106,7 +25902,7 @@
       </p:sp>
       <p:sp>
         <p:nvSpPr>
-          <p:cNvPr id="25" name="Text 23"/>
+          <p:cNvPr id="25" name="Text 19"/>
           <p:cNvSpPr txBox="1"/>
           <p:nvPr/>
         </p:nvSpPr>
@@ -25129,20 +25925,20 @@
               <a:buNone/>
             </a:pPr>
             <a:r>
-              <a:rPr lang="en-US" sz="1400" dirty="0">
+              <a:rPr lang="en-US" sz="1500" dirty="0">
                 <a:solidFill>
                   <a:schemeClr val="tx2"/>
                 </a:solidFill>
               </a:rPr>
               <a:t>No trust from location; segment to limit lateral movement</a:t>
             </a:r>
-            <a:endParaRPr lang="en-US" sz="1400" dirty="0"/>
+            <a:endParaRPr lang="en-US" sz="1500" dirty="0"/>
           </a:p>
         </p:txBody>
       </p:sp>
       <p:sp>
         <p:nvSpPr>
-          <p:cNvPr id="26" name="Text 24"/>
+          <p:cNvPr id="26" name="Text 20"/>
           <p:cNvSpPr txBox="1"/>
           <p:nvPr/>
         </p:nvSpPr>
@@ -25178,7 +25974,7 @@
       </p:sp>
       <p:sp>
         <p:nvSpPr>
-          <p:cNvPr id="27" name="card20"/>
+          <p:cNvPr id="27" name="card45"/>
           <p:cNvSpPr/>
           <p:nvPr/>
         </p:nvSpPr>
@@ -25212,68 +26008,56 @@
       </p:sp>
       <p:sp>
         <p:nvSpPr>
-          <p:cNvPr id="28" name="num4"/>
+          <p:cNvPr id="28" name="iconbg46"/>
           <p:cNvSpPr/>
           <p:nvPr/>
         </p:nvSpPr>
         <p:spPr>
           <a:xfrm>
-            <a:off x="6428232" y="4023360"/>
-            <a:ext cx="502920" cy="502920"/>
+            <a:off x="6428232" y="3995928"/>
+            <a:ext cx="566928" cy="566928"/>
           </a:xfrm>
           <a:prstGeom prst="ellipse">
             <a:avLst/>
           </a:prstGeom>
           <a:solidFill>
-            <a:schemeClr val="tx2"/>
+            <a:srgbClr val="2E3A46"/>
           </a:solidFill>
           <a:ln w="12700">
             <a:solidFill>
-              <a:schemeClr val="tx2"/>
+              <a:srgbClr val="2E3A46"/>
             </a:solidFill>
             <a:prstDash val="solid"/>
           </a:ln>
         </p:spPr>
       </p:sp>
-      <p:sp>
-        <p:nvSpPr>
-          <p:cNvPr id="29" name="Text 27"/>
-          <p:cNvSpPr txBox="1"/>
-          <p:nvPr/>
-        </p:nvSpPr>
-        <p:spPr>
-          <a:xfrm>
-            <a:off x="6428232" y="4023360"/>
-            <a:ext cx="502920" cy="502920"/>
+      <p:pic>
+        <p:nvPicPr>
+          <p:cNvPr id="29" name="icon47" descr="FaTools">    </p:cNvPr>
+          <p:cNvPicPr>
+            <a:picLocks noChangeAspect="1"/>
+          </p:cNvPicPr>
+          <p:nvPr/>
+        </p:nvPicPr>
+        <p:blipFill>
+          <a:blip r:embed="rId5"/>
+          <a:stretch>
+            <a:fillRect/>
+          </a:stretch>
+        </p:blipFill>
+        <p:spPr>
+          <a:xfrm>
+            <a:off x="6564295" y="4131991"/>
+            <a:ext cx="294803" cy="294803"/>
           </a:xfrm>
           <a:prstGeom prst="rect">
             <a:avLst/>
           </a:prstGeom>
-          <a:noFill/>
-          <a:ln/>
-        </p:spPr>
-        <p:txBody>
-          <a:bodyPr wrap="square" lIns="0" tIns="0" rIns="0" bIns="0" rtlCol="0" anchor="ctr"/>
-          <a:lstStyle/>
-          <a:p>
-            <a:pPr algn="ctr" indent="0" marL="0">
-              <a:buNone/>
-            </a:pPr>
-            <a:r>
-              <a:rPr lang="en-US" sz="1600" b="1" dirty="0">
-                <a:solidFill>
-                  <a:schemeClr val="bg1"/>
-                </a:solidFill>
-              </a:rPr>
-              <a:t>5</a:t>
-            </a:r>
-            <a:endParaRPr lang="en-US" sz="1600" dirty="0"/>
-          </a:p>
-        </p:txBody>
-      </p:sp>
-      <p:sp>
-        <p:nvSpPr>
-          <p:cNvPr id="30" name="Text 28"/>
+        </p:spPr>
+      </p:pic>
+      <p:sp>
+        <p:nvSpPr>
+          <p:cNvPr id="30" name="Text 23"/>
           <p:cNvSpPr txBox="1"/>
           <p:nvPr/>
         </p:nvSpPr>
@@ -25309,7 +26093,7 @@
       </p:sp>
       <p:sp>
         <p:nvSpPr>
-          <p:cNvPr id="31" name="Text 29"/>
+          <p:cNvPr id="31" name="Text 24"/>
           <p:cNvSpPr txBox="1"/>
           <p:nvPr/>
         </p:nvSpPr>
@@ -25332,20 +26116,20 @@
               <a:buNone/>
             </a:pPr>
             <a:r>
-              <a:rPr lang="en-US" sz="1400" dirty="0">
+              <a:rPr lang="en-US" sz="1500" dirty="0">
                 <a:solidFill>
                   <a:schemeClr val="tx2"/>
                 </a:solidFill>
               </a:rPr>
               <a:t>Detect or prevent anomalies; usability rarely tested</a:t>
             </a:r>
-            <a:endParaRPr lang="en-US" sz="1400" dirty="0"/>
+            <a:endParaRPr lang="en-US" sz="1500" dirty="0"/>
           </a:p>
         </p:txBody>
       </p:sp>
       <p:sp>
         <p:nvSpPr>
-          <p:cNvPr id="32" name="Text 30"/>
+          <p:cNvPr id="32" name="Text 25"/>
           <p:cNvSpPr txBox="1"/>
           <p:nvPr/>
         </p:nvSpPr>
@@ -25489,7 +26273,7 @@
       </p:sp>
       <p:sp>
         <p:nvSpPr>
-          <p:cNvPr id="3" name="card21"/>
+          <p:cNvPr id="3" name="card48"/>
           <p:cNvSpPr/>
           <p:nvPr/>
         </p:nvSpPr>
@@ -25585,20 +26369,20 @@
               <a:buNone/>
             </a:pPr>
             <a:r>
-              <a:rPr lang="en-US" sz="1600" dirty="0">
+              <a:rPr lang="en-US" sz="1700" dirty="0">
                 <a:solidFill>
                   <a:schemeClr val="tx1"/>
                 </a:solidFill>
               </a:rPr>
               <a:t>Empirical data on misconfiguration are dated and from few sources</a:t>
             </a:r>
-            <a:endParaRPr lang="en-US" sz="1600" dirty="0"/>
+            <a:endParaRPr lang="en-US" sz="1700" dirty="0"/>
           </a:p>
         </p:txBody>
       </p:sp>
       <p:sp>
         <p:nvSpPr>
-          <p:cNvPr id="6" name="card22"/>
+          <p:cNvPr id="6" name="card49"/>
           <p:cNvSpPr/>
           <p:nvPr/>
         </p:nvSpPr>
@@ -25694,20 +26478,20 @@
               <a:buNone/>
             </a:pPr>
             <a:r>
-              <a:rPr lang="en-US" sz="1600" dirty="0">
+              <a:rPr lang="en-US" sz="1700" dirty="0">
                 <a:solidFill>
                   <a:schemeClr val="tx1"/>
                 </a:solidFill>
               </a:rPr>
               <a:t>Unnecessary access is rarely measured against written requirements</a:t>
             </a:r>
-            <a:endParaRPr lang="en-US" sz="1600" dirty="0"/>
+            <a:endParaRPr lang="en-US" sz="1700" dirty="0"/>
           </a:p>
         </p:txBody>
       </p:sp>
       <p:sp>
         <p:nvSpPr>
-          <p:cNvPr id="9" name="card23"/>
+          <p:cNvPr id="9" name="card50"/>
           <p:cNvSpPr/>
           <p:nvPr/>
         </p:nvSpPr>
@@ -25803,20 +26587,20 @@
               <a:buNone/>
             </a:pPr>
             <a:r>
-              <a:rPr lang="en-US" sz="1600" dirty="0">
+              <a:rPr lang="en-US" sz="1700" dirty="0">
                 <a:solidFill>
                   <a:schemeClr val="tx1"/>
                 </a:solidFill>
               </a:rPr>
               <a:t>Security gain and management cost are seldom measured on the same policy</a:t>
             </a:r>
-            <a:endParaRPr lang="en-US" sz="1600" dirty="0"/>
+            <a:endParaRPr lang="en-US" sz="1700" dirty="0"/>
           </a:p>
         </p:txBody>
       </p:sp>
       <p:sp>
         <p:nvSpPr>
-          <p:cNvPr id="12" name="card24"/>
+          <p:cNvPr id="12" name="card51"/>
           <p:cNvSpPr/>
           <p:nvPr/>
         </p:nvSpPr>
@@ -25912,20 +26696,20 @@
               <a:buNone/>
             </a:pPr>
             <a:r>
-              <a:rPr lang="en-US" sz="1600" dirty="0">
+              <a:rPr lang="en-US" sz="1700" dirty="0">
                 <a:solidFill>
                   <a:schemeClr val="tx1"/>
                 </a:solidFill>
               </a:rPr>
               <a:t>Management tools are seldom evaluated with real users</a:t>
             </a:r>
-            <a:endParaRPr lang="en-US" sz="1600" dirty="0"/>
+            <a:endParaRPr lang="en-US" sz="1700" dirty="0"/>
           </a:p>
         </p:txBody>
       </p:sp>
       <p:sp>
         <p:nvSpPr>
-          <p:cNvPr id="15" name="card25"/>
+          <p:cNvPr id="15" name="card52"/>
           <p:cNvSpPr/>
           <p:nvPr/>
         </p:nvSpPr>
@@ -26187,7 +26971,7 @@
       </p:sp>
       <p:pic>
         <p:nvPicPr>
-          <p:cNvPr id="3" name="img26" descr="Network topology with enforcement points AP1 to AP7">    </p:cNvPr>
+          <p:cNvPr id="3" name="img53" descr="Network topology with enforcement points AP1 to AP7">    </p:cNvPr>
           <p:cNvPicPr>
             <a:picLocks noChangeAspect="1"/>
           </p:cNvPicPr>
@@ -26211,7 +26995,7 @@
       </p:pic>
       <p:sp>
         <p:nvSpPr>
-          <p:cNvPr id="4" name="card27"/>
+          <p:cNvPr id="4" name="card54"/>
           <p:cNvSpPr/>
           <p:nvPr/>
         </p:nvSpPr>
@@ -26317,7 +27101,7 @@
       </p:sp>
       <p:sp>
         <p:nvSpPr>
-          <p:cNvPr id="7" name="card28"/>
+          <p:cNvPr id="7" name="card55"/>
           <p:cNvSpPr/>
           <p:nvPr/>
         </p:nvSpPr>
@@ -26423,7 +27207,7 @@
       </p:sp>
       <p:sp>
         <p:nvSpPr>
-          <p:cNvPr id="10" name="card29"/>
+          <p:cNvPr id="10" name="card56"/>
           <p:cNvSpPr/>
           <p:nvPr/>
         </p:nvSpPr>
@@ -26529,7 +27313,7 @@
       </p:sp>
       <p:sp>
         <p:nvSpPr>
-          <p:cNvPr id="13" name="card30"/>
+          <p:cNvPr id="13" name="card57"/>
           <p:cNvSpPr/>
           <p:nvPr/>
         </p:nvSpPr>
@@ -26743,7 +27527,7 @@
       </p:sp>
       <p:sp>
         <p:nvSpPr>
-          <p:cNvPr id="3" name="pill31"/>
+          <p:cNvPr id="3" name="pill58"/>
           <p:cNvSpPr/>
           <p:nvPr/>
         </p:nvSpPr>
@@ -26806,7 +27590,7 @@
       </p:sp>
       <p:sp>
         <p:nvSpPr>
-          <p:cNvPr id="5" name="pill32"/>
+          <p:cNvPr id="5" name="pill59"/>
           <p:cNvSpPr/>
           <p:nvPr/>
         </p:nvSpPr>
@@ -29053,7 +29837,7 @@
       </p:sp>
       <p:sp>
         <p:nvSpPr>
-          <p:cNvPr id="3" name="card33"/>
+          <p:cNvPr id="3" name="card60"/>
           <p:cNvSpPr/>
           <p:nvPr/>
         </p:nvSpPr>
@@ -29259,7 +30043,7 @@
       </p:sp>
       <p:sp>
         <p:nvSpPr>
-          <p:cNvPr id="9" name="card34"/>
+          <p:cNvPr id="9" name="card61"/>
           <p:cNvSpPr/>
           <p:nvPr/>
         </p:nvSpPr>
@@ -29465,7 +30249,7 @@
       </p:sp>
       <p:sp>
         <p:nvSpPr>
-          <p:cNvPr id="15" name="card35"/>
+          <p:cNvPr id="15" name="card62"/>
           <p:cNvSpPr/>
           <p:nvPr/>
         </p:nvSpPr>

</xml_diff>

<commit_message>
Presentation: clickable links on reference slides (now 2 slides)
Co-Authored-By: Claude Opus 5.5 <noreply@anthropic.com>
Claude-Session: https://claude.ai/code/session_01VZE4XfkebTWLatWpMU9HD1
</commit_message>
<xml_diff>
--- a/report/case-study-presentation.pptx
+++ b/report/case-study-presentation.pptx
@@ -29,9 +29,10 @@
     <p:sldId id="277" r:id="rId23"/>
     <p:sldId id="278" r:id="rId24"/>
     <p:sldId id="279" r:id="rId25"/>
+    <p:sldId id="280" r:id="rId26"/>
   </p:sldIdLst>
   <p:notesMasterIdLst>
-    <p:notesMasterId r:id="rId26"/>
+    <p:notesMasterId r:id="rId27"/>
   </p:notesMasterIdLst>
   <p:sldSz cx="12192000" cy="6858000"/>
   <p:notesSz cx="6858000" cy="12192000"/>
@@ -130,7 +131,7 @@
   <p:extLst>
     <p:ext uri="{521415D9-36F7-43E2-AB2F-B90AF26B5E84}">
       <p14:sectionLst xmlns:p14="http://schemas.microsoft.com/office/powerpoint/2010/main">
-        <p14:section name="Introduction" id="{b0c82e09-c38a-1e45-06e5-92b9883c9437}">
+        <p14:section name="Introduction" id="{765ca505-2e53-78c2-7be1-50ee4c76c7f0}">
           <p14:sldIdLst>
             <p14:sldId id="256"/>
             <p14:sldId id="257"/>
@@ -138,13 +139,13 @@
             <p14:sldId id="259"/>
           </p14:sldIdLst>
         </p14:section>
-        <p14:section name="Part A: Literature" id="{6f1649f0-50d5-11be-b0df-5c8a4de9ceb1}">
+        <p14:section name="Part A: Literature" id="{b8f7cac3-3fd5-2bd7-28cd-d24b92b3aa97}">
           <p14:sldIdLst>
             <p14:sldId id="260"/>
             <p14:sldId id="261"/>
           </p14:sldIdLst>
         </p14:section>
-        <p14:section name="Part B: Design" id="{f9624de7-f8f0-a289-2e0c-68f876aa56a8}">
+        <p14:section name="Part B: Design" id="{c1e06a2a-60ab-7b34-fb94-29c826c97648}">
           <p14:sldIdLst>
             <p14:sldId id="262"/>
             <p14:sldId id="263"/>
@@ -153,7 +154,7 @@
             <p14:sldId id="266"/>
           </p14:sldIdLst>
         </p14:section>
-        <p14:section name="Part B: Results" id="{5d24a261-8143-da12-cfe5-e96b7c9f0eb2}">
+        <p14:section name="Part B: Results" id="{3a32cfd9-2884-cc53-7945-b808af5e7c10}">
           <p14:sldIdLst>
             <p14:sldId id="267"/>
             <p14:sldId id="268"/>
@@ -165,13 +166,14 @@
             <p14:sldId id="274"/>
           </p14:sldIdLst>
         </p14:section>
-        <p14:section name="Part C and conclusion" id="{4a1d32c1-f9a4-525b-e120-3942e9e43d86}">
+        <p14:section name="Part C and conclusion" id="{b248d7d8-647a-94ef-68c8-e9716642d5f7}">
           <p14:sldIdLst>
             <p14:sldId id="275"/>
             <p14:sldId id="276"/>
             <p14:sldId id="277"/>
             <p14:sldId id="278"/>
             <p14:sldId id="279"/>
+            <p14:sldId id="280"/>
           </p14:sldIdLst>
         </p14:section>
       </p14:sectionLst>
@@ -2359,7 +2361,7 @@
           <a:p>
             <a:r>
               <a:rPr lang="en-US" dirty="0"/>
-              <a:t>Ten of the eighteen sources; the full list is in the report.</a:t>
+              <a:t>Links are clickable in slideshow mode.</a:t>
             </a:r>
             <a:endParaRPr lang="en-US" dirty="0"/>
           </a:p>
@@ -2383,6 +2385,94 @@
             <a:fld id="{F7021451-1387-4CA6-816F-3879F97B5CBC}" type="slidenum">
               <a:rPr lang="en-US"/>
               <a:t>24</a:t>
+            </a:fld>
+            <a:endParaRPr lang="en-US"/>
+          </a:p>
+        </p:txBody>
+      </p:sp>
+    </p:spTree>
+    <p:extLst>
+      <p:ext uri="{BB962C8B-B14F-4D97-AF65-F5344CB8AC3E}">
+        <p14:creationId xmlns:p14="http://schemas.microsoft.com/office/powerpoint/2010/main" val="1024086991"/>
+      </p:ext>
+    </p:extLst>
+  </p:cSld>
+  <p:clrMapOvr>
+    <a:masterClrMapping/>
+  </p:clrMapOvr>
+</p:notes>
+</file>
+
+<file path=ppt/notesSlides/notesSlide25.xml><?xml version="1.0" encoding="utf-8"?>
+<p:notes xmlns:a="http://schemas.openxmlformats.org/drawingml/2006/main" xmlns:r="http://schemas.openxmlformats.org/officeDocument/2006/relationships" xmlns:p="http://schemas.openxmlformats.org/presentationml/2006/main">
+  <p:cSld>
+    <p:spTree>
+      <p:nvGrpSpPr>
+        <p:cNvPr id="1" name=""/>
+        <p:cNvGrpSpPr/>
+        <p:nvPr/>
+      </p:nvGrpSpPr>
+      <p:grpSpPr>
+        <a:xfrm>
+          <a:off x="0" y="0"/>
+          <a:ext cx="0" cy="0"/>
+          <a:chOff x="0" y="0"/>
+          <a:chExt cx="0" cy="0"/>
+        </a:xfrm>
+      </p:grpSpPr>
+      <p:sp>
+        <p:nvSpPr>
+          <p:cNvPr id="2" name="Slide Image Placeholder 1"/>
+          <p:cNvSpPr>
+            <a:spLocks noGrp="1" noRot="1" noChangeAspect="1"/>
+          </p:cNvSpPr>
+          <p:nvPr>
+            <p:ph type="sldImg"/>
+          </p:nvPr>
+        </p:nvSpPr>
+        <p:spPr/>
+      </p:sp>
+      <p:sp>
+        <p:nvSpPr>
+          <p:cNvPr id="3" name="Notes Placeholder 2"/>
+          <p:cNvSpPr>
+            <a:spLocks noGrp="1"/>
+          </p:cNvSpPr>
+          <p:nvPr>
+            <p:ph type="body" idx="1"/>
+          </p:nvPr>
+        </p:nvSpPr>
+        <p:spPr/>
+        <p:txBody>
+          <a:bodyPr/>
+          <a:lstStyle/>
+          <a:p>
+            <a:r>
+              <a:rPr lang="en-US" dirty="0"/>
+              <a:t>Links are clickable in slideshow mode.</a:t>
+            </a:r>
+            <a:endParaRPr lang="en-US" dirty="0"/>
+          </a:p>
+        </p:txBody>
+      </p:sp>
+      <p:sp>
+        <p:nvSpPr>
+          <p:cNvPr id="4" name="Slide Number Placeholder 3"/>
+          <p:cNvSpPr>
+            <a:spLocks noGrp="1"/>
+          </p:cNvSpPr>
+          <p:nvPr>
+            <p:ph type="sldNum" sz="quarter" idx="10"/>
+          </p:nvPr>
+        </p:nvSpPr>
+        <p:spPr/>
+        <p:txBody>
+          <a:bodyPr/>
+          <a:lstStyle/>
+          <a:p>
+            <a:fld id="{F7021451-1387-4CA6-816F-3879F97B5CBC}" type="slidenum">
+              <a:rPr lang="en-US"/>
+              <a:t>25</a:t>
             </a:fld>
             <a:endParaRPr lang="en-US"/>
           </a:p>
@@ -23207,7 +23297,7 @@
                   <a:schemeClr val="tx1"/>
                 </a:solidFill>
               </a:rPr>
-              <a:t>Key references</a:t>
+              <a:t>Key references (1 of 2)</a:t>
             </a:r>
             <a:endParaRPr lang="en-US" sz="3200" dirty="0"/>
           </a:p>
@@ -23215,14 +23305,48 @@
       </p:sp>
       <p:sp>
         <p:nvSpPr>
-          <p:cNvPr id="3" name="Text 1"/>
+          <p:cNvPr id="3" name="card145"/>
+          <p:cNvSpPr/>
+          <p:nvPr/>
+        </p:nvSpPr>
+        <p:spPr>
+          <a:xfrm>
+            <a:off x="548640" y="1325880"/>
+            <a:ext cx="11064240" cy="804672"/>
+          </a:xfrm>
+          <a:prstGeom prst="roundRect">
+            <a:avLst>
+              <a:gd name="adj" fmla="val 9091"/>
+            </a:avLst>
+          </a:prstGeom>
+          <a:solidFill>
+            <a:schemeClr val="bg2"/>
+          </a:solidFill>
+          <a:ln w="12700">
+            <a:solidFill>
+              <a:schemeClr val="bg2"/>
+            </a:solidFill>
+            <a:prstDash val="solid"/>
+          </a:ln>
+          <a:effectLst>
+            <a:outerShdw sx="100000" sy="100000" kx="0" ky="0" algn="bl" rotWithShape="0" blurRad="76200" dist="25400" dir="5400000">
+              <a:srgbClr val="000000">
+                <a:alpha val="12000"/>
+              </a:srgbClr>
+            </a:outerShdw>
+          </a:effectLst>
+        </p:spPr>
+      </p:sp>
+      <p:sp>
+        <p:nvSpPr>
+          <p:cNvPr id="4" name="Text 2"/>
           <p:cNvSpPr txBox="1"/>
           <p:nvPr/>
         </p:nvSpPr>
         <p:spPr>
           <a:xfrm>
-            <a:off x="731520" y="1371600"/>
-            <a:ext cx="10789920" cy="4480560"/>
+            <a:off x="777240" y="1399032"/>
+            <a:ext cx="10607040" cy="365760"/>
           </a:xfrm>
           <a:prstGeom prst="rect">
             <a:avLst/>
@@ -23235,186 +23359,482 @@
           <a:lstStyle/>
           <a:p>
             <a:pPr indent="0" marL="0">
-              <a:spcAft>
-                <a:spcPts val="800"/>
-              </a:spcAft>
               <a:buNone/>
             </a:pPr>
             <a:r>
               <a:rPr lang="en-US" sz="1500" dirty="0">
                 <a:solidFill>
-                  <a:schemeClr val="tx2"/>
+                  <a:schemeClr val="tx1"/>
                 </a:solidFill>
               </a:rPr>
               <a:t>[1] A. Wool, "A quantitative study of firewall configuration errors," Computer, 37(6), 2004.</a:t>
             </a:r>
             <a:endParaRPr lang="en-US" sz="1500" dirty="0"/>
           </a:p>
+        </p:txBody>
+      </p:sp>
+      <p:sp>
+        <p:nvSpPr>
+          <p:cNvPr id="5" name="Text 3"/>
+          <p:cNvSpPr txBox="1"/>
+          <p:nvPr/>
+        </p:nvSpPr>
+        <p:spPr>
+          <a:xfrm>
+            <a:off x="777240" y="1764792"/>
+            <a:ext cx="10607040" cy="292608"/>
+          </a:xfrm>
+          <a:prstGeom prst="rect">
+            <a:avLst/>
+          </a:prstGeom>
+          <a:noFill/>
+          <a:ln/>
+        </p:spPr>
+        <p:txBody>
+          <a:bodyPr wrap="square" lIns="0" tIns="0" rIns="0" bIns="0" rtlCol="0" anchor="t"/>
+          <a:lstStyle/>
           <a:p>
             <a:pPr indent="0" marL="0">
-              <a:spcAft>
-                <a:spcPts val="800"/>
-              </a:spcAft>
+              <a:buNone/>
+            </a:pPr>
+            <a:r>
+              <a:rPr lang="en-US" sz="1300" u="sng" dirty="0">
+                <a:solidFill>
+                  <a:schemeClr val="accent5"/>
+                </a:solidFill>
+                <a:hlinkClick r:id="rId1" invalidUrl="" action="" tgtFrame="" tooltip="Open source" history="1" highlightClick="0" endSnd="0">
+                  <a:extLst>
+                    <a:ext uri="{A12FA001-AC4F-418D-AE19-62706E023703}">
+                      <ahyp:hlinkClr xmlns:ahyp="http://schemas.microsoft.com/office/drawing/2018/hyperlinkcolor" val="tx"/>
+                    </a:ext>
+                  </a:extLst>
+                </a:hlinkClick>
+              </a:rPr>
+              <a:t>https://ieeexplore.ieee.org/document/1306389</a:t>
+            </a:r>
+            <a:endParaRPr lang="en-US" sz="1300" dirty="0"/>
+          </a:p>
+        </p:txBody>
+      </p:sp>
+      <p:sp>
+        <p:nvSpPr>
+          <p:cNvPr id="6" name="card146"/>
+          <p:cNvSpPr/>
+          <p:nvPr/>
+        </p:nvSpPr>
+        <p:spPr>
+          <a:xfrm>
+            <a:off x="548640" y="2258568"/>
+            <a:ext cx="11064240" cy="804672"/>
+          </a:xfrm>
+          <a:prstGeom prst="roundRect">
+            <a:avLst>
+              <a:gd name="adj" fmla="val 9091"/>
+            </a:avLst>
+          </a:prstGeom>
+          <a:solidFill>
+            <a:schemeClr val="bg2"/>
+          </a:solidFill>
+          <a:ln w="12700">
+            <a:solidFill>
+              <a:schemeClr val="bg2"/>
+            </a:solidFill>
+            <a:prstDash val="solid"/>
+          </a:ln>
+          <a:effectLst>
+            <a:outerShdw sx="100000" sy="100000" kx="0" ky="0" algn="bl" rotWithShape="0" blurRad="76200" dist="25400" dir="5400000">
+              <a:srgbClr val="000000">
+                <a:alpha val="12000"/>
+              </a:srgbClr>
+            </a:outerShdw>
+          </a:effectLst>
+        </p:spPr>
+      </p:sp>
+      <p:sp>
+        <p:nvSpPr>
+          <p:cNvPr id="7" name="Text 5"/>
+          <p:cNvSpPr txBox="1"/>
+          <p:nvPr/>
+        </p:nvSpPr>
+        <p:spPr>
+          <a:xfrm>
+            <a:off x="777240" y="2331720"/>
+            <a:ext cx="10607040" cy="365760"/>
+          </a:xfrm>
+          <a:prstGeom prst="rect">
+            <a:avLst/>
+          </a:prstGeom>
+          <a:noFill/>
+          <a:ln/>
+        </p:spPr>
+        <p:txBody>
+          <a:bodyPr wrap="square" lIns="0" tIns="0" rIns="0" bIns="0" rtlCol="0" anchor="t"/>
+          <a:lstStyle/>
+          <a:p>
+            <a:pPr indent="0" marL="0">
               <a:buNone/>
             </a:pPr>
             <a:r>
               <a:rPr lang="en-US" sz="1500" dirty="0">
                 <a:solidFill>
-                  <a:schemeClr val="tx2"/>
+                  <a:schemeClr val="tx1"/>
                 </a:solidFill>
               </a:rPr>
-              <a:t>[2] A. Wool, "Trends in firewall configuration errors," IEEE Internet Computing, 14(4), 2010.</a:t>
+              <a:t>[2] A. Wool, "Trends in firewall configuration errors," IEEE Internet Computing, 14(4), 2010 (extended version).</a:t>
             </a:r>
             <a:endParaRPr lang="en-US" sz="1500" dirty="0"/>
           </a:p>
+        </p:txBody>
+      </p:sp>
+      <p:sp>
+        <p:nvSpPr>
+          <p:cNvPr id="8" name="Text 6"/>
+          <p:cNvSpPr txBox="1"/>
+          <p:nvPr/>
+        </p:nvSpPr>
+        <p:spPr>
+          <a:xfrm>
+            <a:off x="777240" y="2697480"/>
+            <a:ext cx="10607040" cy="292608"/>
+          </a:xfrm>
+          <a:prstGeom prst="rect">
+            <a:avLst/>
+          </a:prstGeom>
+          <a:noFill/>
+          <a:ln/>
+        </p:spPr>
+        <p:txBody>
+          <a:bodyPr wrap="square" lIns="0" tIns="0" rIns="0" bIns="0" rtlCol="0" anchor="t"/>
+          <a:lstStyle/>
           <a:p>
             <a:pPr indent="0" marL="0">
-              <a:spcAft>
-                <a:spcPts val="800"/>
-              </a:spcAft>
+              <a:buNone/>
+            </a:pPr>
+            <a:r>
+              <a:rPr lang="en-US" sz="1300" u="sng" dirty="0">
+                <a:solidFill>
+                  <a:schemeClr val="accent5"/>
+                </a:solidFill>
+                <a:hlinkClick r:id="rId2" invalidUrl="" action="" tgtFrame="" tooltip="Open source" history="1" highlightClick="0" endSnd="0">
+                  <a:extLst>
+                    <a:ext uri="{A12FA001-AC4F-418D-AE19-62706E023703}">
+                      <ahyp:hlinkClr xmlns:ahyp="http://schemas.microsoft.com/office/drawing/2018/hyperlinkcolor" val="tx"/>
+                    </a:ext>
+                  </a:extLst>
+                </a:hlinkClick>
+              </a:rPr>
+              <a:t>https://arxiv.org/abs/0911.1240</a:t>
+            </a:r>
+            <a:endParaRPr lang="en-US" sz="1300" dirty="0"/>
+          </a:p>
+        </p:txBody>
+      </p:sp>
+      <p:sp>
+        <p:nvSpPr>
+          <p:cNvPr id="9" name="card147"/>
+          <p:cNvSpPr/>
+          <p:nvPr/>
+        </p:nvSpPr>
+        <p:spPr>
+          <a:xfrm>
+            <a:off x="548640" y="3191256"/>
+            <a:ext cx="11064240" cy="804672"/>
+          </a:xfrm>
+          <a:prstGeom prst="roundRect">
+            <a:avLst>
+              <a:gd name="adj" fmla="val 9091"/>
+            </a:avLst>
+          </a:prstGeom>
+          <a:solidFill>
+            <a:schemeClr val="bg2"/>
+          </a:solidFill>
+          <a:ln w="12700">
+            <a:solidFill>
+              <a:schemeClr val="bg2"/>
+            </a:solidFill>
+            <a:prstDash val="solid"/>
+          </a:ln>
+          <a:effectLst>
+            <a:outerShdw sx="100000" sy="100000" kx="0" ky="0" algn="bl" rotWithShape="0" blurRad="76200" dist="25400" dir="5400000">
+              <a:srgbClr val="000000">
+                <a:alpha val="12000"/>
+              </a:srgbClr>
+            </a:outerShdw>
+          </a:effectLst>
+        </p:spPr>
+      </p:sp>
+      <p:sp>
+        <p:nvSpPr>
+          <p:cNvPr id="10" name="Text 8"/>
+          <p:cNvSpPr txBox="1"/>
+          <p:nvPr/>
+        </p:nvSpPr>
+        <p:spPr>
+          <a:xfrm>
+            <a:off x="777240" y="3264408"/>
+            <a:ext cx="10607040" cy="365760"/>
+          </a:xfrm>
+          <a:prstGeom prst="rect">
+            <a:avLst/>
+          </a:prstGeom>
+          <a:noFill/>
+          <a:ln/>
+        </p:spPr>
+        <p:txBody>
+          <a:bodyPr wrap="square" lIns="0" tIns="0" rIns="0" bIns="0" rtlCol="0" anchor="t"/>
+          <a:lstStyle/>
+          <a:p>
+            <a:pPr indent="0" marL="0">
               <a:buNone/>
             </a:pPr>
             <a:r>
               <a:rPr lang="en-US" sz="1500" dirty="0">
                 <a:solidFill>
-                  <a:schemeClr val="tx2"/>
+                  <a:schemeClr val="tx1"/>
                 </a:solidFill>
               </a:rPr>
-              <a:t>[3] K. Scarfone, P. Hoffman, "Guidelines on firewalls and firewall policy," NIST SP 800-41r1, 2009.</a:t>
+              <a:t>[3] K. Scarfone, P. Hoffman, "Guidelines on firewalls and firewall policy," NIST SP 800-41 Rev. 1, 2009.</a:t>
             </a:r>
             <a:endParaRPr lang="en-US" sz="1500" dirty="0"/>
           </a:p>
+        </p:txBody>
+      </p:sp>
+      <p:sp>
+        <p:nvSpPr>
+          <p:cNvPr id="11" name="Text 9"/>
+          <p:cNvSpPr txBox="1"/>
+          <p:nvPr/>
+        </p:nvSpPr>
+        <p:spPr>
+          <a:xfrm>
+            <a:off x="777240" y="3630168"/>
+            <a:ext cx="10607040" cy="292608"/>
+          </a:xfrm>
+          <a:prstGeom prst="rect">
+            <a:avLst/>
+          </a:prstGeom>
+          <a:noFill/>
+          <a:ln/>
+        </p:spPr>
+        <p:txBody>
+          <a:bodyPr wrap="square" lIns="0" tIns="0" rIns="0" bIns="0" rtlCol="0" anchor="t"/>
+          <a:lstStyle/>
           <a:p>
             <a:pPr indent="0" marL="0">
-              <a:spcAft>
-                <a:spcPts val="800"/>
-              </a:spcAft>
+              <a:buNone/>
+            </a:pPr>
+            <a:r>
+              <a:rPr lang="en-US" sz="1300" u="sng" dirty="0">
+                <a:solidFill>
+                  <a:schemeClr val="accent5"/>
+                </a:solidFill>
+                <a:hlinkClick r:id="rId3" invalidUrl="" action="" tgtFrame="" tooltip="Open source" history="1" highlightClick="0" endSnd="0">
+                  <a:extLst>
+                    <a:ext uri="{A12FA001-AC4F-418D-AE19-62706E023703}">
+                      <ahyp:hlinkClr xmlns:ahyp="http://schemas.microsoft.com/office/drawing/2018/hyperlinkcolor" val="tx"/>
+                    </a:ext>
+                  </a:extLst>
+                </a:hlinkClick>
+              </a:rPr>
+              <a:t>https://doi.org/10.6028/NIST.SP.800-41r1</a:t>
+            </a:r>
+            <a:endParaRPr lang="en-US" sz="1300" dirty="0"/>
+          </a:p>
+        </p:txBody>
+      </p:sp>
+      <p:sp>
+        <p:nvSpPr>
+          <p:cNvPr id="12" name="card148"/>
+          <p:cNvSpPr/>
+          <p:nvPr/>
+        </p:nvSpPr>
+        <p:spPr>
+          <a:xfrm>
+            <a:off x="548640" y="4123944"/>
+            <a:ext cx="11064240" cy="804672"/>
+          </a:xfrm>
+          <a:prstGeom prst="roundRect">
+            <a:avLst>
+              <a:gd name="adj" fmla="val 9091"/>
+            </a:avLst>
+          </a:prstGeom>
+          <a:solidFill>
+            <a:schemeClr val="bg2"/>
+          </a:solidFill>
+          <a:ln w="12700">
+            <a:solidFill>
+              <a:schemeClr val="bg2"/>
+            </a:solidFill>
+            <a:prstDash val="solid"/>
+          </a:ln>
+          <a:effectLst>
+            <a:outerShdw sx="100000" sy="100000" kx="0" ky="0" algn="bl" rotWithShape="0" blurRad="76200" dist="25400" dir="5400000">
+              <a:srgbClr val="000000">
+                <a:alpha val="12000"/>
+              </a:srgbClr>
+            </a:outerShdw>
+          </a:effectLst>
+        </p:spPr>
+      </p:sp>
+      <p:sp>
+        <p:nvSpPr>
+          <p:cNvPr id="13" name="Text 11"/>
+          <p:cNvSpPr txBox="1"/>
+          <p:nvPr/>
+        </p:nvSpPr>
+        <p:spPr>
+          <a:xfrm>
+            <a:off x="777240" y="4197096"/>
+            <a:ext cx="10607040" cy="365760"/>
+          </a:xfrm>
+          <a:prstGeom prst="rect">
+            <a:avLst/>
+          </a:prstGeom>
+          <a:noFill/>
+          <a:ln/>
+        </p:spPr>
+        <p:txBody>
+          <a:bodyPr wrap="square" lIns="0" tIns="0" rIns="0" bIns="0" rtlCol="0" anchor="t"/>
+          <a:lstStyle/>
+          <a:p>
+            <a:pPr indent="0" marL="0">
               <a:buNone/>
             </a:pPr>
             <a:r>
               <a:rPr lang="en-US" sz="1500" dirty="0">
                 <a:solidFill>
-                  <a:schemeClr val="tx2"/>
+                  <a:schemeClr val="tx1"/>
                 </a:solidFill>
               </a:rPr>
               <a:t>[4] S. Rose et al., "Zero trust architecture," NIST SP 800-207, 2020.</a:t>
             </a:r>
             <a:endParaRPr lang="en-US" sz="1500" dirty="0"/>
           </a:p>
+        </p:txBody>
+      </p:sp>
+      <p:sp>
+        <p:nvSpPr>
+          <p:cNvPr id="14" name="Text 12"/>
+          <p:cNvSpPr txBox="1"/>
+          <p:nvPr/>
+        </p:nvSpPr>
+        <p:spPr>
+          <a:xfrm>
+            <a:off x="777240" y="4562856"/>
+            <a:ext cx="10607040" cy="292608"/>
+          </a:xfrm>
+          <a:prstGeom prst="rect">
+            <a:avLst/>
+          </a:prstGeom>
+          <a:noFill/>
+          <a:ln/>
+        </p:spPr>
+        <p:txBody>
+          <a:bodyPr wrap="square" lIns="0" tIns="0" rIns="0" bIns="0" rtlCol="0" anchor="t"/>
+          <a:lstStyle/>
           <a:p>
             <a:pPr indent="0" marL="0">
-              <a:spcAft>
-                <a:spcPts val="800"/>
-              </a:spcAft>
+              <a:buNone/>
+            </a:pPr>
+            <a:r>
+              <a:rPr lang="en-US" sz="1300" u="sng" dirty="0">
+                <a:solidFill>
+                  <a:schemeClr val="accent5"/>
+                </a:solidFill>
+                <a:hlinkClick r:id="rId4" invalidUrl="" action="" tgtFrame="" tooltip="Open source" history="1" highlightClick="0" endSnd="0">
+                  <a:extLst>
+                    <a:ext uri="{A12FA001-AC4F-418D-AE19-62706E023703}">
+                      <ahyp:hlinkClr xmlns:ahyp="http://schemas.microsoft.com/office/drawing/2018/hyperlinkcolor" val="tx"/>
+                    </a:ext>
+                  </a:extLst>
+                </a:hlinkClick>
+              </a:rPr>
+              <a:t>https://doi.org/10.6028/NIST.SP.800-207</a:t>
+            </a:r>
+            <a:endParaRPr lang="en-US" sz="1300" dirty="0"/>
+          </a:p>
+        </p:txBody>
+      </p:sp>
+      <p:sp>
+        <p:nvSpPr>
+          <p:cNvPr id="15" name="card149"/>
+          <p:cNvSpPr/>
+          <p:nvPr/>
+        </p:nvSpPr>
+        <p:spPr>
+          <a:xfrm>
+            <a:off x="548640" y="5056632"/>
+            <a:ext cx="11064240" cy="804672"/>
+          </a:xfrm>
+          <a:prstGeom prst="roundRect">
+            <a:avLst>
+              <a:gd name="adj" fmla="val 9091"/>
+            </a:avLst>
+          </a:prstGeom>
+          <a:solidFill>
+            <a:schemeClr val="bg2"/>
+          </a:solidFill>
+          <a:ln w="12700">
+            <a:solidFill>
+              <a:schemeClr val="bg2"/>
+            </a:solidFill>
+            <a:prstDash val="solid"/>
+          </a:ln>
+          <a:effectLst>
+            <a:outerShdw sx="100000" sy="100000" kx="0" ky="0" algn="bl" rotWithShape="0" blurRad="76200" dist="25400" dir="5400000">
+              <a:srgbClr val="000000">
+                <a:alpha val="12000"/>
+              </a:srgbClr>
+            </a:outerShdw>
+          </a:effectLst>
+        </p:spPr>
+      </p:sp>
+      <p:sp>
+        <p:nvSpPr>
+          <p:cNvPr id="16" name="Text 14"/>
+          <p:cNvSpPr txBox="1"/>
+          <p:nvPr/>
+        </p:nvSpPr>
+        <p:spPr>
+          <a:xfrm>
+            <a:off x="777240" y="5129784"/>
+            <a:ext cx="10607040" cy="365760"/>
+          </a:xfrm>
+          <a:prstGeom prst="rect">
+            <a:avLst/>
+          </a:prstGeom>
+          <a:noFill/>
+          <a:ln/>
+        </p:spPr>
+        <p:txBody>
+          <a:bodyPr wrap="square" lIns="0" tIns="0" rIns="0" bIns="0" rtlCol="0" anchor="t"/>
+          <a:lstStyle/>
+          <a:p>
+            <a:pPr indent="0" marL="0">
               <a:buNone/>
             </a:pPr>
             <a:r>
               <a:rPr lang="en-US" sz="1500" dirty="0">
                 <a:solidFill>
-                  <a:schemeClr val="tx2"/>
+                  <a:schemeClr val="tx1"/>
                 </a:solidFill>
               </a:rPr>
-              <a:t>[5] J. H. Saltzer, M. D. Schroeder, "The protection of information in computer systems," Proc. IEEE, 1975.</a:t>
+              <a:t>[5] J. H. Saltzer, M. D. Schroeder, "The protection of information in computer systems," Proc. IEEE, 1975 (full text).</a:t>
             </a:r>
             <a:endParaRPr lang="en-US" sz="1500" dirty="0"/>
           </a:p>
-          <a:p>
-            <a:pPr indent="0" marL="0">
-              <a:spcAft>
-                <a:spcPts val="800"/>
-              </a:spcAft>
-              <a:buNone/>
-            </a:pPr>
-            <a:r>
-              <a:rPr lang="en-US" sz="1500" dirty="0">
-                <a:solidFill>
-                  <a:schemeClr val="tx2"/>
-                </a:solidFill>
-              </a:rPr>
-              <a:t>[9] E. Al-Shaer, H. Hamed, "Discovery of policy anomalies in distributed firewalls," INFOCOM, 2004.</a:t>
-            </a:r>
-            <a:endParaRPr lang="en-US" sz="1500" dirty="0"/>
-          </a:p>
-          <a:p>
-            <a:pPr indent="0" marL="0">
-              <a:spcAft>
-                <a:spcPts val="800"/>
-              </a:spcAft>
-              <a:buNone/>
-            </a:pPr>
-            <a:r>
-              <a:rPr lang="en-US" sz="1500" dirty="0">
-                <a:solidFill>
-                  <a:schemeClr val="tx2"/>
-                </a:solidFill>
-              </a:rPr>
-              <a:t>[10] E. Al-Shaer et al., "Conflict classification and analysis of distributed firewall policies," IEEE JSAC, 2005.</a:t>
-            </a:r>
-            <a:endParaRPr lang="en-US" sz="1500" dirty="0"/>
-          </a:p>
-          <a:p>
-            <a:pPr indent="0" marL="0">
-              <a:spcAft>
-                <a:spcPts val="800"/>
-              </a:spcAft>
-              <a:buNone/>
-            </a:pPr>
-            <a:r>
-              <a:rPr lang="en-US" sz="1500" dirty="0">
-                <a:solidFill>
-                  <a:schemeClr val="tx2"/>
-                </a:solidFill>
-              </a:rPr>
-              <a:t>[11] L. Yuan et al., "FIREMAN: A toolkit for firewall modeling and analysis," IEEE S&amp;P, 2006.</a:t>
-            </a:r>
-            <a:endParaRPr lang="en-US" sz="1500" dirty="0"/>
-          </a:p>
-          <a:p>
-            <a:pPr indent="0" marL="0">
-              <a:spcAft>
-                <a:spcPts val="800"/>
-              </a:spcAft>
-              <a:buNone/>
-            </a:pPr>
-            <a:r>
-              <a:rPr lang="en-US" sz="1500" dirty="0">
-                <a:solidFill>
-                  <a:schemeClr val="tx2"/>
-                </a:solidFill>
-              </a:rPr>
-              <a:t>[13] A. Voronkov et al., "Systematic literature review on usability of firewall configuration," ACM CSUR, 2017.</a:t>
-            </a:r>
-            <a:endParaRPr lang="en-US" sz="1500" dirty="0"/>
-          </a:p>
-          <a:p>
-            <a:pPr indent="0" marL="0">
-              <a:spcAft>
-                <a:spcPts val="800"/>
-              </a:spcAft>
-              <a:buNone/>
-            </a:pPr>
-            <a:r>
-              <a:rPr lang="en-US" sz="1500" dirty="0">
-                <a:solidFill>
-                  <a:schemeClr val="tx2"/>
-                </a:solidFill>
-              </a:rPr>
-              <a:t>[15] R. Chandramouli, "Guide to a secure enterprise network landscape," NIST SP 800-215, 2022.</a:t>
-            </a:r>
-            <a:endParaRPr lang="en-US" sz="1500" dirty="0"/>
-          </a:p>
         </p:txBody>
       </p:sp>
       <p:sp>
         <p:nvSpPr>
-          <p:cNvPr id="4" name="Text 2"/>
+          <p:cNvPr id="17" name="Text 15"/>
           <p:cNvSpPr txBox="1"/>
           <p:nvPr/>
         </p:nvSpPr>
         <p:spPr>
           <a:xfrm>
-            <a:off x="731520" y="5943600"/>
-            <a:ext cx="10789920" cy="365760"/>
+            <a:off x="777240" y="5495544"/>
+            <a:ext cx="10607040" cy="292608"/>
           </a:xfrm>
           <a:prstGeom prst="rect">
             <a:avLst/>
@@ -23430,14 +23850,21 @@
               <a:buNone/>
             </a:pPr>
             <a:r>
-              <a:rPr lang="en-US" sz="1200" i="1" dirty="0">
+              <a:rPr lang="en-US" sz="1300" u="sng" dirty="0">
                 <a:solidFill>
-                  <a:schemeClr val="accent4"/>
+                  <a:schemeClr val="accent5"/>
                 </a:solidFill>
+                <a:hlinkClick r:id="rId5" invalidUrl="" action="" tgtFrame="" tooltip="Open source" history="1" highlightClick="0" endSnd="0">
+                  <a:extLst>
+                    <a:ext uri="{A12FA001-AC4F-418D-AE19-62706E023703}">
+                      <ahyp:hlinkClr xmlns:ahyp="http://schemas.microsoft.com/office/drawing/2018/hyperlinkcolor" val="tx"/>
+                    </a:ext>
+                  </a:extLst>
+                </a:hlinkClick>
               </a:rPr>
-              <a:t>Full list of 18 references in the report (IEEE style).</a:t>
+              <a:t>https://www.cs.virginia.edu/~evans/cs551/saltzer/</a:t>
             </a:r>
-            <a:endParaRPr lang="en-US" sz="1200" dirty="0"/>
+            <a:endParaRPr lang="en-US" sz="1300" dirty="0"/>
           </a:p>
         </p:txBody>
       </p:sp>
@@ -23481,6 +23908,715 @@
             <a:fld id="{F7021451-1387-4CA6-816F-3879F97B5CBC}" type="slidenum">
               <a:rPr b="0" lang="en-US"/>
               <a:t>24</a:t>
+            </a:fld>
+            <a:endParaRPr lang="en-US"/>
+          </a:p>
+        </p:txBody>
+      </p:sp>
+    </p:spTree>
+  </p:cSld>
+  <p:clrMapOvr>
+    <a:masterClrMapping/>
+  </p:clrMapOvr>
+</p:sld>
+</file>
+
+<file path=ppt/slides/slide25.xml><?xml version="1.0" encoding="utf-8"?>
+<p:sld xmlns:a="http://schemas.openxmlformats.org/drawingml/2006/main" xmlns:r="http://schemas.openxmlformats.org/officeDocument/2006/relationships" xmlns:p="http://schemas.openxmlformats.org/presentationml/2006/main">
+  <p:cSld name="Slide 25">
+    <p:spTree>
+      <p:nvGrpSpPr>
+        <p:cNvPr id="1" name=""/>
+        <p:cNvGrpSpPr/>
+        <p:nvPr/>
+      </p:nvGrpSpPr>
+      <p:grpSpPr>
+        <a:xfrm>
+          <a:off x="0" y="0"/>
+          <a:ext cx="0" cy="0"/>
+          <a:chOff x="0" y="0"/>
+          <a:chExt cx="0" cy="0"/>
+        </a:xfrm>
+      </p:grpSpPr>
+      <p:sp>
+        <p:nvSpPr>
+          <p:cNvPr id="2" name="Text 0"/>
+          <p:cNvSpPr/>
+          <p:nvPr>
+            <p:ph idx="100" type="title" hasCustomPrompt="1"/>
+          </p:nvPr>
+        </p:nvSpPr>
+        <p:spPr>
+          <a:xfrm>
+            <a:off x="548640" y="320040"/>
+            <a:ext cx="11064240" cy="822960"/>
+          </a:xfrm>
+          <a:prstGeom prst="rect">
+            <a:avLst/>
+          </a:prstGeom>
+          <a:noFill/>
+          <a:ln/>
+        </p:spPr>
+        <p:txBody>
+          <a:bodyPr wrap="square" rtlCol="0" anchor="ctr"/>
+          <a:lstStyle/>
+          <a:p>
+            <a:pPr indent="0" marL="0">
+              <a:buNone/>
+            </a:pPr>
+            <a:r>
+              <a:rPr lang="en-US" sz="3200" b="1" dirty="0">
+                <a:solidFill>
+                  <a:schemeClr val="tx1"/>
+                </a:solidFill>
+              </a:rPr>
+              <a:t>Key references (2 of 2)</a:t>
+            </a:r>
+            <a:endParaRPr lang="en-US" sz="3200" dirty="0"/>
+          </a:p>
+        </p:txBody>
+      </p:sp>
+      <p:sp>
+        <p:nvSpPr>
+          <p:cNvPr id="3" name="card150"/>
+          <p:cNvSpPr/>
+          <p:nvPr/>
+        </p:nvSpPr>
+        <p:spPr>
+          <a:xfrm>
+            <a:off x="548640" y="1325880"/>
+            <a:ext cx="11064240" cy="804672"/>
+          </a:xfrm>
+          <a:prstGeom prst="roundRect">
+            <a:avLst>
+              <a:gd name="adj" fmla="val 9091"/>
+            </a:avLst>
+          </a:prstGeom>
+          <a:solidFill>
+            <a:schemeClr val="bg2"/>
+          </a:solidFill>
+          <a:ln w="12700">
+            <a:solidFill>
+              <a:schemeClr val="bg2"/>
+            </a:solidFill>
+            <a:prstDash val="solid"/>
+          </a:ln>
+          <a:effectLst>
+            <a:outerShdw sx="100000" sy="100000" kx="0" ky="0" algn="bl" rotWithShape="0" blurRad="76200" dist="25400" dir="5400000">
+              <a:srgbClr val="000000">
+                <a:alpha val="12000"/>
+              </a:srgbClr>
+            </a:outerShdw>
+          </a:effectLst>
+        </p:spPr>
+      </p:sp>
+      <p:sp>
+        <p:nvSpPr>
+          <p:cNvPr id="4" name="Text 2"/>
+          <p:cNvSpPr txBox="1"/>
+          <p:nvPr/>
+        </p:nvSpPr>
+        <p:spPr>
+          <a:xfrm>
+            <a:off x="777240" y="1399032"/>
+            <a:ext cx="10607040" cy="365760"/>
+          </a:xfrm>
+          <a:prstGeom prst="rect">
+            <a:avLst/>
+          </a:prstGeom>
+          <a:noFill/>
+          <a:ln/>
+        </p:spPr>
+        <p:txBody>
+          <a:bodyPr wrap="square" lIns="0" tIns="0" rIns="0" bIns="0" rtlCol="0" anchor="t"/>
+          <a:lstStyle/>
+          <a:p>
+            <a:pPr indent="0" marL="0">
+              <a:buNone/>
+            </a:pPr>
+            <a:r>
+              <a:rPr lang="en-US" sz="1500" dirty="0">
+                <a:solidFill>
+                  <a:schemeClr val="tx1"/>
+                </a:solidFill>
+              </a:rPr>
+              <a:t>[9] E. Al-Shaer, H. Hamed, "Discovery of policy anomalies in distributed firewalls," IEEE INFOCOM, 2004.</a:t>
+            </a:r>
+            <a:endParaRPr lang="en-US" sz="1500" dirty="0"/>
+          </a:p>
+        </p:txBody>
+      </p:sp>
+      <p:sp>
+        <p:nvSpPr>
+          <p:cNvPr id="5" name="Text 3"/>
+          <p:cNvSpPr txBox="1"/>
+          <p:nvPr/>
+        </p:nvSpPr>
+        <p:spPr>
+          <a:xfrm>
+            <a:off x="777240" y="1764792"/>
+            <a:ext cx="10607040" cy="292608"/>
+          </a:xfrm>
+          <a:prstGeom prst="rect">
+            <a:avLst/>
+          </a:prstGeom>
+          <a:noFill/>
+          <a:ln/>
+        </p:spPr>
+        <p:txBody>
+          <a:bodyPr wrap="square" lIns="0" tIns="0" rIns="0" bIns="0" rtlCol="0" anchor="t"/>
+          <a:lstStyle/>
+          <a:p>
+            <a:pPr indent="0" marL="0">
+              <a:buNone/>
+            </a:pPr>
+            <a:r>
+              <a:rPr lang="en-US" sz="1300" u="sng" dirty="0">
+                <a:solidFill>
+                  <a:schemeClr val="accent5"/>
+                </a:solidFill>
+                <a:hlinkClick r:id="rId1" invalidUrl="" action="" tgtFrame="" tooltip="Open source" history="1" highlightClick="0" endSnd="0">
+                  <a:extLst>
+                    <a:ext uri="{A12FA001-AC4F-418D-AE19-62706E023703}">
+                      <ahyp:hlinkClr xmlns:ahyp="http://schemas.microsoft.com/office/drawing/2018/hyperlinkcolor" val="tx"/>
+                    </a:ext>
+                  </a:extLst>
+                </a:hlinkClick>
+              </a:rPr>
+              <a:t>https://pure.kfupm.edu.sa/en/publications/discovery-of-policy-anomalies-in-distributed-firewalls/</a:t>
+            </a:r>
+            <a:endParaRPr lang="en-US" sz="1300" dirty="0"/>
+          </a:p>
+        </p:txBody>
+      </p:sp>
+      <p:sp>
+        <p:nvSpPr>
+          <p:cNvPr id="6" name="card151"/>
+          <p:cNvSpPr/>
+          <p:nvPr/>
+        </p:nvSpPr>
+        <p:spPr>
+          <a:xfrm>
+            <a:off x="548640" y="2258568"/>
+            <a:ext cx="11064240" cy="804672"/>
+          </a:xfrm>
+          <a:prstGeom prst="roundRect">
+            <a:avLst>
+              <a:gd name="adj" fmla="val 9091"/>
+            </a:avLst>
+          </a:prstGeom>
+          <a:solidFill>
+            <a:schemeClr val="bg2"/>
+          </a:solidFill>
+          <a:ln w="12700">
+            <a:solidFill>
+              <a:schemeClr val="bg2"/>
+            </a:solidFill>
+            <a:prstDash val="solid"/>
+          </a:ln>
+          <a:effectLst>
+            <a:outerShdw sx="100000" sy="100000" kx="0" ky="0" algn="bl" rotWithShape="0" blurRad="76200" dist="25400" dir="5400000">
+              <a:srgbClr val="000000">
+                <a:alpha val="12000"/>
+              </a:srgbClr>
+            </a:outerShdw>
+          </a:effectLst>
+        </p:spPr>
+      </p:sp>
+      <p:sp>
+        <p:nvSpPr>
+          <p:cNvPr id="7" name="Text 5"/>
+          <p:cNvSpPr txBox="1"/>
+          <p:nvPr/>
+        </p:nvSpPr>
+        <p:spPr>
+          <a:xfrm>
+            <a:off x="777240" y="2331720"/>
+            <a:ext cx="10607040" cy="365760"/>
+          </a:xfrm>
+          <a:prstGeom prst="rect">
+            <a:avLst/>
+          </a:prstGeom>
+          <a:noFill/>
+          <a:ln/>
+        </p:spPr>
+        <p:txBody>
+          <a:bodyPr wrap="square" lIns="0" tIns="0" rIns="0" bIns="0" rtlCol="0" anchor="t"/>
+          <a:lstStyle/>
+          <a:p>
+            <a:pPr indent="0" marL="0">
+              <a:buNone/>
+            </a:pPr>
+            <a:r>
+              <a:rPr lang="en-US" sz="1500" dirty="0">
+                <a:solidFill>
+                  <a:schemeClr val="tx1"/>
+                </a:solidFill>
+              </a:rPr>
+              <a:t>[10] E. Al-Shaer et al., "Conflict classification and analysis of distributed firewall policies," IEEE JSAC, 2005.</a:t>
+            </a:r>
+            <a:endParaRPr lang="en-US" sz="1500" dirty="0"/>
+          </a:p>
+        </p:txBody>
+      </p:sp>
+      <p:sp>
+        <p:nvSpPr>
+          <p:cNvPr id="8" name="Text 6"/>
+          <p:cNvSpPr txBox="1"/>
+          <p:nvPr/>
+        </p:nvSpPr>
+        <p:spPr>
+          <a:xfrm>
+            <a:off x="777240" y="2697480"/>
+            <a:ext cx="10607040" cy="292608"/>
+          </a:xfrm>
+          <a:prstGeom prst="rect">
+            <a:avLst/>
+          </a:prstGeom>
+          <a:noFill/>
+          <a:ln/>
+        </p:spPr>
+        <p:txBody>
+          <a:bodyPr wrap="square" lIns="0" tIns="0" rIns="0" bIns="0" rtlCol="0" anchor="t"/>
+          <a:lstStyle/>
+          <a:p>
+            <a:pPr indent="0" marL="0">
+              <a:buNone/>
+            </a:pPr>
+            <a:r>
+              <a:rPr lang="en-US" sz="1300" u="sng" dirty="0">
+                <a:solidFill>
+                  <a:schemeClr val="accent5"/>
+                </a:solidFill>
+                <a:hlinkClick r:id="rId2" invalidUrl="" action="" tgtFrame="" tooltip="Open source" history="1" highlightClick="0" endSnd="0">
+                  <a:extLst>
+                    <a:ext uri="{A12FA001-AC4F-418D-AE19-62706E023703}">
+                      <ahyp:hlinkClr xmlns:ahyp="http://schemas.microsoft.com/office/drawing/2018/hyperlinkcolor" val="tx"/>
+                    </a:ext>
+                  </a:extLst>
+                </a:hlinkClick>
+              </a:rPr>
+              <a:t>https://doi.org/10.1109/JSAC.2005.854119</a:t>
+            </a:r>
+            <a:endParaRPr lang="en-US" sz="1300" dirty="0"/>
+          </a:p>
+        </p:txBody>
+      </p:sp>
+      <p:sp>
+        <p:nvSpPr>
+          <p:cNvPr id="9" name="card152"/>
+          <p:cNvSpPr/>
+          <p:nvPr/>
+        </p:nvSpPr>
+        <p:spPr>
+          <a:xfrm>
+            <a:off x="548640" y="3191256"/>
+            <a:ext cx="11064240" cy="804672"/>
+          </a:xfrm>
+          <a:prstGeom prst="roundRect">
+            <a:avLst>
+              <a:gd name="adj" fmla="val 9091"/>
+            </a:avLst>
+          </a:prstGeom>
+          <a:solidFill>
+            <a:schemeClr val="bg2"/>
+          </a:solidFill>
+          <a:ln w="12700">
+            <a:solidFill>
+              <a:schemeClr val="bg2"/>
+            </a:solidFill>
+            <a:prstDash val="solid"/>
+          </a:ln>
+          <a:effectLst>
+            <a:outerShdw sx="100000" sy="100000" kx="0" ky="0" algn="bl" rotWithShape="0" blurRad="76200" dist="25400" dir="5400000">
+              <a:srgbClr val="000000">
+                <a:alpha val="12000"/>
+              </a:srgbClr>
+            </a:outerShdw>
+          </a:effectLst>
+        </p:spPr>
+      </p:sp>
+      <p:sp>
+        <p:nvSpPr>
+          <p:cNvPr id="10" name="Text 8"/>
+          <p:cNvSpPr txBox="1"/>
+          <p:nvPr/>
+        </p:nvSpPr>
+        <p:spPr>
+          <a:xfrm>
+            <a:off x="777240" y="3264408"/>
+            <a:ext cx="10607040" cy="365760"/>
+          </a:xfrm>
+          <a:prstGeom prst="rect">
+            <a:avLst/>
+          </a:prstGeom>
+          <a:noFill/>
+          <a:ln/>
+        </p:spPr>
+        <p:txBody>
+          <a:bodyPr wrap="square" lIns="0" tIns="0" rIns="0" bIns="0" rtlCol="0" anchor="t"/>
+          <a:lstStyle/>
+          <a:p>
+            <a:pPr indent="0" marL="0">
+              <a:buNone/>
+            </a:pPr>
+            <a:r>
+              <a:rPr lang="en-US" sz="1500" dirty="0">
+                <a:solidFill>
+                  <a:schemeClr val="tx1"/>
+                </a:solidFill>
+              </a:rPr>
+              <a:t>[11] L. Yuan et al., "FIREMAN: A toolkit for firewall modeling and analysis," IEEE S&amp;P, 2006.</a:t>
+            </a:r>
+            <a:endParaRPr lang="en-US" sz="1500" dirty="0"/>
+          </a:p>
+        </p:txBody>
+      </p:sp>
+      <p:sp>
+        <p:nvSpPr>
+          <p:cNvPr id="11" name="Text 9"/>
+          <p:cNvSpPr txBox="1"/>
+          <p:nvPr/>
+        </p:nvSpPr>
+        <p:spPr>
+          <a:xfrm>
+            <a:off x="777240" y="3630168"/>
+            <a:ext cx="10607040" cy="292608"/>
+          </a:xfrm>
+          <a:prstGeom prst="rect">
+            <a:avLst/>
+          </a:prstGeom>
+          <a:noFill/>
+          <a:ln/>
+        </p:spPr>
+        <p:txBody>
+          <a:bodyPr wrap="square" lIns="0" tIns="0" rIns="0" bIns="0" rtlCol="0" anchor="t"/>
+          <a:lstStyle/>
+          <a:p>
+            <a:pPr indent="0" marL="0">
+              <a:buNone/>
+            </a:pPr>
+            <a:r>
+              <a:rPr lang="en-US" sz="1300" u="sng" dirty="0">
+                <a:solidFill>
+                  <a:schemeClr val="accent5"/>
+                </a:solidFill>
+                <a:hlinkClick r:id="rId3" invalidUrl="" action="" tgtFrame="" tooltip="Open source" history="1" highlightClick="0" endSnd="0">
+                  <a:extLst>
+                    <a:ext uri="{A12FA001-AC4F-418D-AE19-62706E023703}">
+                      <ahyp:hlinkClr xmlns:ahyp="http://schemas.microsoft.com/office/drawing/2018/hyperlinkcolor" val="tx"/>
+                    </a:ext>
+                  </a:extLst>
+                </a:hlinkClick>
+              </a:rPr>
+              <a:t>https://doi.org/10.1109/SP.2006.16</a:t>
+            </a:r>
+            <a:endParaRPr lang="en-US" sz="1300" dirty="0"/>
+          </a:p>
+        </p:txBody>
+      </p:sp>
+      <p:sp>
+        <p:nvSpPr>
+          <p:cNvPr id="12" name="card153"/>
+          <p:cNvSpPr/>
+          <p:nvPr/>
+        </p:nvSpPr>
+        <p:spPr>
+          <a:xfrm>
+            <a:off x="548640" y="4123944"/>
+            <a:ext cx="11064240" cy="804672"/>
+          </a:xfrm>
+          <a:prstGeom prst="roundRect">
+            <a:avLst>
+              <a:gd name="adj" fmla="val 9091"/>
+            </a:avLst>
+          </a:prstGeom>
+          <a:solidFill>
+            <a:schemeClr val="bg2"/>
+          </a:solidFill>
+          <a:ln w="12700">
+            <a:solidFill>
+              <a:schemeClr val="bg2"/>
+            </a:solidFill>
+            <a:prstDash val="solid"/>
+          </a:ln>
+          <a:effectLst>
+            <a:outerShdw sx="100000" sy="100000" kx="0" ky="0" algn="bl" rotWithShape="0" blurRad="76200" dist="25400" dir="5400000">
+              <a:srgbClr val="000000">
+                <a:alpha val="12000"/>
+              </a:srgbClr>
+            </a:outerShdw>
+          </a:effectLst>
+        </p:spPr>
+      </p:sp>
+      <p:sp>
+        <p:nvSpPr>
+          <p:cNvPr id="13" name="Text 11"/>
+          <p:cNvSpPr txBox="1"/>
+          <p:nvPr/>
+        </p:nvSpPr>
+        <p:spPr>
+          <a:xfrm>
+            <a:off x="777240" y="4197096"/>
+            <a:ext cx="10607040" cy="365760"/>
+          </a:xfrm>
+          <a:prstGeom prst="rect">
+            <a:avLst/>
+          </a:prstGeom>
+          <a:noFill/>
+          <a:ln/>
+        </p:spPr>
+        <p:txBody>
+          <a:bodyPr wrap="square" lIns="0" tIns="0" rIns="0" bIns="0" rtlCol="0" anchor="t"/>
+          <a:lstStyle/>
+          <a:p>
+            <a:pPr indent="0" marL="0">
+              <a:buNone/>
+            </a:pPr>
+            <a:r>
+              <a:rPr lang="en-US" sz="1500" dirty="0">
+                <a:solidFill>
+                  <a:schemeClr val="tx1"/>
+                </a:solidFill>
+              </a:rPr>
+              <a:t>[13] A. Voronkov et al., "Systematic literature review on usability of firewall configuration," ACM CSUR, 2017.</a:t>
+            </a:r>
+            <a:endParaRPr lang="en-US" sz="1500" dirty="0"/>
+          </a:p>
+        </p:txBody>
+      </p:sp>
+      <p:sp>
+        <p:nvSpPr>
+          <p:cNvPr id="14" name="Text 12"/>
+          <p:cNvSpPr txBox="1"/>
+          <p:nvPr/>
+        </p:nvSpPr>
+        <p:spPr>
+          <a:xfrm>
+            <a:off x="777240" y="4562856"/>
+            <a:ext cx="10607040" cy="292608"/>
+          </a:xfrm>
+          <a:prstGeom prst="rect">
+            <a:avLst/>
+          </a:prstGeom>
+          <a:noFill/>
+          <a:ln/>
+        </p:spPr>
+        <p:txBody>
+          <a:bodyPr wrap="square" lIns="0" tIns="0" rIns="0" bIns="0" rtlCol="0" anchor="t"/>
+          <a:lstStyle/>
+          <a:p>
+            <a:pPr indent="0" marL="0">
+              <a:buNone/>
+            </a:pPr>
+            <a:r>
+              <a:rPr lang="en-US" sz="1300" u="sng" dirty="0">
+                <a:solidFill>
+                  <a:schemeClr val="accent5"/>
+                </a:solidFill>
+                <a:hlinkClick r:id="rId4" invalidUrl="" action="" tgtFrame="" tooltip="Open source" history="1" highlightClick="0" endSnd="0">
+                  <a:extLst>
+                    <a:ext uri="{A12FA001-AC4F-418D-AE19-62706E023703}">
+                      <ahyp:hlinkClr xmlns:ahyp="http://schemas.microsoft.com/office/drawing/2018/hyperlinkcolor" val="tx"/>
+                    </a:ext>
+                  </a:extLst>
+                </a:hlinkClick>
+              </a:rPr>
+              <a:t>https://doi.org/10.1145/3130876</a:t>
+            </a:r>
+            <a:endParaRPr lang="en-US" sz="1300" dirty="0"/>
+          </a:p>
+        </p:txBody>
+      </p:sp>
+      <p:sp>
+        <p:nvSpPr>
+          <p:cNvPr id="15" name="card154"/>
+          <p:cNvSpPr/>
+          <p:nvPr/>
+        </p:nvSpPr>
+        <p:spPr>
+          <a:xfrm>
+            <a:off x="548640" y="5056632"/>
+            <a:ext cx="11064240" cy="804672"/>
+          </a:xfrm>
+          <a:prstGeom prst="roundRect">
+            <a:avLst>
+              <a:gd name="adj" fmla="val 9091"/>
+            </a:avLst>
+          </a:prstGeom>
+          <a:solidFill>
+            <a:schemeClr val="bg2"/>
+          </a:solidFill>
+          <a:ln w="12700">
+            <a:solidFill>
+              <a:schemeClr val="bg2"/>
+            </a:solidFill>
+            <a:prstDash val="solid"/>
+          </a:ln>
+          <a:effectLst>
+            <a:outerShdw sx="100000" sy="100000" kx="0" ky="0" algn="bl" rotWithShape="0" blurRad="76200" dist="25400" dir="5400000">
+              <a:srgbClr val="000000">
+                <a:alpha val="12000"/>
+              </a:srgbClr>
+            </a:outerShdw>
+          </a:effectLst>
+        </p:spPr>
+      </p:sp>
+      <p:sp>
+        <p:nvSpPr>
+          <p:cNvPr id="16" name="Text 14"/>
+          <p:cNvSpPr txBox="1"/>
+          <p:nvPr/>
+        </p:nvSpPr>
+        <p:spPr>
+          <a:xfrm>
+            <a:off x="777240" y="5129784"/>
+            <a:ext cx="10607040" cy="365760"/>
+          </a:xfrm>
+          <a:prstGeom prst="rect">
+            <a:avLst/>
+          </a:prstGeom>
+          <a:noFill/>
+          <a:ln/>
+        </p:spPr>
+        <p:txBody>
+          <a:bodyPr wrap="square" lIns="0" tIns="0" rIns="0" bIns="0" rtlCol="0" anchor="t"/>
+          <a:lstStyle/>
+          <a:p>
+            <a:pPr indent="0" marL="0">
+              <a:buNone/>
+            </a:pPr>
+            <a:r>
+              <a:rPr lang="en-US" sz="1500" dirty="0">
+                <a:solidFill>
+                  <a:schemeClr val="tx1"/>
+                </a:solidFill>
+              </a:rPr>
+              <a:t>[15] R. Chandramouli, "Guide to a secure enterprise network landscape," NIST SP 800-215, 2022.</a:t>
+            </a:r>
+            <a:endParaRPr lang="en-US" sz="1500" dirty="0"/>
+          </a:p>
+        </p:txBody>
+      </p:sp>
+      <p:sp>
+        <p:nvSpPr>
+          <p:cNvPr id="17" name="Text 15"/>
+          <p:cNvSpPr txBox="1"/>
+          <p:nvPr/>
+        </p:nvSpPr>
+        <p:spPr>
+          <a:xfrm>
+            <a:off x="777240" y="5495544"/>
+            <a:ext cx="10607040" cy="292608"/>
+          </a:xfrm>
+          <a:prstGeom prst="rect">
+            <a:avLst/>
+          </a:prstGeom>
+          <a:noFill/>
+          <a:ln/>
+        </p:spPr>
+        <p:txBody>
+          <a:bodyPr wrap="square" lIns="0" tIns="0" rIns="0" bIns="0" rtlCol="0" anchor="t"/>
+          <a:lstStyle/>
+          <a:p>
+            <a:pPr indent="0" marL="0">
+              <a:buNone/>
+            </a:pPr>
+            <a:r>
+              <a:rPr lang="en-US" sz="1300" u="sng" dirty="0">
+                <a:solidFill>
+                  <a:schemeClr val="accent5"/>
+                </a:solidFill>
+                <a:hlinkClick r:id="rId5" invalidUrl="" action="" tgtFrame="" tooltip="Open source" history="1" highlightClick="0" endSnd="0">
+                  <a:extLst>
+                    <a:ext uri="{A12FA001-AC4F-418D-AE19-62706E023703}">
+                      <ahyp:hlinkClr xmlns:ahyp="http://schemas.microsoft.com/office/drawing/2018/hyperlinkcolor" val="tx"/>
+                    </a:ext>
+                  </a:extLst>
+                </a:hlinkClick>
+              </a:rPr>
+              <a:t>https://doi.org/10.6028/NIST.SP.800-215</a:t>
+            </a:r>
+            <a:endParaRPr lang="en-US" sz="1300" dirty="0"/>
+          </a:p>
+        </p:txBody>
+      </p:sp>
+      <p:sp>
+        <p:nvSpPr>
+          <p:cNvPr id="18" name="Text 16"/>
+          <p:cNvSpPr txBox="1"/>
+          <p:nvPr/>
+        </p:nvSpPr>
+        <p:spPr>
+          <a:xfrm>
+            <a:off x="548640" y="6035040"/>
+            <a:ext cx="11064240" cy="365760"/>
+          </a:xfrm>
+          <a:prstGeom prst="rect">
+            <a:avLst/>
+          </a:prstGeom>
+          <a:noFill/>
+          <a:ln/>
+        </p:spPr>
+        <p:txBody>
+          <a:bodyPr wrap="square" lIns="0" tIns="0" rIns="0" bIns="0" rtlCol="0" anchor="t"/>
+          <a:lstStyle/>
+          <a:p>
+            <a:pPr indent="0" marL="0">
+              <a:buNone/>
+            </a:pPr>
+            <a:r>
+              <a:rPr lang="en-US" sz="1200" i="1" dirty="0">
+                <a:solidFill>
+                  <a:schemeClr val="accent4"/>
+                </a:solidFill>
+              </a:rPr>
+              <a:t>Full list of 18 references in the report (IEEE style). Links: DOI where available, otherwise publisher, repository or full-text page.</a:t>
+            </a:r>
+            <a:endParaRPr lang="en-US" sz="1200" dirty="0"/>
+          </a:p>
+        </p:txBody>
+      </p:sp>
+      <p:sp>
+        <p:nvSpPr>
+          <p:cNvPr id="25" name="Slide Number Placeholder 0"/>
+          <p:cNvSpPr>
+            <a:spLocks noGrp="1"/>
+          </p:cNvSpPr>
+          <p:nvPr>
+            <p:ph type="sldNum" sz="quarter" idx="4294967295"/>
+          </p:nvPr>
+        </p:nvSpPr>
+        <p:spPr>
+          <a:xfrm>
+            <a:off x="11338560" y="6400800"/>
+            <a:ext cx="548640" cy="274320"/>
+          </a:xfrm>
+          <a:prstGeom prst="rect">
+            <a:avLst/>
+          </a:prstGeom>
+          <a:extLst>
+            <a:ext uri="{C572A759-6A51-4108-AA02-DFA0A04FC94B}">
+              <ma14:wrappingTextBoxFlag xmlns:ma14="http://schemas.microsoft.com/office/mac/drawingml/2011/main" val="0"/>
+            </a:ext>
+          </a:extLst>
+        </p:spPr>
+        <p:txBody>
+          <a:bodyPr/>
+          <a:lstStyle>
+            <a:lvl1pPr>
+              <a:defRPr sz="1000">
+                <a:solidFill>
+                  <a:schemeClr val="accent6"/>
+                </a:solidFill>
+              </a:defRPr>
+            </a:lvl1pPr>
+          </a:lstStyle>
+          <a:p>
+            <a:pPr algn="l"/>
+            <a:fld id="{F7021451-1387-4CA6-816F-3879F97B5CBC}" type="slidenum">
+              <a:rPr b="0" lang="en-US"/>
+              <a:t>25</a:t>
             </a:fld>
             <a:endParaRPr lang="en-US"/>
           </a:p>

</xml_diff>

<commit_message>
Add links for all 18 references in report and presentation
Report: every reference ends with a clickable DOI or URL.
Presentation: all 18 references with links over three slides.

Co-Authored-By: Claude Opus 5.5 <noreply@anthropic.com>
Claude-Session: https://claude.ai/code/session_01VZE4XfkebTWLatWpMU9HD1
</commit_message>
<xml_diff>
--- a/report/case-study-presentation.pptx
+++ b/report/case-study-presentation.pptx
@@ -30,9 +30,10 @@
     <p:sldId id="278" r:id="rId24"/>
     <p:sldId id="279" r:id="rId25"/>
     <p:sldId id="280" r:id="rId26"/>
+    <p:sldId id="281" r:id="rId27"/>
   </p:sldIdLst>
   <p:notesMasterIdLst>
-    <p:notesMasterId r:id="rId27"/>
+    <p:notesMasterId r:id="rId28"/>
   </p:notesMasterIdLst>
   <p:sldSz cx="12192000" cy="6858000"/>
   <p:notesSz cx="6858000" cy="12192000"/>
@@ -131,7 +132,7 @@
   <p:extLst>
     <p:ext uri="{521415D9-36F7-43E2-AB2F-B90AF26B5E84}">
       <p14:sectionLst xmlns:p14="http://schemas.microsoft.com/office/powerpoint/2010/main">
-        <p14:section name="Introduction" id="{765ca505-2e53-78c2-7be1-50ee4c76c7f0}">
+        <p14:section name="Introduction" id="{b5b31547-8c20-f411-4d76-25384bd6c03e}">
           <p14:sldIdLst>
             <p14:sldId id="256"/>
             <p14:sldId id="257"/>
@@ -139,13 +140,13 @@
             <p14:sldId id="259"/>
           </p14:sldIdLst>
         </p14:section>
-        <p14:section name="Part A: Literature" id="{b8f7cac3-3fd5-2bd7-28cd-d24b92b3aa97}">
+        <p14:section name="Part A: Literature" id="{aefce44b-373d-60eb-8d7f-d396bf9303a5}">
           <p14:sldIdLst>
             <p14:sldId id="260"/>
             <p14:sldId id="261"/>
           </p14:sldIdLst>
         </p14:section>
-        <p14:section name="Part B: Design" id="{c1e06a2a-60ab-7b34-fb94-29c826c97648}">
+        <p14:section name="Part B: Design" id="{be3ceb07-a4b0-3511-fb16-8c94ef208096}">
           <p14:sldIdLst>
             <p14:sldId id="262"/>
             <p14:sldId id="263"/>
@@ -154,7 +155,7 @@
             <p14:sldId id="266"/>
           </p14:sldIdLst>
         </p14:section>
-        <p14:section name="Part B: Results" id="{3a32cfd9-2884-cc53-7945-b808af5e7c10}">
+        <p14:section name="Part B: Results" id="{13d557aa-ab3a-3dce-7242-02cc3d0d4285}">
           <p14:sldIdLst>
             <p14:sldId id="267"/>
             <p14:sldId id="268"/>
@@ -166,7 +167,7 @@
             <p14:sldId id="274"/>
           </p14:sldIdLst>
         </p14:section>
-        <p14:section name="Part C and conclusion" id="{b248d7d8-647a-94ef-68c8-e9716642d5f7}">
+        <p14:section name="Part C and conclusion" id="{144ff620-3f90-9280-e9ba-ba37755a6e59}">
           <p14:sldIdLst>
             <p14:sldId id="275"/>
             <p14:sldId id="276"/>
@@ -174,6 +175,7 @@
             <p14:sldId id="278"/>
             <p14:sldId id="279"/>
             <p14:sldId id="280"/>
+            <p14:sldId id="281"/>
           </p14:sldIdLst>
         </p14:section>
       </p14:sectionLst>
@@ -2473,6 +2475,94 @@
             <a:fld id="{F7021451-1387-4CA6-816F-3879F97B5CBC}" type="slidenum">
               <a:rPr lang="en-US"/>
               <a:t>25</a:t>
+            </a:fld>
+            <a:endParaRPr lang="en-US"/>
+          </a:p>
+        </p:txBody>
+      </p:sp>
+    </p:spTree>
+    <p:extLst>
+      <p:ext uri="{BB962C8B-B14F-4D97-AF65-F5344CB8AC3E}">
+        <p14:creationId xmlns:p14="http://schemas.microsoft.com/office/powerpoint/2010/main" val="1024086991"/>
+      </p:ext>
+    </p:extLst>
+  </p:cSld>
+  <p:clrMapOvr>
+    <a:masterClrMapping/>
+  </p:clrMapOvr>
+</p:notes>
+</file>
+
+<file path=ppt/notesSlides/notesSlide26.xml><?xml version="1.0" encoding="utf-8"?>
+<p:notes xmlns:a="http://schemas.openxmlformats.org/drawingml/2006/main" xmlns:r="http://schemas.openxmlformats.org/officeDocument/2006/relationships" xmlns:p="http://schemas.openxmlformats.org/presentationml/2006/main">
+  <p:cSld>
+    <p:spTree>
+      <p:nvGrpSpPr>
+        <p:cNvPr id="1" name=""/>
+        <p:cNvGrpSpPr/>
+        <p:nvPr/>
+      </p:nvGrpSpPr>
+      <p:grpSpPr>
+        <a:xfrm>
+          <a:off x="0" y="0"/>
+          <a:ext cx="0" cy="0"/>
+          <a:chOff x="0" y="0"/>
+          <a:chExt cx="0" cy="0"/>
+        </a:xfrm>
+      </p:grpSpPr>
+      <p:sp>
+        <p:nvSpPr>
+          <p:cNvPr id="2" name="Slide Image Placeholder 1"/>
+          <p:cNvSpPr>
+            <a:spLocks noGrp="1" noRot="1" noChangeAspect="1"/>
+          </p:cNvSpPr>
+          <p:nvPr>
+            <p:ph type="sldImg"/>
+          </p:nvPr>
+        </p:nvSpPr>
+        <p:spPr/>
+      </p:sp>
+      <p:sp>
+        <p:nvSpPr>
+          <p:cNvPr id="3" name="Notes Placeholder 2"/>
+          <p:cNvSpPr>
+            <a:spLocks noGrp="1"/>
+          </p:cNvSpPr>
+          <p:nvPr>
+            <p:ph type="body" idx="1"/>
+          </p:nvPr>
+        </p:nvSpPr>
+        <p:spPr/>
+        <p:txBody>
+          <a:bodyPr/>
+          <a:lstStyle/>
+          <a:p>
+            <a:r>
+              <a:rPr lang="en-US" dirty="0"/>
+              <a:t>Links are clickable in slideshow mode.</a:t>
+            </a:r>
+            <a:endParaRPr lang="en-US" dirty="0"/>
+          </a:p>
+        </p:txBody>
+      </p:sp>
+      <p:sp>
+        <p:nvSpPr>
+          <p:cNvPr id="4" name="Slide Number Placeholder 3"/>
+          <p:cNvSpPr>
+            <a:spLocks noGrp="1"/>
+          </p:cNvSpPr>
+          <p:nvPr>
+            <p:ph type="sldNum" sz="quarter" idx="10"/>
+          </p:nvPr>
+        </p:nvSpPr>
+        <p:spPr/>
+        <p:txBody>
+          <a:bodyPr/>
+          <a:lstStyle/>
+          <a:p>
+            <a:fld id="{F7021451-1387-4CA6-816F-3879F97B5CBC}" type="slidenum">
+              <a:rPr lang="en-US"/>
+              <a:t>26</a:t>
             </a:fld>
             <a:endParaRPr lang="en-US"/>
           </a:p>
@@ -23297,7 +23387,7 @@
                   <a:schemeClr val="tx1"/>
                 </a:solidFill>
               </a:rPr>
-              <a:t>Key references (1 of 2)</a:t>
+              <a:t>References (1 of 3)</a:t>
             </a:r>
             <a:endParaRPr lang="en-US" sz="3200" dirty="0"/>
           </a:p>
@@ -23311,12 +23401,12 @@
         </p:nvSpPr>
         <p:spPr>
           <a:xfrm>
-            <a:off x="548640" y="1325880"/>
-            <a:ext cx="11064240" cy="804672"/>
+            <a:off x="548640" y="1234440"/>
+            <a:ext cx="11064240" cy="713232"/>
           </a:xfrm>
           <a:prstGeom prst="roundRect">
             <a:avLst>
-              <a:gd name="adj" fmla="val 9091"/>
+              <a:gd name="adj" fmla="val 10256"/>
             </a:avLst>
           </a:prstGeom>
           <a:solidFill>
@@ -23345,8 +23435,8 @@
         </p:nvSpPr>
         <p:spPr>
           <a:xfrm>
-            <a:off x="777240" y="1399032"/>
-            <a:ext cx="10607040" cy="365760"/>
+            <a:off x="777240" y="1289304"/>
+            <a:ext cx="10607040" cy="329184"/>
           </a:xfrm>
           <a:prstGeom prst="rect">
             <a:avLst/>
@@ -23362,14 +23452,14 @@
               <a:buNone/>
             </a:pPr>
             <a:r>
-              <a:rPr lang="en-US" sz="1500" dirty="0">
+              <a:rPr lang="en-US" sz="1400" dirty="0">
                 <a:solidFill>
                   <a:schemeClr val="tx1"/>
                 </a:solidFill>
               </a:rPr>
               <a:t>[1] A. Wool, "A quantitative study of firewall configuration errors," Computer, 37(6), 2004.</a:t>
             </a:r>
-            <a:endParaRPr lang="en-US" sz="1500" dirty="0"/>
+            <a:endParaRPr lang="en-US" sz="1400" dirty="0"/>
           </a:p>
         </p:txBody>
       </p:sp>
@@ -23381,8 +23471,8 @@
         </p:nvSpPr>
         <p:spPr>
           <a:xfrm>
-            <a:off x="777240" y="1764792"/>
-            <a:ext cx="10607040" cy="292608"/>
+            <a:off x="777240" y="1627632"/>
+            <a:ext cx="10607040" cy="274320"/>
           </a:xfrm>
           <a:prstGeom prst="rect">
             <a:avLst/>
@@ -23398,7 +23488,7 @@
               <a:buNone/>
             </a:pPr>
             <a:r>
-              <a:rPr lang="en-US" sz="1300" u="sng" dirty="0">
+              <a:rPr lang="en-US" sz="1200" u="sng" dirty="0">
                 <a:solidFill>
                   <a:schemeClr val="accent5"/>
                 </a:solidFill>
@@ -23412,7 +23502,7 @@
               </a:rPr>
               <a:t>https://ieeexplore.ieee.org/document/1306389</a:t>
             </a:r>
-            <a:endParaRPr lang="en-US" sz="1300" dirty="0"/>
+            <a:endParaRPr lang="en-US" sz="1200" dirty="0"/>
           </a:p>
         </p:txBody>
       </p:sp>
@@ -23424,12 +23514,12 @@
         </p:nvSpPr>
         <p:spPr>
           <a:xfrm>
-            <a:off x="548640" y="2258568"/>
-            <a:ext cx="11064240" cy="804672"/>
+            <a:off x="548640" y="2039112"/>
+            <a:ext cx="11064240" cy="713232"/>
           </a:xfrm>
           <a:prstGeom prst="roundRect">
             <a:avLst>
-              <a:gd name="adj" fmla="val 9091"/>
+              <a:gd name="adj" fmla="val 10256"/>
             </a:avLst>
           </a:prstGeom>
           <a:solidFill>
@@ -23458,8 +23548,8 @@
         </p:nvSpPr>
         <p:spPr>
           <a:xfrm>
-            <a:off x="777240" y="2331720"/>
-            <a:ext cx="10607040" cy="365760"/>
+            <a:off x="777240" y="2093976"/>
+            <a:ext cx="10607040" cy="329184"/>
           </a:xfrm>
           <a:prstGeom prst="rect">
             <a:avLst/>
@@ -23475,14 +23565,14 @@
               <a:buNone/>
             </a:pPr>
             <a:r>
-              <a:rPr lang="en-US" sz="1500" dirty="0">
+              <a:rPr lang="en-US" sz="1400" dirty="0">
                 <a:solidFill>
                   <a:schemeClr val="tx1"/>
                 </a:solidFill>
               </a:rPr>
               <a:t>[2] A. Wool, "Trends in firewall configuration errors," IEEE Internet Computing, 14(4), 2010 (extended version).</a:t>
             </a:r>
-            <a:endParaRPr lang="en-US" sz="1500" dirty="0"/>
+            <a:endParaRPr lang="en-US" sz="1400" dirty="0"/>
           </a:p>
         </p:txBody>
       </p:sp>
@@ -23494,8 +23584,8 @@
         </p:nvSpPr>
         <p:spPr>
           <a:xfrm>
-            <a:off x="777240" y="2697480"/>
-            <a:ext cx="10607040" cy="292608"/>
+            <a:off x="777240" y="2432304"/>
+            <a:ext cx="10607040" cy="274320"/>
           </a:xfrm>
           <a:prstGeom prst="rect">
             <a:avLst/>
@@ -23511,7 +23601,7 @@
               <a:buNone/>
             </a:pPr>
             <a:r>
-              <a:rPr lang="en-US" sz="1300" u="sng" dirty="0">
+              <a:rPr lang="en-US" sz="1200" u="sng" dirty="0">
                 <a:solidFill>
                   <a:schemeClr val="accent5"/>
                 </a:solidFill>
@@ -23525,7 +23615,7 @@
               </a:rPr>
               <a:t>https://arxiv.org/abs/0911.1240</a:t>
             </a:r>
-            <a:endParaRPr lang="en-US" sz="1300" dirty="0"/>
+            <a:endParaRPr lang="en-US" sz="1200" dirty="0"/>
           </a:p>
         </p:txBody>
       </p:sp>
@@ -23537,12 +23627,12 @@
         </p:nvSpPr>
         <p:spPr>
           <a:xfrm>
-            <a:off x="548640" y="3191256"/>
-            <a:ext cx="11064240" cy="804672"/>
+            <a:off x="548640" y="2843784"/>
+            <a:ext cx="11064240" cy="713232"/>
           </a:xfrm>
           <a:prstGeom prst="roundRect">
             <a:avLst>
-              <a:gd name="adj" fmla="val 9091"/>
+              <a:gd name="adj" fmla="val 10256"/>
             </a:avLst>
           </a:prstGeom>
           <a:solidFill>
@@ -23571,8 +23661,8 @@
         </p:nvSpPr>
         <p:spPr>
           <a:xfrm>
-            <a:off x="777240" y="3264408"/>
-            <a:ext cx="10607040" cy="365760"/>
+            <a:off x="777240" y="2898648"/>
+            <a:ext cx="10607040" cy="329184"/>
           </a:xfrm>
           <a:prstGeom prst="rect">
             <a:avLst/>
@@ -23588,14 +23678,14 @@
               <a:buNone/>
             </a:pPr>
             <a:r>
-              <a:rPr lang="en-US" sz="1500" dirty="0">
+              <a:rPr lang="en-US" sz="1400" dirty="0">
                 <a:solidFill>
                   <a:schemeClr val="tx1"/>
                 </a:solidFill>
               </a:rPr>
               <a:t>[3] K. Scarfone, P. Hoffman, "Guidelines on firewalls and firewall policy," NIST SP 800-41 Rev. 1, 2009.</a:t>
             </a:r>
-            <a:endParaRPr lang="en-US" sz="1500" dirty="0"/>
+            <a:endParaRPr lang="en-US" sz="1400" dirty="0"/>
           </a:p>
         </p:txBody>
       </p:sp>
@@ -23607,8 +23697,8 @@
         </p:nvSpPr>
         <p:spPr>
           <a:xfrm>
-            <a:off x="777240" y="3630168"/>
-            <a:ext cx="10607040" cy="292608"/>
+            <a:off x="777240" y="3236976"/>
+            <a:ext cx="10607040" cy="274320"/>
           </a:xfrm>
           <a:prstGeom prst="rect">
             <a:avLst/>
@@ -23624,7 +23714,7 @@
               <a:buNone/>
             </a:pPr>
             <a:r>
-              <a:rPr lang="en-US" sz="1300" u="sng" dirty="0">
+              <a:rPr lang="en-US" sz="1200" u="sng" dirty="0">
                 <a:solidFill>
                   <a:schemeClr val="accent5"/>
                 </a:solidFill>
@@ -23638,7 +23728,7 @@
               </a:rPr>
               <a:t>https://doi.org/10.6028/NIST.SP.800-41r1</a:t>
             </a:r>
-            <a:endParaRPr lang="en-US" sz="1300" dirty="0"/>
+            <a:endParaRPr lang="en-US" sz="1200" dirty="0"/>
           </a:p>
         </p:txBody>
       </p:sp>
@@ -23650,12 +23740,12 @@
         </p:nvSpPr>
         <p:spPr>
           <a:xfrm>
-            <a:off x="548640" y="4123944"/>
-            <a:ext cx="11064240" cy="804672"/>
+            <a:off x="548640" y="3648456"/>
+            <a:ext cx="11064240" cy="713232"/>
           </a:xfrm>
           <a:prstGeom prst="roundRect">
             <a:avLst>
-              <a:gd name="adj" fmla="val 9091"/>
+              <a:gd name="adj" fmla="val 10256"/>
             </a:avLst>
           </a:prstGeom>
           <a:solidFill>
@@ -23684,8 +23774,8 @@
         </p:nvSpPr>
         <p:spPr>
           <a:xfrm>
-            <a:off x="777240" y="4197096"/>
-            <a:ext cx="10607040" cy="365760"/>
+            <a:off x="777240" y="3703320"/>
+            <a:ext cx="10607040" cy="329184"/>
           </a:xfrm>
           <a:prstGeom prst="rect">
             <a:avLst/>
@@ -23701,14 +23791,14 @@
               <a:buNone/>
             </a:pPr>
             <a:r>
-              <a:rPr lang="en-US" sz="1500" dirty="0">
+              <a:rPr lang="en-US" sz="1400" dirty="0">
                 <a:solidFill>
                   <a:schemeClr val="tx1"/>
                 </a:solidFill>
               </a:rPr>
               <a:t>[4] S. Rose et al., "Zero trust architecture," NIST SP 800-207, 2020.</a:t>
             </a:r>
-            <a:endParaRPr lang="en-US" sz="1500" dirty="0"/>
+            <a:endParaRPr lang="en-US" sz="1400" dirty="0"/>
           </a:p>
         </p:txBody>
       </p:sp>
@@ -23720,8 +23810,8 @@
         </p:nvSpPr>
         <p:spPr>
           <a:xfrm>
-            <a:off x="777240" y="4562856"/>
-            <a:ext cx="10607040" cy="292608"/>
+            <a:off x="777240" y="4041648"/>
+            <a:ext cx="10607040" cy="274320"/>
           </a:xfrm>
           <a:prstGeom prst="rect">
             <a:avLst/>
@@ -23737,7 +23827,7 @@
               <a:buNone/>
             </a:pPr>
             <a:r>
-              <a:rPr lang="en-US" sz="1300" u="sng" dirty="0">
+              <a:rPr lang="en-US" sz="1200" u="sng" dirty="0">
                 <a:solidFill>
                   <a:schemeClr val="accent5"/>
                 </a:solidFill>
@@ -23751,7 +23841,7 @@
               </a:rPr>
               <a:t>https://doi.org/10.6028/NIST.SP.800-207</a:t>
             </a:r>
-            <a:endParaRPr lang="en-US" sz="1300" dirty="0"/>
+            <a:endParaRPr lang="en-US" sz="1200" dirty="0"/>
           </a:p>
         </p:txBody>
       </p:sp>
@@ -23763,12 +23853,12 @@
         </p:nvSpPr>
         <p:spPr>
           <a:xfrm>
-            <a:off x="548640" y="5056632"/>
-            <a:ext cx="11064240" cy="804672"/>
+            <a:off x="548640" y="4453128"/>
+            <a:ext cx="11064240" cy="713232"/>
           </a:xfrm>
           <a:prstGeom prst="roundRect">
             <a:avLst>
-              <a:gd name="adj" fmla="val 9091"/>
+              <a:gd name="adj" fmla="val 10256"/>
             </a:avLst>
           </a:prstGeom>
           <a:solidFill>
@@ -23797,8 +23887,8 @@
         </p:nvSpPr>
         <p:spPr>
           <a:xfrm>
-            <a:off x="777240" y="5129784"/>
-            <a:ext cx="10607040" cy="365760"/>
+            <a:off x="777240" y="4507992"/>
+            <a:ext cx="10607040" cy="329184"/>
           </a:xfrm>
           <a:prstGeom prst="rect">
             <a:avLst/>
@@ -23814,14 +23904,14 @@
               <a:buNone/>
             </a:pPr>
             <a:r>
-              <a:rPr lang="en-US" sz="1500" dirty="0">
+              <a:rPr lang="en-US" sz="1400" dirty="0">
                 <a:solidFill>
                   <a:schemeClr val="tx1"/>
                 </a:solidFill>
               </a:rPr>
               <a:t>[5] J. H. Saltzer, M. D. Schroeder, "The protection of information in computer systems," Proc. IEEE, 1975 (full text).</a:t>
             </a:r>
-            <a:endParaRPr lang="en-US" sz="1500" dirty="0"/>
+            <a:endParaRPr lang="en-US" sz="1400" dirty="0"/>
           </a:p>
         </p:txBody>
       </p:sp>
@@ -23833,8 +23923,8 @@
         </p:nvSpPr>
         <p:spPr>
           <a:xfrm>
-            <a:off x="777240" y="5495544"/>
-            <a:ext cx="10607040" cy="292608"/>
+            <a:off x="777240" y="4846320"/>
+            <a:ext cx="10607040" cy="274320"/>
           </a:xfrm>
           <a:prstGeom prst="rect">
             <a:avLst/>
@@ -23850,7 +23940,7 @@
               <a:buNone/>
             </a:pPr>
             <a:r>
-              <a:rPr lang="en-US" sz="1300" u="sng" dirty="0">
+              <a:rPr lang="en-US" sz="1200" u="sng" dirty="0">
                 <a:solidFill>
                   <a:schemeClr val="accent5"/>
                 </a:solidFill>
@@ -23864,7 +23954,120 @@
               </a:rPr>
               <a:t>https://www.cs.virginia.edu/~evans/cs551/saltzer/</a:t>
             </a:r>
-            <a:endParaRPr lang="en-US" sz="1300" dirty="0"/>
+            <a:endParaRPr lang="en-US" sz="1200" dirty="0"/>
+          </a:p>
+        </p:txBody>
+      </p:sp>
+      <p:sp>
+        <p:nvSpPr>
+          <p:cNvPr id="18" name="card150"/>
+          <p:cNvSpPr/>
+          <p:nvPr/>
+        </p:nvSpPr>
+        <p:spPr>
+          <a:xfrm>
+            <a:off x="548640" y="5257800"/>
+            <a:ext cx="11064240" cy="713232"/>
+          </a:xfrm>
+          <a:prstGeom prst="roundRect">
+            <a:avLst>
+              <a:gd name="adj" fmla="val 10256"/>
+            </a:avLst>
+          </a:prstGeom>
+          <a:solidFill>
+            <a:schemeClr val="bg2"/>
+          </a:solidFill>
+          <a:ln w="12700">
+            <a:solidFill>
+              <a:schemeClr val="bg2"/>
+            </a:solidFill>
+            <a:prstDash val="solid"/>
+          </a:ln>
+          <a:effectLst>
+            <a:outerShdw sx="100000" sy="100000" kx="0" ky="0" algn="bl" rotWithShape="0" blurRad="76200" dist="25400" dir="5400000">
+              <a:srgbClr val="000000">
+                <a:alpha val="12000"/>
+              </a:srgbClr>
+            </a:outerShdw>
+          </a:effectLst>
+        </p:spPr>
+      </p:sp>
+      <p:sp>
+        <p:nvSpPr>
+          <p:cNvPr id="19" name="Text 17"/>
+          <p:cNvSpPr txBox="1"/>
+          <p:nvPr/>
+        </p:nvSpPr>
+        <p:spPr>
+          <a:xfrm>
+            <a:off x="777240" y="5312664"/>
+            <a:ext cx="10607040" cy="329184"/>
+          </a:xfrm>
+          <a:prstGeom prst="rect">
+            <a:avLst/>
+          </a:prstGeom>
+          <a:noFill/>
+          <a:ln/>
+        </p:spPr>
+        <p:txBody>
+          <a:bodyPr wrap="square" lIns="0" tIns="0" rIns="0" bIns="0" rtlCol="0" anchor="t"/>
+          <a:lstStyle/>
+          <a:p>
+            <a:pPr indent="0" marL="0">
+              <a:buNone/>
+            </a:pPr>
+            <a:r>
+              <a:rPr lang="en-US" sz="1400" dirty="0">
+                <a:solidFill>
+                  <a:schemeClr val="tx1"/>
+                </a:solidFill>
+              </a:rPr>
+              <a:t>[6] N. Freed, "Behavior of and requirements for Internet firewalls," RFC 2979, 2000.</a:t>
+            </a:r>
+            <a:endParaRPr lang="en-US" sz="1400" dirty="0"/>
+          </a:p>
+        </p:txBody>
+      </p:sp>
+      <p:sp>
+        <p:nvSpPr>
+          <p:cNvPr id="20" name="Text 18"/>
+          <p:cNvSpPr txBox="1"/>
+          <p:nvPr/>
+        </p:nvSpPr>
+        <p:spPr>
+          <a:xfrm>
+            <a:off x="777240" y="5650992"/>
+            <a:ext cx="10607040" cy="274320"/>
+          </a:xfrm>
+          <a:prstGeom prst="rect">
+            <a:avLst/>
+          </a:prstGeom>
+          <a:noFill/>
+          <a:ln/>
+        </p:spPr>
+        <p:txBody>
+          <a:bodyPr wrap="square" lIns="0" tIns="0" rIns="0" bIns="0" rtlCol="0" anchor="t"/>
+          <a:lstStyle/>
+          <a:p>
+            <a:pPr indent="0" marL="0">
+              <a:buNone/>
+            </a:pPr>
+            <a:r>
+              <a:rPr lang="en-US" sz="1200" u="sng" dirty="0">
+                <a:solidFill>
+                  <a:schemeClr val="accent5"/>
+                </a:solidFill>
+                <a:hlinkClick r:id="rId6" invalidUrl="" action="" tgtFrame="" tooltip="Open source" history="1" highlightClick="0" endSnd="0">
+                  <a:extLst>
+                    <a:ext uri="{A12FA001-AC4F-418D-AE19-62706E023703}">
+                      <ahyp:hlinkClr xmlns:ahyp="http://schemas.microsoft.com/office/drawing/2018/hyperlinkcolor" val="tx"/>
+                    </a:ext>
+                  </a:extLst>
+                </a:hlinkClick>
+              </a:rPr>
+              <a:t>https://www.rfc-editor.org/rfc/rfc2979</a:t>
+            </a:r>
+            <a:endParaRPr lang="en-US" sz="1200" dirty="0"/>
           </a:p>
         </p:txBody>
       </p:sp>
@@ -23970,7 +24173,7 @@
                   <a:schemeClr val="tx1"/>
                 </a:solidFill>
               </a:rPr>
-              <a:t>Key references (2 of 2)</a:t>
+              <a:t>References (2 of 3)</a:t>
             </a:r>
             <a:endParaRPr lang="en-US" sz="3200" dirty="0"/>
           </a:p>
@@ -23978,18 +24181,18 @@
       </p:sp>
       <p:sp>
         <p:nvSpPr>
-          <p:cNvPr id="3" name="card150"/>
+          <p:cNvPr id="3" name="card151"/>
           <p:cNvSpPr/>
           <p:nvPr/>
         </p:nvSpPr>
         <p:spPr>
           <a:xfrm>
-            <a:off x="548640" y="1325880"/>
-            <a:ext cx="11064240" cy="804672"/>
+            <a:off x="548640" y="1234440"/>
+            <a:ext cx="11064240" cy="713232"/>
           </a:xfrm>
           <a:prstGeom prst="roundRect">
             <a:avLst>
-              <a:gd name="adj" fmla="val 9091"/>
+              <a:gd name="adj" fmla="val 10256"/>
             </a:avLst>
           </a:prstGeom>
           <a:solidFill>
@@ -24018,8 +24221,8 @@
         </p:nvSpPr>
         <p:spPr>
           <a:xfrm>
-            <a:off x="777240" y="1399032"/>
-            <a:ext cx="10607040" cy="365760"/>
+            <a:off x="777240" y="1289304"/>
+            <a:ext cx="10607040" cy="329184"/>
           </a:xfrm>
           <a:prstGeom prst="rect">
             <a:avLst/>
@@ -24035,14 +24238,14 @@
               <a:buNone/>
             </a:pPr>
             <a:r>
-              <a:rPr lang="en-US" sz="1500" dirty="0">
+              <a:rPr lang="en-US" sz="1400" dirty="0">
                 <a:solidFill>
                   <a:schemeClr val="tx1"/>
                 </a:solidFill>
               </a:rPr>
-              <a:t>[9] E. Al-Shaer, H. Hamed, "Discovery of policy anomalies in distributed firewalls," IEEE INFOCOM, 2004.</a:t>
+              <a:t>[7] P. Ferguson, D. Senie, "Network ingress filtering," BCP 38 / RFC 2827, 2000.</a:t>
             </a:r>
-            <a:endParaRPr lang="en-US" sz="1500" dirty="0"/>
+            <a:endParaRPr lang="en-US" sz="1400" dirty="0"/>
           </a:p>
         </p:txBody>
       </p:sp>
@@ -24054,8 +24257,8 @@
         </p:nvSpPr>
         <p:spPr>
           <a:xfrm>
-            <a:off x="777240" y="1764792"/>
-            <a:ext cx="10607040" cy="292608"/>
+            <a:off x="777240" y="1627632"/>
+            <a:ext cx="10607040" cy="274320"/>
           </a:xfrm>
           <a:prstGeom prst="rect">
             <a:avLst/>
@@ -24071,7 +24274,7 @@
               <a:buNone/>
             </a:pPr>
             <a:r>
-              <a:rPr lang="en-US" sz="1300" u="sng" dirty="0">
+              <a:rPr lang="en-US" sz="1200" u="sng" dirty="0">
                 <a:solidFill>
                   <a:schemeClr val="accent5"/>
                 </a:solidFill>
@@ -24083,26 +24286,26 @@
                   </a:extLst>
                 </a:hlinkClick>
               </a:rPr>
-              <a:t>https://pure.kfupm.edu.sa/en/publications/discovery-of-policy-anomalies-in-distributed-firewalls/</a:t>
+              <a:t>https://doi.org/10.17487/RFC2827</a:t>
             </a:r>
-            <a:endParaRPr lang="en-US" sz="1300" dirty="0"/>
-          </a:p>
-        </p:txBody>
-      </p:sp>
-      <p:sp>
-        <p:nvSpPr>
-          <p:cNvPr id="6" name="card151"/>
+            <a:endParaRPr lang="en-US" sz="1200" dirty="0"/>
+          </a:p>
+        </p:txBody>
+      </p:sp>
+      <p:sp>
+        <p:nvSpPr>
+          <p:cNvPr id="6" name="card152"/>
           <p:cNvSpPr/>
           <p:nvPr/>
         </p:nvSpPr>
         <p:spPr>
           <a:xfrm>
-            <a:off x="548640" y="2258568"/>
-            <a:ext cx="11064240" cy="804672"/>
+            <a:off x="548640" y="2039112"/>
+            <a:ext cx="11064240" cy="713232"/>
           </a:xfrm>
           <a:prstGeom prst="roundRect">
             <a:avLst>
-              <a:gd name="adj" fmla="val 9091"/>
+              <a:gd name="adj" fmla="val 10256"/>
             </a:avLst>
           </a:prstGeom>
           <a:solidFill>
@@ -24131,8 +24334,8 @@
         </p:nvSpPr>
         <p:spPr>
           <a:xfrm>
-            <a:off x="777240" y="2331720"/>
-            <a:ext cx="10607040" cy="365760"/>
+            <a:off x="777240" y="2093976"/>
+            <a:ext cx="10607040" cy="329184"/>
           </a:xfrm>
           <a:prstGeom prst="rect">
             <a:avLst/>
@@ -24148,14 +24351,14 @@
               <a:buNone/>
             </a:pPr>
             <a:r>
-              <a:rPr lang="en-US" sz="1500" dirty="0">
+              <a:rPr lang="en-US" sz="1400" dirty="0">
                 <a:solidFill>
                   <a:schemeClr val="tx1"/>
                 </a:solidFill>
               </a:rPr>
-              <a:t>[10] E. Al-Shaer et al., "Conflict classification and analysis of distributed firewall policies," IEEE JSAC, 2005.</a:t>
+              <a:t>[8] R. Ward, B. Beyer, "BeyondCorp: A new approach to enterprise security," ;login:, 39(6), 2014.</a:t>
             </a:r>
-            <a:endParaRPr lang="en-US" sz="1500" dirty="0"/>
+            <a:endParaRPr lang="en-US" sz="1400" dirty="0"/>
           </a:p>
         </p:txBody>
       </p:sp>
@@ -24167,8 +24370,8 @@
         </p:nvSpPr>
         <p:spPr>
           <a:xfrm>
-            <a:off x="777240" y="2697480"/>
-            <a:ext cx="10607040" cy="292608"/>
+            <a:off x="777240" y="2432304"/>
+            <a:ext cx="10607040" cy="274320"/>
           </a:xfrm>
           <a:prstGeom prst="rect">
             <a:avLst/>
@@ -24184,7 +24387,7 @@
               <a:buNone/>
             </a:pPr>
             <a:r>
-              <a:rPr lang="en-US" sz="1300" u="sng" dirty="0">
+              <a:rPr lang="en-US" sz="1200" u="sng" dirty="0">
                 <a:solidFill>
                   <a:schemeClr val="accent5"/>
                 </a:solidFill>
@@ -24196,26 +24399,26 @@
                   </a:extLst>
                 </a:hlinkClick>
               </a:rPr>
-              <a:t>https://doi.org/10.1109/JSAC.2005.854119</a:t>
+              <a:t>https://www.usenix.org/publications/login/dec14/ward</a:t>
             </a:r>
-            <a:endParaRPr lang="en-US" sz="1300" dirty="0"/>
-          </a:p>
-        </p:txBody>
-      </p:sp>
-      <p:sp>
-        <p:nvSpPr>
-          <p:cNvPr id="9" name="card152"/>
+            <a:endParaRPr lang="en-US" sz="1200" dirty="0"/>
+          </a:p>
+        </p:txBody>
+      </p:sp>
+      <p:sp>
+        <p:nvSpPr>
+          <p:cNvPr id="9" name="card153"/>
           <p:cNvSpPr/>
           <p:nvPr/>
         </p:nvSpPr>
         <p:spPr>
           <a:xfrm>
-            <a:off x="548640" y="3191256"/>
-            <a:ext cx="11064240" cy="804672"/>
+            <a:off x="548640" y="2843784"/>
+            <a:ext cx="11064240" cy="713232"/>
           </a:xfrm>
           <a:prstGeom prst="roundRect">
             <a:avLst>
-              <a:gd name="adj" fmla="val 9091"/>
+              <a:gd name="adj" fmla="val 10256"/>
             </a:avLst>
           </a:prstGeom>
           <a:solidFill>
@@ -24244,8 +24447,8 @@
         </p:nvSpPr>
         <p:spPr>
           <a:xfrm>
-            <a:off x="777240" y="3264408"/>
-            <a:ext cx="10607040" cy="365760"/>
+            <a:off x="777240" y="2898648"/>
+            <a:ext cx="10607040" cy="329184"/>
           </a:xfrm>
           <a:prstGeom prst="rect">
             <a:avLst/>
@@ -24261,14 +24464,14 @@
               <a:buNone/>
             </a:pPr>
             <a:r>
-              <a:rPr lang="en-US" sz="1500" dirty="0">
+              <a:rPr lang="en-US" sz="1400" dirty="0">
                 <a:solidFill>
                   <a:schemeClr val="tx1"/>
                 </a:solidFill>
               </a:rPr>
-              <a:t>[11] L. Yuan et al., "FIREMAN: A toolkit for firewall modeling and analysis," IEEE S&amp;P, 2006.</a:t>
+              <a:t>[9] E. Al-Shaer, H. Hamed, "Discovery of policy anomalies in distributed firewalls," IEEE INFOCOM, 2004.</a:t>
             </a:r>
-            <a:endParaRPr lang="en-US" sz="1500" dirty="0"/>
+            <a:endParaRPr lang="en-US" sz="1400" dirty="0"/>
           </a:p>
         </p:txBody>
       </p:sp>
@@ -24280,8 +24483,8 @@
         </p:nvSpPr>
         <p:spPr>
           <a:xfrm>
-            <a:off x="777240" y="3630168"/>
-            <a:ext cx="10607040" cy="292608"/>
+            <a:off x="777240" y="3236976"/>
+            <a:ext cx="10607040" cy="274320"/>
           </a:xfrm>
           <a:prstGeom prst="rect">
             <a:avLst/>
@@ -24297,7 +24500,7 @@
               <a:buNone/>
             </a:pPr>
             <a:r>
-              <a:rPr lang="en-US" sz="1300" u="sng" dirty="0">
+              <a:rPr lang="en-US" sz="1200" u="sng" dirty="0">
                 <a:solidFill>
                   <a:schemeClr val="accent5"/>
                 </a:solidFill>
@@ -24309,26 +24512,26 @@
                   </a:extLst>
                 </a:hlinkClick>
               </a:rPr>
-              <a:t>https://doi.org/10.1109/SP.2006.16</a:t>
+              <a:t>https://pure.kfupm.edu.sa/en/publications/discovery-of-policy-anomalies-in-distributed-firewalls/</a:t>
             </a:r>
-            <a:endParaRPr lang="en-US" sz="1300" dirty="0"/>
-          </a:p>
-        </p:txBody>
-      </p:sp>
-      <p:sp>
-        <p:nvSpPr>
-          <p:cNvPr id="12" name="card153"/>
+            <a:endParaRPr lang="en-US" sz="1200" dirty="0"/>
+          </a:p>
+        </p:txBody>
+      </p:sp>
+      <p:sp>
+        <p:nvSpPr>
+          <p:cNvPr id="12" name="card154"/>
           <p:cNvSpPr/>
           <p:nvPr/>
         </p:nvSpPr>
         <p:spPr>
           <a:xfrm>
-            <a:off x="548640" y="4123944"/>
-            <a:ext cx="11064240" cy="804672"/>
+            <a:off x="548640" y="3648456"/>
+            <a:ext cx="11064240" cy="713232"/>
           </a:xfrm>
           <a:prstGeom prst="roundRect">
             <a:avLst>
-              <a:gd name="adj" fmla="val 9091"/>
+              <a:gd name="adj" fmla="val 10256"/>
             </a:avLst>
           </a:prstGeom>
           <a:solidFill>
@@ -24357,8 +24560,8 @@
         </p:nvSpPr>
         <p:spPr>
           <a:xfrm>
-            <a:off x="777240" y="4197096"/>
-            <a:ext cx="10607040" cy="365760"/>
+            <a:off x="777240" y="3703320"/>
+            <a:ext cx="10607040" cy="329184"/>
           </a:xfrm>
           <a:prstGeom prst="rect">
             <a:avLst/>
@@ -24374,14 +24577,14 @@
               <a:buNone/>
             </a:pPr>
             <a:r>
-              <a:rPr lang="en-US" sz="1500" dirty="0">
+              <a:rPr lang="en-US" sz="1400" dirty="0">
                 <a:solidFill>
                   <a:schemeClr val="tx1"/>
                 </a:solidFill>
               </a:rPr>
-              <a:t>[13] A. Voronkov et al., "Systematic literature review on usability of firewall configuration," ACM CSUR, 2017.</a:t>
+              <a:t>[10] E. Al-Shaer et al., "Conflict classification and analysis of distributed firewall policies," IEEE JSAC, 2005.</a:t>
             </a:r>
-            <a:endParaRPr lang="en-US" sz="1500" dirty="0"/>
+            <a:endParaRPr lang="en-US" sz="1400" dirty="0"/>
           </a:p>
         </p:txBody>
       </p:sp>
@@ -24393,8 +24596,8 @@
         </p:nvSpPr>
         <p:spPr>
           <a:xfrm>
-            <a:off x="777240" y="4562856"/>
-            <a:ext cx="10607040" cy="292608"/>
+            <a:off x="777240" y="4041648"/>
+            <a:ext cx="10607040" cy="274320"/>
           </a:xfrm>
           <a:prstGeom prst="rect">
             <a:avLst/>
@@ -24410,7 +24613,7 @@
               <a:buNone/>
             </a:pPr>
             <a:r>
-              <a:rPr lang="en-US" sz="1300" u="sng" dirty="0">
+              <a:rPr lang="en-US" sz="1200" u="sng" dirty="0">
                 <a:solidFill>
                   <a:schemeClr val="accent5"/>
                 </a:solidFill>
@@ -24422,26 +24625,26 @@
                   </a:extLst>
                 </a:hlinkClick>
               </a:rPr>
-              <a:t>https://doi.org/10.1145/3130876</a:t>
+              <a:t>https://doi.org/10.1109/JSAC.2005.854119</a:t>
             </a:r>
-            <a:endParaRPr lang="en-US" sz="1300" dirty="0"/>
-          </a:p>
-        </p:txBody>
-      </p:sp>
-      <p:sp>
-        <p:nvSpPr>
-          <p:cNvPr id="15" name="card154"/>
+            <a:endParaRPr lang="en-US" sz="1200" dirty="0"/>
+          </a:p>
+        </p:txBody>
+      </p:sp>
+      <p:sp>
+        <p:nvSpPr>
+          <p:cNvPr id="15" name="card155"/>
           <p:cNvSpPr/>
           <p:nvPr/>
         </p:nvSpPr>
         <p:spPr>
           <a:xfrm>
-            <a:off x="548640" y="5056632"/>
-            <a:ext cx="11064240" cy="804672"/>
+            <a:off x="548640" y="4453128"/>
+            <a:ext cx="11064240" cy="713232"/>
           </a:xfrm>
           <a:prstGeom prst="roundRect">
             <a:avLst>
-              <a:gd name="adj" fmla="val 9091"/>
+              <a:gd name="adj" fmla="val 10256"/>
             </a:avLst>
           </a:prstGeom>
           <a:solidFill>
@@ -24470,8 +24673,8 @@
         </p:nvSpPr>
         <p:spPr>
           <a:xfrm>
-            <a:off x="777240" y="5129784"/>
-            <a:ext cx="10607040" cy="365760"/>
+            <a:off x="777240" y="4507992"/>
+            <a:ext cx="10607040" cy="329184"/>
           </a:xfrm>
           <a:prstGeom prst="rect">
             <a:avLst/>
@@ -24487,14 +24690,14 @@
               <a:buNone/>
             </a:pPr>
             <a:r>
-              <a:rPr lang="en-US" sz="1500" dirty="0">
+              <a:rPr lang="en-US" sz="1400" dirty="0">
                 <a:solidFill>
                   <a:schemeClr val="tx1"/>
                 </a:solidFill>
               </a:rPr>
-              <a:t>[15] R. Chandramouli, "Guide to a secure enterprise network landscape," NIST SP 800-215, 2022.</a:t>
+              <a:t>[11] L. Yuan et al., "FIREMAN: A toolkit for firewall modeling and analysis," IEEE S&amp;P, 2006.</a:t>
             </a:r>
-            <a:endParaRPr lang="en-US" sz="1500" dirty="0"/>
+            <a:endParaRPr lang="en-US" sz="1400" dirty="0"/>
           </a:p>
         </p:txBody>
       </p:sp>
@@ -24506,8 +24709,8 @@
         </p:nvSpPr>
         <p:spPr>
           <a:xfrm>
-            <a:off x="777240" y="5495544"/>
-            <a:ext cx="10607040" cy="292608"/>
+            <a:off x="777240" y="4846320"/>
+            <a:ext cx="10607040" cy="274320"/>
           </a:xfrm>
           <a:prstGeom prst="rect">
             <a:avLst/>
@@ -24523,7 +24726,7 @@
               <a:buNone/>
             </a:pPr>
             <a:r>
-              <a:rPr lang="en-US" sz="1300" u="sng" dirty="0">
+              <a:rPr lang="en-US" sz="1200" u="sng" dirty="0">
                 <a:solidFill>
                   <a:schemeClr val="accent5"/>
                 </a:solidFill>
@@ -24535,22 +24738,56 @@
                   </a:extLst>
                 </a:hlinkClick>
               </a:rPr>
-              <a:t>https://doi.org/10.6028/NIST.SP.800-215</a:t>
+              <a:t>https://doi.org/10.1109/SP.2006.16</a:t>
             </a:r>
-            <a:endParaRPr lang="en-US" sz="1300" dirty="0"/>
-          </a:p>
-        </p:txBody>
-      </p:sp>
-      <p:sp>
-        <p:nvSpPr>
-          <p:cNvPr id="18" name="Text 16"/>
+            <a:endParaRPr lang="en-US" sz="1200" dirty="0"/>
+          </a:p>
+        </p:txBody>
+      </p:sp>
+      <p:sp>
+        <p:nvSpPr>
+          <p:cNvPr id="18" name="card156"/>
+          <p:cNvSpPr/>
+          <p:nvPr/>
+        </p:nvSpPr>
+        <p:spPr>
+          <a:xfrm>
+            <a:off x="548640" y="5257800"/>
+            <a:ext cx="11064240" cy="713232"/>
+          </a:xfrm>
+          <a:prstGeom prst="roundRect">
+            <a:avLst>
+              <a:gd name="adj" fmla="val 10256"/>
+            </a:avLst>
+          </a:prstGeom>
+          <a:solidFill>
+            <a:schemeClr val="bg2"/>
+          </a:solidFill>
+          <a:ln w="12700">
+            <a:solidFill>
+              <a:schemeClr val="bg2"/>
+            </a:solidFill>
+            <a:prstDash val="solid"/>
+          </a:ln>
+          <a:effectLst>
+            <a:outerShdw sx="100000" sy="100000" kx="0" ky="0" algn="bl" rotWithShape="0" blurRad="76200" dist="25400" dir="5400000">
+              <a:srgbClr val="000000">
+                <a:alpha val="12000"/>
+              </a:srgbClr>
+            </a:outerShdw>
+          </a:effectLst>
+        </p:spPr>
+      </p:sp>
+      <p:sp>
+        <p:nvSpPr>
+          <p:cNvPr id="19" name="Text 17"/>
           <p:cNvSpPr txBox="1"/>
           <p:nvPr/>
         </p:nvSpPr>
         <p:spPr>
           <a:xfrm>
-            <a:off x="548640" y="6035040"/>
-            <a:ext cx="11064240" cy="365760"/>
+            <a:off x="777240" y="5312664"/>
+            <a:ext cx="10607040" cy="329184"/>
           </a:xfrm>
           <a:prstGeom prst="rect">
             <a:avLst/>
@@ -24566,12 +24803,55 @@
               <a:buNone/>
             </a:pPr>
             <a:r>
-              <a:rPr lang="en-US" sz="1200" i="1" dirty="0">
+              <a:rPr lang="en-US" sz="1400" dirty="0">
                 <a:solidFill>
-                  <a:schemeClr val="accent4"/>
+                  <a:schemeClr val="tx1"/>
                 </a:solidFill>
               </a:rPr>
-              <a:t>Full list of 18 references in the report (IEEE style). Links: DOI where available, otherwise publisher, repository or full-text page.</a:t>
+              <a:t>[12] M. G. Gouda, A. X. Liu, "Structured firewall design," Computer Networks, 51(4), 2007.</a:t>
+            </a:r>
+            <a:endParaRPr lang="en-US" sz="1400" dirty="0"/>
+          </a:p>
+        </p:txBody>
+      </p:sp>
+      <p:sp>
+        <p:nvSpPr>
+          <p:cNvPr id="20" name="Text 18"/>
+          <p:cNvSpPr txBox="1"/>
+          <p:nvPr/>
+        </p:nvSpPr>
+        <p:spPr>
+          <a:xfrm>
+            <a:off x="777240" y="5650992"/>
+            <a:ext cx="10607040" cy="274320"/>
+          </a:xfrm>
+          <a:prstGeom prst="rect">
+            <a:avLst/>
+          </a:prstGeom>
+          <a:noFill/>
+          <a:ln/>
+        </p:spPr>
+        <p:txBody>
+          <a:bodyPr wrap="square" lIns="0" tIns="0" rIns="0" bIns="0" rtlCol="0" anchor="t"/>
+          <a:lstStyle/>
+          <a:p>
+            <a:pPr indent="0" marL="0">
+              <a:buNone/>
+            </a:pPr>
+            <a:r>
+              <a:rPr lang="en-US" sz="1200" u="sng" dirty="0">
+                <a:solidFill>
+                  <a:schemeClr val="accent5"/>
+                </a:solidFill>
+                <a:hlinkClick r:id="rId6" invalidUrl="" action="" tgtFrame="" tooltip="Open source" history="1" highlightClick="0" endSnd="0">
+                  <a:extLst>
+                    <a:ext uri="{A12FA001-AC4F-418D-AE19-62706E023703}">
+                      <ahyp:hlinkClr xmlns:ahyp="http://schemas.microsoft.com/office/drawing/2018/hyperlinkcolor" val="tx"/>
+                    </a:ext>
+                  </a:extLst>
+                </a:hlinkClick>
+              </a:rPr>
+              <a:t>https://ftp.math.utah.edu/pub/tex/bib/idx/compnetamsterdam2000/51/4/1106_1120.html</a:t>
             </a:r>
             <a:endParaRPr lang="en-US" sz="1200" dirty="0"/>
           </a:p>
@@ -24617,6 +24897,828 @@
             <a:fld id="{F7021451-1387-4CA6-816F-3879F97B5CBC}" type="slidenum">
               <a:rPr b="0" lang="en-US"/>
               <a:t>25</a:t>
+            </a:fld>
+            <a:endParaRPr lang="en-US"/>
+          </a:p>
+        </p:txBody>
+      </p:sp>
+    </p:spTree>
+  </p:cSld>
+  <p:clrMapOvr>
+    <a:masterClrMapping/>
+  </p:clrMapOvr>
+</p:sld>
+</file>
+
+<file path=ppt/slides/slide26.xml><?xml version="1.0" encoding="utf-8"?>
+<p:sld xmlns:a="http://schemas.openxmlformats.org/drawingml/2006/main" xmlns:r="http://schemas.openxmlformats.org/officeDocument/2006/relationships" xmlns:p="http://schemas.openxmlformats.org/presentationml/2006/main">
+  <p:cSld name="Slide 26">
+    <p:spTree>
+      <p:nvGrpSpPr>
+        <p:cNvPr id="1" name=""/>
+        <p:cNvGrpSpPr/>
+        <p:nvPr/>
+      </p:nvGrpSpPr>
+      <p:grpSpPr>
+        <a:xfrm>
+          <a:off x="0" y="0"/>
+          <a:ext cx="0" cy="0"/>
+          <a:chOff x="0" y="0"/>
+          <a:chExt cx="0" cy="0"/>
+        </a:xfrm>
+      </p:grpSpPr>
+      <p:sp>
+        <p:nvSpPr>
+          <p:cNvPr id="2" name="Text 0"/>
+          <p:cNvSpPr/>
+          <p:nvPr>
+            <p:ph idx="100" type="title" hasCustomPrompt="1"/>
+          </p:nvPr>
+        </p:nvSpPr>
+        <p:spPr>
+          <a:xfrm>
+            <a:off x="548640" y="320040"/>
+            <a:ext cx="11064240" cy="822960"/>
+          </a:xfrm>
+          <a:prstGeom prst="rect">
+            <a:avLst/>
+          </a:prstGeom>
+          <a:noFill/>
+          <a:ln/>
+        </p:spPr>
+        <p:txBody>
+          <a:bodyPr wrap="square" rtlCol="0" anchor="ctr"/>
+          <a:lstStyle/>
+          <a:p>
+            <a:pPr indent="0" marL="0">
+              <a:buNone/>
+            </a:pPr>
+            <a:r>
+              <a:rPr lang="en-US" sz="3200" b="1" dirty="0">
+                <a:solidFill>
+                  <a:schemeClr val="tx1"/>
+                </a:solidFill>
+              </a:rPr>
+              <a:t>References (3 of 3)</a:t>
+            </a:r>
+            <a:endParaRPr lang="en-US" sz="3200" dirty="0"/>
+          </a:p>
+        </p:txBody>
+      </p:sp>
+      <p:sp>
+        <p:nvSpPr>
+          <p:cNvPr id="3" name="card157"/>
+          <p:cNvSpPr/>
+          <p:nvPr/>
+        </p:nvSpPr>
+        <p:spPr>
+          <a:xfrm>
+            <a:off x="548640" y="1234440"/>
+            <a:ext cx="11064240" cy="713232"/>
+          </a:xfrm>
+          <a:prstGeom prst="roundRect">
+            <a:avLst>
+              <a:gd name="adj" fmla="val 10256"/>
+            </a:avLst>
+          </a:prstGeom>
+          <a:solidFill>
+            <a:schemeClr val="bg2"/>
+          </a:solidFill>
+          <a:ln w="12700">
+            <a:solidFill>
+              <a:schemeClr val="bg2"/>
+            </a:solidFill>
+            <a:prstDash val="solid"/>
+          </a:ln>
+          <a:effectLst>
+            <a:outerShdw sx="100000" sy="100000" kx="0" ky="0" algn="bl" rotWithShape="0" blurRad="76200" dist="25400" dir="5400000">
+              <a:srgbClr val="000000">
+                <a:alpha val="12000"/>
+              </a:srgbClr>
+            </a:outerShdw>
+          </a:effectLst>
+        </p:spPr>
+      </p:sp>
+      <p:sp>
+        <p:nvSpPr>
+          <p:cNvPr id="4" name="Text 2"/>
+          <p:cNvSpPr txBox="1"/>
+          <p:nvPr/>
+        </p:nvSpPr>
+        <p:spPr>
+          <a:xfrm>
+            <a:off x="777240" y="1289304"/>
+            <a:ext cx="10607040" cy="329184"/>
+          </a:xfrm>
+          <a:prstGeom prst="rect">
+            <a:avLst/>
+          </a:prstGeom>
+          <a:noFill/>
+          <a:ln/>
+        </p:spPr>
+        <p:txBody>
+          <a:bodyPr wrap="square" lIns="0" tIns="0" rIns="0" bIns="0" rtlCol="0" anchor="t"/>
+          <a:lstStyle/>
+          <a:p>
+            <a:pPr indent="0" marL="0">
+              <a:buNone/>
+            </a:pPr>
+            <a:r>
+              <a:rPr lang="en-US" sz="1400" dirty="0">
+                <a:solidFill>
+                  <a:schemeClr val="tx1"/>
+                </a:solidFill>
+              </a:rPr>
+              <a:t>[13] A. Voronkov et al., "Systematic literature review on usability of firewall configuration," ACM CSUR, 2017.</a:t>
+            </a:r>
+            <a:endParaRPr lang="en-US" sz="1400" dirty="0"/>
+          </a:p>
+        </p:txBody>
+      </p:sp>
+      <p:sp>
+        <p:nvSpPr>
+          <p:cNvPr id="5" name="Text 3"/>
+          <p:cNvSpPr txBox="1"/>
+          <p:nvPr/>
+        </p:nvSpPr>
+        <p:spPr>
+          <a:xfrm>
+            <a:off x="777240" y="1627632"/>
+            <a:ext cx="10607040" cy="274320"/>
+          </a:xfrm>
+          <a:prstGeom prst="rect">
+            <a:avLst/>
+          </a:prstGeom>
+          <a:noFill/>
+          <a:ln/>
+        </p:spPr>
+        <p:txBody>
+          <a:bodyPr wrap="square" lIns="0" tIns="0" rIns="0" bIns="0" rtlCol="0" anchor="t"/>
+          <a:lstStyle/>
+          <a:p>
+            <a:pPr indent="0" marL="0">
+              <a:buNone/>
+            </a:pPr>
+            <a:r>
+              <a:rPr lang="en-US" sz="1200" u="sng" dirty="0">
+                <a:solidFill>
+                  <a:schemeClr val="accent5"/>
+                </a:solidFill>
+                <a:hlinkClick r:id="rId1" invalidUrl="" action="" tgtFrame="" tooltip="Open source" history="1" highlightClick="0" endSnd="0">
+                  <a:extLst>
+                    <a:ext uri="{A12FA001-AC4F-418D-AE19-62706E023703}">
+                      <ahyp:hlinkClr xmlns:ahyp="http://schemas.microsoft.com/office/drawing/2018/hyperlinkcolor" val="tx"/>
+                    </a:ext>
+                  </a:extLst>
+                </a:hlinkClick>
+              </a:rPr>
+              <a:t>https://doi.org/10.1145/3130876</a:t>
+            </a:r>
+            <a:endParaRPr lang="en-US" sz="1200" dirty="0"/>
+          </a:p>
+        </p:txBody>
+      </p:sp>
+      <p:sp>
+        <p:nvSpPr>
+          <p:cNvPr id="6" name="card158"/>
+          <p:cNvSpPr/>
+          <p:nvPr/>
+        </p:nvSpPr>
+        <p:spPr>
+          <a:xfrm>
+            <a:off x="548640" y="2039112"/>
+            <a:ext cx="11064240" cy="713232"/>
+          </a:xfrm>
+          <a:prstGeom prst="roundRect">
+            <a:avLst>
+              <a:gd name="adj" fmla="val 10256"/>
+            </a:avLst>
+          </a:prstGeom>
+          <a:solidFill>
+            <a:schemeClr val="bg2"/>
+          </a:solidFill>
+          <a:ln w="12700">
+            <a:solidFill>
+              <a:schemeClr val="bg2"/>
+            </a:solidFill>
+            <a:prstDash val="solid"/>
+          </a:ln>
+          <a:effectLst>
+            <a:outerShdw sx="100000" sy="100000" kx="0" ky="0" algn="bl" rotWithShape="0" blurRad="76200" dist="25400" dir="5400000">
+              <a:srgbClr val="000000">
+                <a:alpha val="12000"/>
+              </a:srgbClr>
+            </a:outerShdw>
+          </a:effectLst>
+        </p:spPr>
+      </p:sp>
+      <p:sp>
+        <p:nvSpPr>
+          <p:cNvPr id="7" name="Text 5"/>
+          <p:cNvSpPr txBox="1"/>
+          <p:nvPr/>
+        </p:nvSpPr>
+        <p:spPr>
+          <a:xfrm>
+            <a:off x="777240" y="2093976"/>
+            <a:ext cx="10607040" cy="329184"/>
+          </a:xfrm>
+          <a:prstGeom prst="rect">
+            <a:avLst/>
+          </a:prstGeom>
+          <a:noFill/>
+          <a:ln/>
+        </p:spPr>
+        <p:txBody>
+          <a:bodyPr wrap="square" lIns="0" tIns="0" rIns="0" bIns="0" rtlCol="0" anchor="t"/>
+          <a:lstStyle/>
+          <a:p>
+            <a:pPr indent="0" marL="0">
+              <a:buNone/>
+            </a:pPr>
+            <a:r>
+              <a:rPr lang="en-US" sz="1400" dirty="0">
+                <a:solidFill>
+                  <a:schemeClr val="tx1"/>
+                </a:solidFill>
+              </a:rPr>
+              <a:t>[14] N. Syed et al., "Zero trust architecture (ZTA): A comprehensive survey," IEEE Access, 2022.</a:t>
+            </a:r>
+            <a:endParaRPr lang="en-US" sz="1400" dirty="0"/>
+          </a:p>
+        </p:txBody>
+      </p:sp>
+      <p:sp>
+        <p:nvSpPr>
+          <p:cNvPr id="8" name="Text 6"/>
+          <p:cNvSpPr txBox="1"/>
+          <p:nvPr/>
+        </p:nvSpPr>
+        <p:spPr>
+          <a:xfrm>
+            <a:off x="777240" y="2432304"/>
+            <a:ext cx="10607040" cy="274320"/>
+          </a:xfrm>
+          <a:prstGeom prst="rect">
+            <a:avLst/>
+          </a:prstGeom>
+          <a:noFill/>
+          <a:ln/>
+        </p:spPr>
+        <p:txBody>
+          <a:bodyPr wrap="square" lIns="0" tIns="0" rIns="0" bIns="0" rtlCol="0" anchor="t"/>
+          <a:lstStyle/>
+          <a:p>
+            <a:pPr indent="0" marL="0">
+              <a:buNone/>
+            </a:pPr>
+            <a:r>
+              <a:rPr lang="en-US" sz="1200" u="sng" dirty="0">
+                <a:solidFill>
+                  <a:schemeClr val="accent5"/>
+                </a:solidFill>
+                <a:hlinkClick r:id="rId2" invalidUrl="" action="" tgtFrame="" tooltip="Open source" history="1" highlightClick="0" endSnd="0">
+                  <a:extLst>
+                    <a:ext uri="{A12FA001-AC4F-418D-AE19-62706E023703}">
+                      <ahyp:hlinkClr xmlns:ahyp="http://schemas.microsoft.com/office/drawing/2018/hyperlinkcolor" val="tx"/>
+                    </a:ext>
+                  </a:extLst>
+                </a:hlinkClick>
+              </a:rPr>
+              <a:t>https://ieeexplore.ieee.org/document/9773102</a:t>
+            </a:r>
+            <a:endParaRPr lang="en-US" sz="1200" dirty="0"/>
+          </a:p>
+        </p:txBody>
+      </p:sp>
+      <p:sp>
+        <p:nvSpPr>
+          <p:cNvPr id="9" name="card159"/>
+          <p:cNvSpPr/>
+          <p:nvPr/>
+        </p:nvSpPr>
+        <p:spPr>
+          <a:xfrm>
+            <a:off x="548640" y="2843784"/>
+            <a:ext cx="11064240" cy="713232"/>
+          </a:xfrm>
+          <a:prstGeom prst="roundRect">
+            <a:avLst>
+              <a:gd name="adj" fmla="val 10256"/>
+            </a:avLst>
+          </a:prstGeom>
+          <a:solidFill>
+            <a:schemeClr val="bg2"/>
+          </a:solidFill>
+          <a:ln w="12700">
+            <a:solidFill>
+              <a:schemeClr val="bg2"/>
+            </a:solidFill>
+            <a:prstDash val="solid"/>
+          </a:ln>
+          <a:effectLst>
+            <a:outerShdw sx="100000" sy="100000" kx="0" ky="0" algn="bl" rotWithShape="0" blurRad="76200" dist="25400" dir="5400000">
+              <a:srgbClr val="000000">
+                <a:alpha val="12000"/>
+              </a:srgbClr>
+            </a:outerShdw>
+          </a:effectLst>
+        </p:spPr>
+      </p:sp>
+      <p:sp>
+        <p:nvSpPr>
+          <p:cNvPr id="10" name="Text 8"/>
+          <p:cNvSpPr txBox="1"/>
+          <p:nvPr/>
+        </p:nvSpPr>
+        <p:spPr>
+          <a:xfrm>
+            <a:off x="777240" y="2898648"/>
+            <a:ext cx="10607040" cy="329184"/>
+          </a:xfrm>
+          <a:prstGeom prst="rect">
+            <a:avLst/>
+          </a:prstGeom>
+          <a:noFill/>
+          <a:ln/>
+        </p:spPr>
+        <p:txBody>
+          <a:bodyPr wrap="square" lIns="0" tIns="0" rIns="0" bIns="0" rtlCol="0" anchor="t"/>
+          <a:lstStyle/>
+          <a:p>
+            <a:pPr indent="0" marL="0">
+              <a:buNone/>
+            </a:pPr>
+            <a:r>
+              <a:rPr lang="en-US" sz="1400" dirty="0">
+                <a:solidFill>
+                  <a:schemeClr val="tx1"/>
+                </a:solidFill>
+              </a:rPr>
+              <a:t>[15] R. Chandramouli, "Guide to a secure enterprise network landscape," NIST SP 800-215, 2022.</a:t>
+            </a:r>
+            <a:endParaRPr lang="en-US" sz="1400" dirty="0"/>
+          </a:p>
+        </p:txBody>
+      </p:sp>
+      <p:sp>
+        <p:nvSpPr>
+          <p:cNvPr id="11" name="Text 9"/>
+          <p:cNvSpPr txBox="1"/>
+          <p:nvPr/>
+        </p:nvSpPr>
+        <p:spPr>
+          <a:xfrm>
+            <a:off x="777240" y="3236976"/>
+            <a:ext cx="10607040" cy="274320"/>
+          </a:xfrm>
+          <a:prstGeom prst="rect">
+            <a:avLst/>
+          </a:prstGeom>
+          <a:noFill/>
+          <a:ln/>
+        </p:spPr>
+        <p:txBody>
+          <a:bodyPr wrap="square" lIns="0" tIns="0" rIns="0" bIns="0" rtlCol="0" anchor="t"/>
+          <a:lstStyle/>
+          <a:p>
+            <a:pPr indent="0" marL="0">
+              <a:buNone/>
+            </a:pPr>
+            <a:r>
+              <a:rPr lang="en-US" sz="1200" u="sng" dirty="0">
+                <a:solidFill>
+                  <a:schemeClr val="accent5"/>
+                </a:solidFill>
+                <a:hlinkClick r:id="rId3" invalidUrl="" action="" tgtFrame="" tooltip="Open source" history="1" highlightClick="0" endSnd="0">
+                  <a:extLst>
+                    <a:ext uri="{A12FA001-AC4F-418D-AE19-62706E023703}">
+                      <ahyp:hlinkClr xmlns:ahyp="http://schemas.microsoft.com/office/drawing/2018/hyperlinkcolor" val="tx"/>
+                    </a:ext>
+                  </a:extLst>
+                </a:hlinkClick>
+              </a:rPr>
+              <a:t>https://doi.org/10.6028/NIST.SP.800-215</a:t>
+            </a:r>
+            <a:endParaRPr lang="en-US" sz="1200" dirty="0"/>
+          </a:p>
+        </p:txBody>
+      </p:sp>
+      <p:sp>
+        <p:nvSpPr>
+          <p:cNvPr id="12" name="card160"/>
+          <p:cNvSpPr/>
+          <p:nvPr/>
+        </p:nvSpPr>
+        <p:spPr>
+          <a:xfrm>
+            <a:off x="548640" y="3648456"/>
+            <a:ext cx="11064240" cy="713232"/>
+          </a:xfrm>
+          <a:prstGeom prst="roundRect">
+            <a:avLst>
+              <a:gd name="adj" fmla="val 10256"/>
+            </a:avLst>
+          </a:prstGeom>
+          <a:solidFill>
+            <a:schemeClr val="bg2"/>
+          </a:solidFill>
+          <a:ln w="12700">
+            <a:solidFill>
+              <a:schemeClr val="bg2"/>
+            </a:solidFill>
+            <a:prstDash val="solid"/>
+          </a:ln>
+          <a:effectLst>
+            <a:outerShdw sx="100000" sy="100000" kx="0" ky="0" algn="bl" rotWithShape="0" blurRad="76200" dist="25400" dir="5400000">
+              <a:srgbClr val="000000">
+                <a:alpha val="12000"/>
+              </a:srgbClr>
+            </a:outerShdw>
+          </a:effectLst>
+        </p:spPr>
+      </p:sp>
+      <p:sp>
+        <p:nvSpPr>
+          <p:cNvPr id="13" name="Text 11"/>
+          <p:cNvSpPr txBox="1"/>
+          <p:nvPr/>
+        </p:nvSpPr>
+        <p:spPr>
+          <a:xfrm>
+            <a:off x="777240" y="3703320"/>
+            <a:ext cx="10607040" cy="329184"/>
+          </a:xfrm>
+          <a:prstGeom prst="rect">
+            <a:avLst/>
+          </a:prstGeom>
+          <a:noFill/>
+          <a:ln/>
+        </p:spPr>
+        <p:txBody>
+          <a:bodyPr wrap="square" lIns="0" tIns="0" rIns="0" bIns="0" rtlCol="0" anchor="t"/>
+          <a:lstStyle/>
+          <a:p>
+            <a:pPr indent="0" marL="0">
+              <a:buNone/>
+            </a:pPr>
+            <a:r>
+              <a:rPr lang="en-US" sz="1400" dirty="0">
+                <a:solidFill>
+                  <a:schemeClr val="tx1"/>
+                </a:solidFill>
+              </a:rPr>
+              <a:t>[16] CISA, "Microsegmentation in zero trust, part one: Introduction and planning," 2025.</a:t>
+            </a:r>
+            <a:endParaRPr lang="en-US" sz="1400" dirty="0"/>
+          </a:p>
+        </p:txBody>
+      </p:sp>
+      <p:sp>
+        <p:nvSpPr>
+          <p:cNvPr id="14" name="Text 12"/>
+          <p:cNvSpPr txBox="1"/>
+          <p:nvPr/>
+        </p:nvSpPr>
+        <p:spPr>
+          <a:xfrm>
+            <a:off x="777240" y="4041648"/>
+            <a:ext cx="10607040" cy="274320"/>
+          </a:xfrm>
+          <a:prstGeom prst="rect">
+            <a:avLst/>
+          </a:prstGeom>
+          <a:noFill/>
+          <a:ln/>
+        </p:spPr>
+        <p:txBody>
+          <a:bodyPr wrap="square" lIns="0" tIns="0" rIns="0" bIns="0" rtlCol="0" anchor="t"/>
+          <a:lstStyle/>
+          <a:p>
+            <a:pPr indent="0" marL="0">
+              <a:buNone/>
+            </a:pPr>
+            <a:r>
+              <a:rPr lang="en-US" sz="1200" u="sng" dirty="0">
+                <a:solidFill>
+                  <a:schemeClr val="accent5"/>
+                </a:solidFill>
+                <a:hlinkClick r:id="rId4" invalidUrl="" action="" tgtFrame="" tooltip="Open source" history="1" highlightClick="0" endSnd="0">
+                  <a:extLst>
+                    <a:ext uri="{A12FA001-AC4F-418D-AE19-62706E023703}">
+                      <ahyp:hlinkClr xmlns:ahyp="http://schemas.microsoft.com/office/drawing/2018/hyperlinkcolor" val="tx"/>
+                    </a:ext>
+                  </a:extLst>
+                </a:hlinkClick>
+              </a:rPr>
+              <a:t>https://www.cisa.gov/resources-tools/resources/microsegmentation-zero-trust-part-one-introduction-and-planning</a:t>
+            </a:r>
+            <a:endParaRPr lang="en-US" sz="1200" dirty="0"/>
+          </a:p>
+        </p:txBody>
+      </p:sp>
+      <p:sp>
+        <p:nvSpPr>
+          <p:cNvPr id="15" name="card161"/>
+          <p:cNvSpPr/>
+          <p:nvPr/>
+        </p:nvSpPr>
+        <p:spPr>
+          <a:xfrm>
+            <a:off x="548640" y="4453128"/>
+            <a:ext cx="11064240" cy="713232"/>
+          </a:xfrm>
+          <a:prstGeom prst="roundRect">
+            <a:avLst>
+              <a:gd name="adj" fmla="val 10256"/>
+            </a:avLst>
+          </a:prstGeom>
+          <a:solidFill>
+            <a:schemeClr val="bg2"/>
+          </a:solidFill>
+          <a:ln w="12700">
+            <a:solidFill>
+              <a:schemeClr val="bg2"/>
+            </a:solidFill>
+            <a:prstDash val="solid"/>
+          </a:ln>
+          <a:effectLst>
+            <a:outerShdw sx="100000" sy="100000" kx="0" ky="0" algn="bl" rotWithShape="0" blurRad="76200" dist="25400" dir="5400000">
+              <a:srgbClr val="000000">
+                <a:alpha val="12000"/>
+              </a:srgbClr>
+            </a:outerShdw>
+          </a:effectLst>
+        </p:spPr>
+      </p:sp>
+      <p:sp>
+        <p:nvSpPr>
+          <p:cNvPr id="16" name="Text 14"/>
+          <p:cNvSpPr txBox="1"/>
+          <p:nvPr/>
+        </p:nvSpPr>
+        <p:spPr>
+          <a:xfrm>
+            <a:off x="777240" y="4507992"/>
+            <a:ext cx="10607040" cy="329184"/>
+          </a:xfrm>
+          <a:prstGeom prst="rect">
+            <a:avLst/>
+          </a:prstGeom>
+          <a:noFill/>
+          <a:ln/>
+        </p:spPr>
+        <p:txBody>
+          <a:bodyPr wrap="square" lIns="0" tIns="0" rIns="0" bIns="0" rtlCol="0" anchor="t"/>
+          <a:lstStyle/>
+          <a:p>
+            <a:pPr indent="0" marL="0">
+              <a:buNone/>
+            </a:pPr>
+            <a:r>
+              <a:rPr lang="en-US" sz="1400" dirty="0">
+                <a:solidFill>
+                  <a:schemeClr val="tx1"/>
+                </a:solidFill>
+              </a:rPr>
+              <a:t>[17] Y. Bartal et al., "Firmato: A novel firewall management toolkit," ACM TOCS, 2004.</a:t>
+            </a:r>
+            <a:endParaRPr lang="en-US" sz="1400" dirty="0"/>
+          </a:p>
+        </p:txBody>
+      </p:sp>
+      <p:sp>
+        <p:nvSpPr>
+          <p:cNvPr id="17" name="Text 15"/>
+          <p:cNvSpPr txBox="1"/>
+          <p:nvPr/>
+        </p:nvSpPr>
+        <p:spPr>
+          <a:xfrm>
+            <a:off x="777240" y="4846320"/>
+            <a:ext cx="10607040" cy="274320"/>
+          </a:xfrm>
+          <a:prstGeom prst="rect">
+            <a:avLst/>
+          </a:prstGeom>
+          <a:noFill/>
+          <a:ln/>
+        </p:spPr>
+        <p:txBody>
+          <a:bodyPr wrap="square" lIns="0" tIns="0" rIns="0" bIns="0" rtlCol="0" anchor="t"/>
+          <a:lstStyle/>
+          <a:p>
+            <a:pPr indent="0" marL="0">
+              <a:buNone/>
+            </a:pPr>
+            <a:r>
+              <a:rPr lang="en-US" sz="1200" u="sng" dirty="0">
+                <a:solidFill>
+                  <a:schemeClr val="accent5"/>
+                </a:solidFill>
+                <a:hlinkClick r:id="rId5" invalidUrl="" action="" tgtFrame="" tooltip="Open source" history="1" highlightClick="0" endSnd="0">
+                  <a:extLst>
+                    <a:ext uri="{A12FA001-AC4F-418D-AE19-62706E023703}">
+                      <ahyp:hlinkClr xmlns:ahyp="http://schemas.microsoft.com/office/drawing/2018/hyperlinkcolor" val="tx"/>
+                    </a:ext>
+                  </a:extLst>
+                </a:hlinkClick>
+              </a:rPr>
+              <a:t>https://doi.org/10.1145/1035582.1035583</a:t>
+            </a:r>
+            <a:endParaRPr lang="en-US" sz="1200" dirty="0"/>
+          </a:p>
+        </p:txBody>
+      </p:sp>
+      <p:sp>
+        <p:nvSpPr>
+          <p:cNvPr id="18" name="card162"/>
+          <p:cNvSpPr/>
+          <p:nvPr/>
+        </p:nvSpPr>
+        <p:spPr>
+          <a:xfrm>
+            <a:off x="548640" y="5257800"/>
+            <a:ext cx="11064240" cy="713232"/>
+          </a:xfrm>
+          <a:prstGeom prst="roundRect">
+            <a:avLst>
+              <a:gd name="adj" fmla="val 10256"/>
+            </a:avLst>
+          </a:prstGeom>
+          <a:solidFill>
+            <a:schemeClr val="bg2"/>
+          </a:solidFill>
+          <a:ln w="12700">
+            <a:solidFill>
+              <a:schemeClr val="bg2"/>
+            </a:solidFill>
+            <a:prstDash val="solid"/>
+          </a:ln>
+          <a:effectLst>
+            <a:outerShdw sx="100000" sy="100000" kx="0" ky="0" algn="bl" rotWithShape="0" blurRad="76200" dist="25400" dir="5400000">
+              <a:srgbClr val="000000">
+                <a:alpha val="12000"/>
+              </a:srgbClr>
+            </a:outerShdw>
+          </a:effectLst>
+        </p:spPr>
+      </p:sp>
+      <p:sp>
+        <p:nvSpPr>
+          <p:cNvPr id="19" name="Text 17"/>
+          <p:cNvSpPr txBox="1"/>
+          <p:nvPr/>
+        </p:nvSpPr>
+        <p:spPr>
+          <a:xfrm>
+            <a:off x="777240" y="5312664"/>
+            <a:ext cx="10607040" cy="329184"/>
+          </a:xfrm>
+          <a:prstGeom prst="rect">
+            <a:avLst/>
+          </a:prstGeom>
+          <a:noFill/>
+          <a:ln/>
+        </p:spPr>
+        <p:txBody>
+          <a:bodyPr wrap="square" lIns="0" tIns="0" rIns="0" bIns="0" rtlCol="0" anchor="t"/>
+          <a:lstStyle/>
+          <a:p>
+            <a:pPr indent="0" marL="0">
+              <a:buNone/>
+            </a:pPr>
+            <a:r>
+              <a:rPr lang="en-US" sz="1400" dirty="0">
+                <a:solidFill>
+                  <a:schemeClr val="tx1"/>
+                </a:solidFill>
+              </a:rPr>
+              <a:t>[18] J. Arkko et al., "IPv4 address blocks reserved for documentation," RFC 5737, 2010.</a:t>
+            </a:r>
+            <a:endParaRPr lang="en-US" sz="1400" dirty="0"/>
+          </a:p>
+        </p:txBody>
+      </p:sp>
+      <p:sp>
+        <p:nvSpPr>
+          <p:cNvPr id="20" name="Text 18"/>
+          <p:cNvSpPr txBox="1"/>
+          <p:nvPr/>
+        </p:nvSpPr>
+        <p:spPr>
+          <a:xfrm>
+            <a:off x="777240" y="5650992"/>
+            <a:ext cx="10607040" cy="274320"/>
+          </a:xfrm>
+          <a:prstGeom prst="rect">
+            <a:avLst/>
+          </a:prstGeom>
+          <a:noFill/>
+          <a:ln/>
+        </p:spPr>
+        <p:txBody>
+          <a:bodyPr wrap="square" lIns="0" tIns="0" rIns="0" bIns="0" rtlCol="0" anchor="t"/>
+          <a:lstStyle/>
+          <a:p>
+            <a:pPr indent="0" marL="0">
+              <a:buNone/>
+            </a:pPr>
+            <a:r>
+              <a:rPr lang="en-US" sz="1200" u="sng" dirty="0">
+                <a:solidFill>
+                  <a:schemeClr val="accent5"/>
+                </a:solidFill>
+                <a:hlinkClick r:id="rId6" invalidUrl="" action="" tgtFrame="" tooltip="Open source" history="1" highlightClick="0" endSnd="0">
+                  <a:extLst>
+                    <a:ext uri="{A12FA001-AC4F-418D-AE19-62706E023703}">
+                      <ahyp:hlinkClr xmlns:ahyp="http://schemas.microsoft.com/office/drawing/2018/hyperlinkcolor" val="tx"/>
+                    </a:ext>
+                  </a:extLst>
+                </a:hlinkClick>
+              </a:rPr>
+              <a:t>https://www.rfc-editor.org/rfc/rfc5737</a:t>
+            </a:r>
+            <a:endParaRPr lang="en-US" sz="1200" dirty="0"/>
+          </a:p>
+        </p:txBody>
+      </p:sp>
+      <p:sp>
+        <p:nvSpPr>
+          <p:cNvPr id="21" name="Text 19"/>
+          <p:cNvSpPr txBox="1"/>
+          <p:nvPr/>
+        </p:nvSpPr>
+        <p:spPr>
+          <a:xfrm>
+            <a:off x="548640" y="6172200"/>
+            <a:ext cx="10607040" cy="320040"/>
+          </a:xfrm>
+          <a:prstGeom prst="rect">
+            <a:avLst/>
+          </a:prstGeom>
+          <a:noFill/>
+          <a:ln/>
+        </p:spPr>
+        <p:txBody>
+          <a:bodyPr wrap="square" lIns="0" tIns="0" rIns="0" bIns="0" rtlCol="0" anchor="t"/>
+          <a:lstStyle/>
+          <a:p>
+            <a:pPr indent="0" marL="0">
+              <a:buNone/>
+            </a:pPr>
+            <a:r>
+              <a:rPr lang="en-US" sz="1200" i="1" dirty="0">
+                <a:solidFill>
+                  <a:schemeClr val="accent4"/>
+                </a:solidFill>
+              </a:rPr>
+              <a:t>All 18 references, as in the report (IEEE style). Links: DOI where available, otherwise publisher, repository or full-text page.</a:t>
+            </a:r>
+            <a:endParaRPr lang="en-US" sz="1200" dirty="0"/>
+          </a:p>
+        </p:txBody>
+      </p:sp>
+      <p:sp>
+        <p:nvSpPr>
+          <p:cNvPr id="25" name="Slide Number Placeholder 0"/>
+          <p:cNvSpPr>
+            <a:spLocks noGrp="1"/>
+          </p:cNvSpPr>
+          <p:nvPr>
+            <p:ph type="sldNum" sz="quarter" idx="4294967295"/>
+          </p:nvPr>
+        </p:nvSpPr>
+        <p:spPr>
+          <a:xfrm>
+            <a:off x="11338560" y="6400800"/>
+            <a:ext cx="548640" cy="274320"/>
+          </a:xfrm>
+          <a:prstGeom prst="rect">
+            <a:avLst/>
+          </a:prstGeom>
+          <a:extLst>
+            <a:ext uri="{C572A759-6A51-4108-AA02-DFA0A04FC94B}">
+              <ma14:wrappingTextBoxFlag xmlns:ma14="http://schemas.microsoft.com/office/mac/drawingml/2011/main" val="0"/>
+            </a:ext>
+          </a:extLst>
+        </p:spPr>
+        <p:txBody>
+          <a:bodyPr/>
+          <a:lstStyle>
+            <a:lvl1pPr>
+              <a:defRPr sz="1000">
+                <a:solidFill>
+                  <a:schemeClr val="accent6"/>
+                </a:solidFill>
+              </a:defRPr>
+            </a:lvl1pPr>
+          </a:lstStyle>
+          <a:p>
+            <a:pPr algn="l"/>
+            <a:fld id="{F7021451-1387-4CA6-816F-3879F97B5CBC}" type="slidenum">
+              <a:rPr b="0" lang="en-US"/>
+              <a:t>26</a:t>
             </a:fld>
             <a:endParaRPr lang="en-US"/>
           </a:p>

</xml_diff>

<commit_message>
Set team name: Ping of 5
Co-Authored-By: Claude Opus 5.5 <noreply@anthropic.com>
Claude-Session: https://claude.ai/code/session_01VZE4XfkebTWLatWpMU9HD1
</commit_message>
<xml_diff>
--- a/report/case-study-presentation.pptx
+++ b/report/case-study-presentation.pptx
@@ -132,7 +132,7 @@
   <p:extLst>
     <p:ext uri="{521415D9-36F7-43E2-AB2F-B90AF26B5E84}">
       <p14:sectionLst xmlns:p14="http://schemas.microsoft.com/office/powerpoint/2010/main">
-        <p14:section name="Introduction" id="{b5b31547-8c20-f411-4d76-25384bd6c03e}">
+        <p14:section name="Introduction" id="{b829d6b9-3800-605a-a47e-60119619995e}">
           <p14:sldIdLst>
             <p14:sldId id="256"/>
             <p14:sldId id="257"/>
@@ -140,13 +140,13 @@
             <p14:sldId id="259"/>
           </p14:sldIdLst>
         </p14:section>
-        <p14:section name="Part A: Literature" id="{aefce44b-373d-60eb-8d7f-d396bf9303a5}">
+        <p14:section name="Part A: Literature" id="{83c8915b-514e-ed61-c923-8ba442e8991e}">
           <p14:sldIdLst>
             <p14:sldId id="260"/>
             <p14:sldId id="261"/>
           </p14:sldIdLst>
         </p14:section>
-        <p14:section name="Part B: Design" id="{be3ceb07-a4b0-3511-fb16-8c94ef208096}">
+        <p14:section name="Part B: Design" id="{1d737a47-ff93-a9eb-f675-e9b9cce3e2b8}">
           <p14:sldIdLst>
             <p14:sldId id="262"/>
             <p14:sldId id="263"/>
@@ -155,7 +155,7 @@
             <p14:sldId id="266"/>
           </p14:sldIdLst>
         </p14:section>
-        <p14:section name="Part B: Results" id="{13d557aa-ab3a-3dce-7242-02cc3d0d4285}">
+        <p14:section name="Part B: Results" id="{78819f33-309c-f459-b13c-b2a0324d0bd2}">
           <p14:sldIdLst>
             <p14:sldId id="267"/>
             <p14:sldId id="268"/>
@@ -167,7 +167,7 @@
             <p14:sldId id="274"/>
           </p14:sldIdLst>
         </p14:section>
-        <p14:section name="Part C and conclusion" id="{144ff620-3f90-9280-e9ba-ba37755a6e59}">
+        <p14:section name="Part C and conclusion" id="{558aa6e0-1ac7-6812-70c3-d209bc56b5a8}">
           <p14:sldIdLst>
             <p14:sldId id="275"/>
             <p14:sldId id="276"/>
@@ -3981,7 +3981,7 @@
                   <a:schemeClr val="accent3"/>
                 </a:solidFill>
               </a:rPr>
-              <a:t>BACSE203 Computer Networks · Fall 2026 · Case Study (Topic 17)</a:t>
+              <a:t>Team Ping of 5 · BACSE203 Computer Networks · Fall 2026 · Case Study (Topic 17)</a:t>
             </a:r>
             <a:endParaRPr lang="en-US" sz="1800" dirty="0"/>
           </a:p>

</xml_diff>

<commit_message>
Final check: correct Stage 3 evidence count (8) and submission date
Co-Authored-By: Claude Opus 5.5 <noreply@anthropic.com>
Claude-Session: https://claude.ai/code/session_01VZE4XfkebTWLatWpMU9HD1
</commit_message>
<xml_diff>
--- a/report/case-study-presentation.pptx
+++ b/report/case-study-presentation.pptx
@@ -132,7 +132,7 @@
   <p:extLst>
     <p:ext uri="{521415D9-36F7-43E2-AB2F-B90AF26B5E84}">
       <p14:sectionLst xmlns:p14="http://schemas.microsoft.com/office/powerpoint/2010/main">
-        <p14:section name="Introduction" id="{b829d6b9-3800-605a-a47e-60119619995e}">
+        <p14:section name="Introduction" id="{289bcbd1-1e8f-31ba-e1ea-48127c5d43a6}">
           <p14:sldIdLst>
             <p14:sldId id="256"/>
             <p14:sldId id="257"/>
@@ -140,13 +140,13 @@
             <p14:sldId id="259"/>
           </p14:sldIdLst>
         </p14:section>
-        <p14:section name="Part A: Literature" id="{83c8915b-514e-ed61-c923-8ba442e8991e}">
+        <p14:section name="Part A: Literature" id="{d2f6a137-7f64-4cc9-f868-ec3f91105360}">
           <p14:sldIdLst>
             <p14:sldId id="260"/>
             <p14:sldId id="261"/>
           </p14:sldIdLst>
         </p14:section>
-        <p14:section name="Part B: Design" id="{1d737a47-ff93-a9eb-f675-e9b9cce3e2b8}">
+        <p14:section name="Part B: Design" id="{e6fa6653-72f5-cf2e-dd67-df202da647a0}">
           <p14:sldIdLst>
             <p14:sldId id="262"/>
             <p14:sldId id="263"/>
@@ -155,7 +155,7 @@
             <p14:sldId id="266"/>
           </p14:sldIdLst>
         </p14:section>
-        <p14:section name="Part B: Results" id="{78819f33-309c-f459-b13c-b2a0324d0bd2}">
+        <p14:section name="Part B: Results" id="{b5b4b813-06a4-2586-2d8c-5aa72ab4d49f}">
           <p14:sldIdLst>
             <p14:sldId id="267"/>
             <p14:sldId id="268"/>
@@ -167,7 +167,7 @@
             <p14:sldId id="274"/>
           </p14:sldIdLst>
         </p14:section>
-        <p14:section name="Part C and conclusion" id="{558aa6e0-1ac7-6812-70c3-d209bc56b5a8}">
+        <p14:section name="Part C and conclusion" id="{1a2e183c-99eb-b926-2edb-05915d807e88}">
           <p14:sldIdLst>
             <p14:sldId id="275"/>
             <p14:sldId id="276"/>
@@ -21376,7 +21376,7 @@
                   <a:schemeClr val="tx1"/>
                 </a:solidFill>
               </a:rPr>
-              <a:t>Screenshots for 17 tests in Stage 0, 4 in Stage 1, 14 in Stage 2, 7 in Stage 3</a:t>
+              <a:t>Screenshots for 17 tests in Stage 0, 4 in Stage 1, 14 in Stage 2, 8 in Stage 3</a:t>
             </a:r>
             <a:endParaRPr lang="en-US" sz="1600" dirty="0"/>
           </a:p>

</xml_diff>